<commit_message>
Increase content font sizes by ~1pt for readability
Bump body text, table cells, cards and references across all slides
so the content reads larger, per presenter feedback.

Co-Authored-By: Claude Opus 4.8 <noreply@anthropic.com>
Claude-Session: https://claude.ai/code/session_01AEe91STi5e9GfyhHPe5sca
</commit_message>
<xml_diff>
--- a/Brexpiprazol_Presentacion_Dra_Heydi_Trujillo.pptx
+++ b/Brexpiprazol_Presentacion_Dra_Heydi_Trujillo.pptx
@@ -3749,7 +3749,7 @@
               <a:buChar char="•"/>
             </a:pPr>
             <a:r>
-              <a:rPr lang="en-US" sz="1500" dirty="0">
+              <a:rPr lang="en-US" sz="1600" dirty="0">
                 <a:solidFill>
                   <a:srgbClr val="1B2138"/>
                 </a:solidFill>
@@ -3759,7 +3759,7 @@
               </a:rPr>
               <a:t>Absorción: buena por vía oral; sin efecto clínicamente relevante de los alimentos.</a:t>
             </a:r>
-            <a:endParaRPr lang="en-US" sz="1500" dirty="0"/>
+            <a:endParaRPr lang="en-US" sz="1600" dirty="0"/>
           </a:p>
           <a:p>
             <a:pPr marL="177800" indent="-177800">
@@ -3770,7 +3770,7 @@
               <a:buChar char="•"/>
             </a:pPr>
             <a:r>
-              <a:rPr lang="en-US" sz="1500" dirty="0">
+              <a:rPr lang="en-US" sz="1600" dirty="0">
                 <a:solidFill>
                   <a:srgbClr val="1B2138"/>
                 </a:solidFill>
@@ -3780,7 +3780,7 @@
               </a:rPr>
               <a:t>Distribución: amplia; unión a albúmina y α1-glicoproteína ácida &gt;99%.</a:t>
             </a:r>
-            <a:endParaRPr lang="en-US" sz="1500" dirty="0"/>
+            <a:endParaRPr lang="en-US" sz="1600" dirty="0"/>
           </a:p>
           <a:p>
             <a:pPr marL="177800" indent="-177800">
@@ -3791,7 +3791,7 @@
               <a:buChar char="•"/>
             </a:pPr>
             <a:r>
-              <a:rPr lang="en-US" sz="1500" dirty="0">
+              <a:rPr lang="en-US" sz="1600" dirty="0">
                 <a:solidFill>
                   <a:srgbClr val="1B2138"/>
                 </a:solidFill>
@@ -3801,7 +3801,7 @@
               </a:rPr>
               <a:t>Metabolismo: hepático por CYP3A4 y CYP2D6 → metabolito DM-3411 (sin contribución clínica relevante).</a:t>
             </a:r>
-            <a:endParaRPr lang="en-US" sz="1500" dirty="0"/>
+            <a:endParaRPr lang="en-US" sz="1600" dirty="0"/>
           </a:p>
           <a:p>
             <a:pPr marL="177800" indent="-177800">
@@ -3812,7 +3812,7 @@
               <a:buChar char="•"/>
             </a:pPr>
             <a:r>
-              <a:rPr lang="en-US" sz="1500" dirty="0">
+              <a:rPr lang="en-US" sz="1600" dirty="0">
                 <a:solidFill>
                   <a:srgbClr val="1B2138"/>
                 </a:solidFill>
@@ -3822,7 +3822,7 @@
               </a:rPr>
               <a:t>Estado estacionario en 10–12 días; semivida larga que permite dosis única diaria.</a:t>
             </a:r>
-            <a:endParaRPr lang="en-US" sz="1500" dirty="0"/>
+            <a:endParaRPr lang="en-US" sz="1600" dirty="0"/>
           </a:p>
           <a:p>
             <a:pPr marL="177800" indent="-177800">
@@ -3833,7 +3833,7 @@
               <a:buChar char="•"/>
             </a:pPr>
             <a:r>
-              <a:rPr lang="en-US" sz="1500" dirty="0">
+              <a:rPr lang="en-US" sz="1600" dirty="0">
                 <a:solidFill>
                   <a:srgbClr val="1B2138"/>
                 </a:solidFill>
@@ -3843,7 +3843,7 @@
               </a:rPr>
               <a:t>Eliminación: heces ≈46%, orina ≈25%.</a:t>
             </a:r>
-            <a:endParaRPr lang="en-US" sz="1500" dirty="0"/>
+            <a:endParaRPr lang="en-US" sz="1600" dirty="0"/>
           </a:p>
         </p:txBody>
       </p:sp>
@@ -4138,7 +4138,7 @@
               <a:buNone/>
             </a:pPr>
             <a:r>
-              <a:rPr lang="en-US" sz="1350" dirty="0">
+              <a:rPr lang="en-US" sz="1450" dirty="0">
                 <a:solidFill>
                   <a:srgbClr val="1B2138"/>
                 </a:solidFill>
@@ -4256,7 +4256,7 @@
               <a:buNone/>
             </a:pPr>
             <a:r>
-              <a:rPr lang="en-US" sz="1350" dirty="0">
+              <a:rPr lang="en-US" sz="1450" dirty="0">
                 <a:solidFill>
                   <a:srgbClr val="1B2138"/>
                 </a:solidFill>
@@ -4374,7 +4374,7 @@
               <a:buNone/>
             </a:pPr>
             <a:r>
-              <a:rPr lang="en-US" sz="1350" dirty="0">
+              <a:rPr lang="en-US" sz="1450" dirty="0">
                 <a:solidFill>
                   <a:srgbClr val="1B2138"/>
                 </a:solidFill>
@@ -4577,7 +4577,7 @@
               <a:buChar char="•"/>
             </a:pPr>
             <a:r>
-              <a:rPr lang="en-US" sz="1500" dirty="0">
+              <a:rPr lang="en-US" sz="1600" dirty="0">
                 <a:solidFill>
                   <a:srgbClr val="1B2138"/>
                 </a:solidFill>
@@ -4587,7 +4587,7 @@
               </a:rPr>
               <a:t>Ensayos pivotales de fase 3 (p. ej. VECTOR y BEACON), doble ciego y controlados con placebo, a 6 semanas.</a:t>
             </a:r>
-            <a:endParaRPr lang="en-US" sz="1500" dirty="0"/>
+            <a:endParaRPr lang="en-US" sz="1600" dirty="0"/>
           </a:p>
           <a:p>
             <a:pPr marL="177800" indent="-177800">
@@ -4598,7 +4598,7 @@
               <a:buChar char="•"/>
             </a:pPr>
             <a:r>
-              <a:rPr lang="en-US" sz="1500" dirty="0">
+              <a:rPr lang="en-US" sz="1600" dirty="0">
                 <a:solidFill>
                   <a:srgbClr val="1B2138"/>
                 </a:solidFill>
@@ -4608,7 +4608,7 @@
               </a:rPr>
               <a:t>Reducción significativa de la puntuación total PANSS con 2–4 mg/día frente a placebo.</a:t>
             </a:r>
-            <a:endParaRPr lang="en-US" sz="1500" dirty="0"/>
+            <a:endParaRPr lang="en-US" sz="1600" dirty="0"/>
           </a:p>
           <a:p>
             <a:pPr marL="177800" indent="-177800">
@@ -4619,7 +4619,7 @@
               <a:buChar char="•"/>
             </a:pPr>
             <a:r>
-              <a:rPr lang="en-US" sz="1500" dirty="0">
+              <a:rPr lang="en-US" sz="1600" dirty="0">
                 <a:solidFill>
                   <a:srgbClr val="1B2138"/>
                 </a:solidFill>
@@ -4629,7 +4629,7 @@
               </a:rPr>
               <a:t>Mejoría también en la escala CGI-S de gravedad global.</a:t>
             </a:r>
-            <a:endParaRPr lang="en-US" sz="1500" dirty="0"/>
+            <a:endParaRPr lang="en-US" sz="1600" dirty="0"/>
           </a:p>
           <a:p>
             <a:pPr marL="177800" indent="-177800">
@@ -4640,7 +4640,7 @@
               <a:buChar char="•"/>
             </a:pPr>
             <a:r>
-              <a:rPr lang="en-US" sz="1500" dirty="0">
+              <a:rPr lang="en-US" sz="1600" dirty="0">
                 <a:solidFill>
                   <a:srgbClr val="1B2138"/>
                 </a:solidFill>
@@ -4650,7 +4650,7 @@
               </a:rPr>
               <a:t>Estudios de mantenimiento: prolongación significativa del tiempo hasta la recaída.</a:t>
             </a:r>
-            <a:endParaRPr lang="en-US" sz="1500" dirty="0"/>
+            <a:endParaRPr lang="en-US" sz="1600" dirty="0"/>
           </a:p>
           <a:p>
             <a:pPr marL="177800" indent="-177800">
@@ -4661,7 +4661,7 @@
               <a:buChar char="•"/>
             </a:pPr>
             <a:r>
-              <a:rPr lang="en-US" sz="1500" dirty="0">
+              <a:rPr lang="en-US" sz="1600" dirty="0">
                 <a:solidFill>
                   <a:srgbClr val="1B2138"/>
                 </a:solidFill>
@@ -4671,7 +4671,7 @@
               </a:rPr>
               <a:t>Baja incidencia de acatisia y buen perfil de tolerabilidad a largo plazo.</a:t>
             </a:r>
-            <a:endParaRPr lang="en-US" sz="1500" dirty="0"/>
+            <a:endParaRPr lang="en-US" sz="1600" dirty="0"/>
           </a:p>
         </p:txBody>
       </p:sp>
@@ -5098,7 +5098,7 @@
               <a:buChar char="•"/>
             </a:pPr>
             <a:r>
-              <a:rPr lang="en-US" sz="1500" dirty="0">
+              <a:rPr lang="en-US" sz="1600" dirty="0">
                 <a:solidFill>
                   <a:srgbClr val="1B2138"/>
                 </a:solidFill>
@@ -5108,7 +5108,7 @@
               </a:rPr>
               <a:t>Indicado como complemento del antidepresivo cuando la respuesta es inadecuada.</a:t>
             </a:r>
-            <a:endParaRPr lang="en-US" sz="1500" dirty="0"/>
+            <a:endParaRPr lang="en-US" sz="1600" dirty="0"/>
           </a:p>
           <a:p>
             <a:pPr marL="177800" indent="-177800">
@@ -5119,7 +5119,7 @@
               <a:buChar char="•"/>
             </a:pPr>
             <a:r>
-              <a:rPr lang="en-US" sz="1500" dirty="0">
+              <a:rPr lang="en-US" sz="1600" dirty="0">
                 <a:solidFill>
                   <a:srgbClr val="1B2138"/>
                 </a:solidFill>
@@ -5129,7 +5129,7 @@
               </a:rPr>
               <a:t>Ensayos pivotales (PYXIS/POLARIS): reducción significativa de la escala MADRS frente a antidepresivo + placebo.</a:t>
             </a:r>
-            <a:endParaRPr lang="en-US" sz="1500" dirty="0"/>
+            <a:endParaRPr lang="en-US" sz="1600" dirty="0"/>
           </a:p>
           <a:p>
             <a:pPr marL="177800" indent="-177800">
@@ -5140,7 +5140,7 @@
               <a:buChar char="•"/>
             </a:pPr>
             <a:r>
-              <a:rPr lang="en-US" sz="1500" dirty="0">
+              <a:rPr lang="en-US" sz="1600" dirty="0">
                 <a:solidFill>
                   <a:srgbClr val="1B2138"/>
                 </a:solidFill>
@@ -5150,7 +5150,7 @@
               </a:rPr>
               <a:t>Dosis objetivo habitual: 2 mg/día (rango 1–3 mg).</a:t>
             </a:r>
-            <a:endParaRPr lang="en-US" sz="1500" dirty="0"/>
+            <a:endParaRPr lang="en-US" sz="1600" dirty="0"/>
           </a:p>
           <a:p>
             <a:pPr marL="177800" indent="-177800">
@@ -5161,7 +5161,7 @@
               <a:buChar char="•"/>
             </a:pPr>
             <a:r>
-              <a:rPr lang="en-US" sz="1500" dirty="0">
+              <a:rPr lang="en-US" sz="1600" dirty="0">
                 <a:solidFill>
                   <a:srgbClr val="1B2138"/>
                 </a:solidFill>
@@ -5171,7 +5171,7 @@
               </a:rPr>
               <a:t>Beneficio sobre síntomas depresivos residuales con inicio de acción en las primeras semanas.</a:t>
             </a:r>
-            <a:endParaRPr lang="en-US" sz="1500" dirty="0"/>
+            <a:endParaRPr lang="en-US" sz="1600" dirty="0"/>
           </a:p>
           <a:p>
             <a:pPr marL="177800" indent="-177800">
@@ -5182,7 +5182,7 @@
               <a:buChar char="•"/>
             </a:pPr>
             <a:r>
-              <a:rPr lang="en-US" sz="1500" dirty="0">
+              <a:rPr lang="en-US" sz="1600" dirty="0">
                 <a:solidFill>
                   <a:srgbClr val="1B2138"/>
                 </a:solidFill>
@@ -5192,7 +5192,7 @@
               </a:rPr>
               <a:t>Vigilar acatisia, aumento de peso y somnolencia como efectos más frecuentes en este contexto.</a:t>
             </a:r>
-            <a:endParaRPr lang="en-US" sz="1500" dirty="0"/>
+            <a:endParaRPr lang="en-US" sz="1600" dirty="0"/>
           </a:p>
         </p:txBody>
       </p:sp>
@@ -5583,7 +5583,7 @@
               <a:buChar char="•"/>
             </a:pPr>
             <a:r>
-              <a:rPr lang="en-US" sz="1500" dirty="0">
+              <a:rPr lang="en-US" sz="1600" dirty="0">
                 <a:solidFill>
                   <a:srgbClr val="1B2138"/>
                 </a:solidFill>
@@ -5593,7 +5593,7 @@
               </a:rPr>
               <a:t>Dos ensayos de fase 3: reducción significativa del Cohen-Mansfield Agitation Inventory (CMAI).</a:t>
             </a:r>
-            <a:endParaRPr lang="en-US" sz="1500" dirty="0"/>
+            <a:endParaRPr lang="en-US" sz="1600" dirty="0"/>
           </a:p>
           <a:p>
             <a:pPr marL="177800" indent="-177800">
@@ -5604,7 +5604,7 @@
               <a:buChar char="•"/>
             </a:pPr>
             <a:r>
-              <a:rPr lang="en-US" sz="1500" dirty="0">
+              <a:rPr lang="en-US" sz="1600" dirty="0">
                 <a:solidFill>
                   <a:srgbClr val="1B2138"/>
                 </a:solidFill>
@@ -5614,7 +5614,7 @@
               </a:rPr>
               <a:t>Dosis objetivo de 2–3 mg/día tras titulación gradual.</a:t>
             </a:r>
-            <a:endParaRPr lang="en-US" sz="1500" dirty="0"/>
+            <a:endParaRPr lang="en-US" sz="1600" dirty="0"/>
           </a:p>
           <a:p>
             <a:pPr marL="177800" indent="-177800">
@@ -5625,7 +5625,7 @@
               <a:buChar char="•"/>
             </a:pPr>
             <a:r>
-              <a:rPr lang="en-US" sz="1500" dirty="0">
+              <a:rPr lang="en-US" sz="1600" dirty="0">
                 <a:solidFill>
                   <a:srgbClr val="1B2138"/>
                 </a:solidFill>
@@ -5635,7 +5635,7 @@
               </a:rPr>
               <a:t>Aborda una necesidad no cubierta: la agitación es de las manifestaciones más angustiantes de la demencia.</a:t>
             </a:r>
-            <a:endParaRPr lang="en-US" sz="1500" dirty="0"/>
+            <a:endParaRPr lang="en-US" sz="1600" dirty="0"/>
           </a:p>
           <a:p>
             <a:pPr marL="177800" indent="-177800">
@@ -5646,7 +5646,7 @@
               <a:buChar char="•"/>
             </a:pPr>
             <a:r>
-              <a:rPr lang="en-US" sz="1500" b="1" dirty="0">
+              <a:rPr lang="en-US" sz="1600" b="1" dirty="0">
                 <a:solidFill>
                   <a:srgbClr val="9A2617"/>
                 </a:solidFill>
@@ -5656,7 +5656,7 @@
               </a:rPr>
               <a:t>Persiste la advertencia enmarcada de mayor mortalidad en ancianos con psicosis por demencia.</a:t>
             </a:r>
-            <a:endParaRPr lang="en-US" sz="1500" dirty="0"/>
+            <a:endParaRPr lang="en-US" sz="1600" dirty="0"/>
           </a:p>
         </p:txBody>
       </p:sp>
@@ -7274,7 +7274,7 @@
               <a:buChar char="•"/>
             </a:pPr>
             <a:r>
-              <a:rPr lang="en-US" sz="1500" dirty="0">
+              <a:rPr lang="en-US" sz="1600" dirty="0">
                 <a:solidFill>
                   <a:srgbClr val="1B2138"/>
                 </a:solidFill>
@@ -7284,7 +7284,7 @@
               </a:rPr>
               <a:t>Amplio abanico de concentraciones (0,25–4 mg) que facilita una titulación fina y personalizada.</a:t>
             </a:r>
-            <a:endParaRPr lang="en-US" sz="1500" dirty="0"/>
+            <a:endParaRPr lang="en-US" sz="1600" dirty="0"/>
           </a:p>
           <a:p>
             <a:pPr marL="177800" indent="-177800">
@@ -7295,7 +7295,7 @@
               <a:buChar char="•"/>
             </a:pPr>
             <a:r>
-              <a:rPr lang="en-US" sz="1500" dirty="0">
+              <a:rPr lang="en-US" sz="1600" dirty="0">
                 <a:solidFill>
                   <a:srgbClr val="1B2138"/>
                 </a:solidFill>
@@ -7305,7 +7305,7 @@
               </a:rPr>
               <a:t>Escalar despacio reduce la incidencia de acatisia e inquietud al inicio del tratamiento.</a:t>
             </a:r>
-            <a:endParaRPr lang="en-US" sz="1500" dirty="0"/>
+            <a:endParaRPr lang="en-US" sz="1600" dirty="0"/>
           </a:p>
           <a:p>
             <a:pPr marL="177800" indent="-177800">
@@ -7316,7 +7316,7 @@
               <a:buChar char="•"/>
             </a:pPr>
             <a:r>
-              <a:rPr lang="en-US" sz="1500" dirty="0">
+              <a:rPr lang="en-US" sz="1600" dirty="0">
                 <a:solidFill>
                   <a:srgbClr val="1B2138"/>
                 </a:solidFill>
@@ -7326,7 +7326,7 @@
               </a:rPr>
               <a:t>Ajuste por farmacogenética: en metabolizadores lentos del CYP2D6, reducir la dosis a la mitad.</a:t>
             </a:r>
-            <a:endParaRPr lang="en-US" sz="1500" dirty="0"/>
+            <a:endParaRPr lang="en-US" sz="1600" dirty="0"/>
           </a:p>
           <a:p>
             <a:pPr marL="177800" indent="-177800">
@@ -7337,7 +7337,7 @@
               <a:buChar char="•"/>
             </a:pPr>
             <a:r>
-              <a:rPr lang="en-US" sz="1500" dirty="0">
+              <a:rPr lang="en-US" sz="1600" dirty="0">
                 <a:solidFill>
                   <a:srgbClr val="1B2138"/>
                 </a:solidFill>
@@ -7347,7 +7347,7 @@
               </a:rPr>
               <a:t>Con inhibidores potentes de CYP3A4 o CYP2D6, reducir la dosis; con inductores de CYP3A4, aumentarla.</a:t>
             </a:r>
-            <a:endParaRPr lang="en-US" sz="1500" dirty="0"/>
+            <a:endParaRPr lang="en-US" sz="1600" dirty="0"/>
           </a:p>
           <a:p>
             <a:pPr marL="177800" indent="-177800">
@@ -7358,7 +7358,7 @@
               <a:buChar char="•"/>
             </a:pPr>
             <a:r>
-              <a:rPr lang="en-US" sz="1500" dirty="0">
+              <a:rPr lang="en-US" sz="1600" dirty="0">
                 <a:solidFill>
                   <a:srgbClr val="1B2138"/>
                 </a:solidFill>
@@ -7368,7 +7368,7 @@
               </a:rPr>
               <a:t>La semivida larga favorece la adherencia y amortigua el impacto de una toma olvidada.</a:t>
             </a:r>
-            <a:endParaRPr lang="en-US" sz="1500" dirty="0"/>
+            <a:endParaRPr lang="en-US" sz="1600" dirty="0"/>
           </a:p>
         </p:txBody>
       </p:sp>
@@ -7921,7 +7921,7 @@
               <a:buNone/>
             </a:pPr>
             <a:r>
-              <a:rPr lang="en-US" sz="1200" dirty="0">
+              <a:rPr lang="en-US" sz="1300" dirty="0">
                 <a:solidFill>
                   <a:srgbClr val="1B2138"/>
                 </a:solidFill>
@@ -8160,7 +8160,7 @@
               <a:buNone/>
             </a:pPr>
             <a:r>
-              <a:rPr lang="en-US" sz="1200" dirty="0">
+              <a:rPr lang="en-US" sz="1300" dirty="0">
                 <a:solidFill>
                   <a:srgbClr val="FFFFFF"/>
                 </a:solidFill>
@@ -8203,7 +8203,7 @@
               <a:buChar char="•"/>
             </a:pPr>
             <a:r>
-              <a:rPr lang="en-US" sz="1500" dirty="0">
+              <a:rPr lang="en-US" sz="1600" dirty="0">
                 <a:solidFill>
                   <a:srgbClr val="FFFFFF"/>
                 </a:solidFill>
@@ -8213,7 +8213,7 @@
               </a:rPr>
               <a:t>Síndrome neuroléptico maligno y discinesia tardía.</a:t>
             </a:r>
-            <a:endParaRPr lang="en-US" sz="1500" dirty="0"/>
+            <a:endParaRPr lang="en-US" sz="1600" dirty="0"/>
           </a:p>
           <a:p>
             <a:pPr marL="177800" indent="-177800">
@@ -8224,7 +8224,7 @@
               <a:buChar char="•"/>
             </a:pPr>
             <a:r>
-              <a:rPr lang="en-US" sz="1500" dirty="0">
+              <a:rPr lang="en-US" sz="1600" dirty="0">
                 <a:solidFill>
                   <a:srgbClr val="FFFFFF"/>
                 </a:solidFill>
@@ -8234,7 +8234,7 @@
               </a:rPr>
               <a:t>Alteraciones metabólicas: hiperglucemia, dislipidemia, aumento de peso.</a:t>
             </a:r>
-            <a:endParaRPr lang="en-US" sz="1500" dirty="0"/>
+            <a:endParaRPr lang="en-US" sz="1600" dirty="0"/>
           </a:p>
           <a:p>
             <a:pPr marL="177800" indent="-177800">
@@ -8245,7 +8245,7 @@
               <a:buChar char="•"/>
             </a:pPr>
             <a:r>
-              <a:rPr lang="en-US" sz="1500" dirty="0">
+              <a:rPr lang="en-US" sz="1600" dirty="0">
                 <a:solidFill>
                   <a:srgbClr val="FFFFFF"/>
                 </a:solidFill>
@@ -8255,7 +8255,7 @@
               </a:rPr>
               <a:t>Hipotensión ortostática, leucopenia/neutropenia, convulsiones y disfagia.</a:t>
             </a:r>
-            <a:endParaRPr lang="en-US" sz="1500" dirty="0"/>
+            <a:endParaRPr lang="en-US" sz="1600" dirty="0"/>
           </a:p>
           <a:p>
             <a:pPr marL="177800" indent="-177800">
@@ -8266,7 +8266,7 @@
               <a:buChar char="•"/>
             </a:pPr>
             <a:r>
-              <a:rPr lang="en-US" sz="1500" dirty="0">
+              <a:rPr lang="en-US" sz="1600" dirty="0">
                 <a:solidFill>
                   <a:srgbClr val="FFFFFF"/>
                 </a:solidFill>
@@ -8276,7 +8276,7 @@
               </a:rPr>
               <a:t>Trastornos del control de impulsos (p. ej. ludopatía) y disregulación térmica.</a:t>
             </a:r>
-            <a:endParaRPr lang="en-US" sz="1500" dirty="0"/>
+            <a:endParaRPr lang="en-US" sz="1600" dirty="0"/>
           </a:p>
           <a:p>
             <a:pPr marL="177800" indent="-177800">
@@ -8287,7 +8287,7 @@
               <a:buChar char="•"/>
             </a:pPr>
             <a:r>
-              <a:rPr lang="en-US" sz="1500" b="1" dirty="0">
+              <a:rPr lang="en-US" sz="1600" b="1" dirty="0">
                 <a:solidFill>
                   <a:srgbClr val="CADCFC"/>
                 </a:solidFill>
@@ -8297,7 +8297,7 @@
               </a:rPr>
               <a:t>Contraindicado ante hipersensibilidad conocida al brexpiprazol.</a:t>
             </a:r>
-            <a:endParaRPr lang="en-US" sz="1500" dirty="0"/>
+            <a:endParaRPr lang="en-US" sz="1600" dirty="0"/>
           </a:p>
         </p:txBody>
       </p:sp>
@@ -9308,7 +9308,7 @@
               <a:buNone/>
             </a:pPr>
             <a:r>
-              <a:rPr lang="en-US" sz="1250" dirty="0">
+              <a:rPr lang="en-US" sz="1350" dirty="0">
                 <a:solidFill>
                   <a:srgbClr val="5C6784"/>
                 </a:solidFill>
@@ -9318,7 +9318,7 @@
               </a:rPr>
               <a:t>Introducción y contexto clínico   ·   Historia y desarrollo   ·   Estructura y clasificación</a:t>
             </a:r>
-            <a:endParaRPr lang="en-US" sz="1250" dirty="0"/>
+            <a:endParaRPr lang="en-US" sz="1350" dirty="0"/>
           </a:p>
         </p:txBody>
       </p:sp>
@@ -9445,7 +9445,7 @@
               <a:buNone/>
             </a:pPr>
             <a:r>
-              <a:rPr lang="en-US" sz="1250" dirty="0">
+              <a:rPr lang="en-US" sz="1350" dirty="0">
                 <a:solidFill>
                   <a:srgbClr val="5C6784"/>
                 </a:solidFill>
@@ -9455,7 +9455,7 @@
               </a:rPr>
               <a:t>Mecanismo de acción   ·   Farmacodinamia receptorial   ·   Farmacocinética (ADME)</a:t>
             </a:r>
-            <a:endParaRPr lang="en-US" sz="1250" dirty="0"/>
+            <a:endParaRPr lang="en-US" sz="1350" dirty="0"/>
           </a:p>
         </p:txBody>
       </p:sp>
@@ -9582,7 +9582,7 @@
               <a:buNone/>
             </a:pPr>
             <a:r>
-              <a:rPr lang="en-US" sz="1250" dirty="0">
+              <a:rPr lang="en-US" sz="1350" dirty="0">
                 <a:solidFill>
                   <a:srgbClr val="5C6784"/>
                 </a:solidFill>
@@ -9592,7 +9592,7 @@
               </a:rPr>
               <a:t>Indicaciones y evidencia   ·   Posología y presentaciones   ·   Seguridad e interacciones</a:t>
             </a:r>
-            <a:endParaRPr lang="en-US" sz="1250" dirty="0"/>
+            <a:endParaRPr lang="en-US" sz="1350" dirty="0"/>
           </a:p>
         </p:txBody>
       </p:sp>
@@ -9719,7 +9719,7 @@
               <a:buNone/>
             </a:pPr>
             <a:r>
-              <a:rPr lang="en-US" sz="1250" dirty="0">
+              <a:rPr lang="en-US" sz="1350" dirty="0">
                 <a:solidFill>
                   <a:srgbClr val="5C6784"/>
                 </a:solidFill>
@@ -9729,7 +9729,7 @@
               </a:rPr>
               <a:t>Posicionamiento terapéutico   ·   Perlas clínicas   ·   Conclusiones y referencias</a:t>
             </a:r>
-            <a:endParaRPr lang="en-US" sz="1250" dirty="0"/>
+            <a:endParaRPr lang="en-US" sz="1350" dirty="0"/>
           </a:p>
         </p:txBody>
       </p:sp>
@@ -10892,7 +10892,7 @@
               <a:buNone/>
             </a:pPr>
             <a:r>
-              <a:rPr lang="en-US" sz="1300" dirty="0">
+              <a:rPr lang="en-US" sz="1400" dirty="0">
                 <a:solidFill>
                   <a:srgbClr val="1B2138"/>
                 </a:solidFill>
@@ -11150,7 +11150,7 @@
               <a:buNone/>
             </a:pPr>
             <a:r>
-              <a:rPr lang="en-US" sz="1350" dirty="0">
+              <a:rPr lang="en-US" sz="1450" dirty="0">
                 <a:solidFill>
                   <a:srgbClr val="1B2138"/>
                 </a:solidFill>
@@ -11160,7 +11160,7 @@
               </a:rPr>
               <a:t>Titular siempre de forma gradual: es la mejor estrategia frente a la acatisia inicial.</a:t>
             </a:r>
-            <a:endParaRPr lang="en-US" sz="1350" dirty="0"/>
+            <a:endParaRPr lang="en-US" sz="1450" dirty="0"/>
           </a:p>
         </p:txBody>
       </p:sp>
@@ -11248,7 +11248,7 @@
               <a:buNone/>
             </a:pPr>
             <a:r>
-              <a:rPr lang="en-US" sz="1350" dirty="0">
+              <a:rPr lang="en-US" sz="1450" dirty="0">
                 <a:solidFill>
                   <a:srgbClr val="1B2138"/>
                 </a:solidFill>
@@ -11258,7 +11258,7 @@
               </a:rPr>
               <a:t>Monitorizar peso, glucemia y lípidos al inicio y periódicamente.</a:t>
             </a:r>
-            <a:endParaRPr lang="en-US" sz="1350" dirty="0"/>
+            <a:endParaRPr lang="en-US" sz="1450" dirty="0"/>
           </a:p>
         </p:txBody>
       </p:sp>
@@ -11346,7 +11346,7 @@
               <a:buNone/>
             </a:pPr>
             <a:r>
-              <a:rPr lang="en-US" sz="1350" dirty="0">
+              <a:rPr lang="en-US" sz="1450" dirty="0">
                 <a:solidFill>
                   <a:srgbClr val="1B2138"/>
                 </a:solidFill>
@@ -11356,7 +11356,7 @@
               </a:rPr>
               <a:t>Revisar el perfil farmacogenético/interacciones (CYP2D6 y CYP3A4) antes de fijar la dosis.</a:t>
             </a:r>
-            <a:endParaRPr lang="en-US" sz="1350" dirty="0"/>
+            <a:endParaRPr lang="en-US" sz="1450" dirty="0"/>
           </a:p>
         </p:txBody>
       </p:sp>
@@ -11444,7 +11444,7 @@
               <a:buNone/>
             </a:pPr>
             <a:r>
-              <a:rPr lang="en-US" sz="1350" dirty="0">
+              <a:rPr lang="en-US" sz="1450" dirty="0">
                 <a:solidFill>
                   <a:srgbClr val="1B2138"/>
                 </a:solidFill>
@@ -11454,7 +11454,7 @@
               </a:rPr>
               <a:t>La semivida larga aporta estabilidad plasmática y tolera bien los olvidos ocasionales.</a:t>
             </a:r>
-            <a:endParaRPr lang="en-US" sz="1350" dirty="0"/>
+            <a:endParaRPr lang="en-US" sz="1450" dirty="0"/>
           </a:p>
         </p:txBody>
       </p:sp>
@@ -11542,7 +11542,7 @@
               <a:buNone/>
             </a:pPr>
             <a:r>
-              <a:rPr lang="en-US" sz="1350" dirty="0">
+              <a:rPr lang="en-US" sz="1450" dirty="0">
                 <a:solidFill>
                   <a:srgbClr val="1B2138"/>
                 </a:solidFill>
@@ -11552,7 +11552,7 @@
               </a:rPr>
               <a:t>En agitación por demencia, individualizar y reevaluar el balance beneficio-riesgo.</a:t>
             </a:r>
-            <a:endParaRPr lang="en-US" sz="1350" dirty="0"/>
+            <a:endParaRPr lang="en-US" sz="1450" dirty="0"/>
           </a:p>
         </p:txBody>
       </p:sp>
@@ -11701,7 +11701,7 @@
               <a:buChar char="•"/>
             </a:pPr>
             <a:r>
-              <a:rPr lang="en-US" sz="1500" dirty="0">
+              <a:rPr lang="en-US" sz="1600" dirty="0">
                 <a:solidFill>
                   <a:srgbClr val="CADCFC"/>
                 </a:solidFill>
@@ -11711,7 +11711,7 @@
               </a:rPr>
               <a:t>El brexpiprazol es un antipsicótico atípico de nueva generación (SDAM) que estabiliza los sistemas dopaminérgico y serotoninérgico.</a:t>
             </a:r>
-            <a:endParaRPr lang="en-US" sz="1500" dirty="0"/>
+            <a:endParaRPr lang="en-US" sz="1600" dirty="0"/>
           </a:p>
           <a:p>
             <a:pPr marL="177800" indent="-177800">
@@ -11722,7 +11722,7 @@
               <a:buChar char="•"/>
             </a:pPr>
             <a:r>
-              <a:rPr lang="en-US" sz="1500" dirty="0">
+              <a:rPr lang="en-US" sz="1600" dirty="0">
                 <a:solidFill>
                   <a:srgbClr val="CADCFC"/>
                 </a:solidFill>
@@ -11732,7 +11732,7 @@
               </a:rPr>
               <a:t>Su menor actividad intrínseca D2 se traduce en eficacia antipsicótica con menor acatisia y activación.</a:t>
             </a:r>
-            <a:endParaRPr lang="en-US" sz="1500" dirty="0"/>
+            <a:endParaRPr lang="en-US" sz="1600" dirty="0"/>
           </a:p>
           <a:p>
             <a:pPr marL="177800" indent="-177800">
@@ -11743,7 +11743,7 @@
               <a:buChar char="•"/>
             </a:pPr>
             <a:r>
-              <a:rPr lang="en-US" sz="1500" dirty="0">
+              <a:rPr lang="en-US" sz="1600" dirty="0">
                 <a:solidFill>
                   <a:srgbClr val="CADCFC"/>
                 </a:solidFill>
@@ -11753,7 +11753,7 @@
               </a:rPr>
               <a:t>Cuenta con evidencia sólida en esquizofrenia, como adyuvante en depresión mayor y, desde 2023, en la agitación por Alzheimer.</a:t>
             </a:r>
-            <a:endParaRPr lang="en-US" sz="1500" dirty="0"/>
+            <a:endParaRPr lang="en-US" sz="1600" dirty="0"/>
           </a:p>
           <a:p>
             <a:pPr marL="177800" indent="-177800">
@@ -11764,7 +11764,7 @@
               <a:buChar char="•"/>
             </a:pPr>
             <a:r>
-              <a:rPr lang="en-US" sz="1500" dirty="0">
+              <a:rPr lang="en-US" sz="1600" dirty="0">
                 <a:solidFill>
                   <a:srgbClr val="CADCFC"/>
                 </a:solidFill>
@@ -11774,7 +11774,7 @@
               </a:rPr>
               <a:t>Perfil de seguridad manejable con titulación gradual y monitorización metabólica adecuada.</a:t>
             </a:r>
-            <a:endParaRPr lang="en-US" sz="1500" dirty="0"/>
+            <a:endParaRPr lang="en-US" sz="1600" dirty="0"/>
           </a:p>
           <a:p>
             <a:pPr marL="177800" indent="-177800">
@@ -11785,7 +11785,7 @@
               <a:buChar char="•"/>
             </a:pPr>
             <a:r>
-              <a:rPr lang="en-US" sz="1500" b="1" dirty="0">
+              <a:rPr lang="en-US" sz="1600" b="1" dirty="0">
                 <a:solidFill>
                   <a:srgbClr val="FFFFFF"/>
                 </a:solidFill>
@@ -11795,7 +11795,7 @@
               </a:rPr>
               <a:t>Herramienta valiosa cuando se selecciona e individualiza correctamente al paciente.</a:t>
             </a:r>
-            <a:endParaRPr lang="en-US" sz="1500" dirty="0"/>
+            <a:endParaRPr lang="en-US" sz="1600" dirty="0"/>
           </a:p>
         </p:txBody>
       </p:sp>
@@ -11952,12 +11952,12 @@
           <a:p>
             <a:pPr indent="0" marL="0">
               <a:spcAft>
-                <a:spcPts val="1100"/>
+                <a:spcPts val="1000"/>
               </a:spcAft>
               <a:buNone/>
             </a:pPr>
             <a:r>
-              <a:rPr lang="en-US" sz="1150" dirty="0">
+              <a:rPr lang="en-US" sz="1250" dirty="0">
                 <a:solidFill>
                   <a:srgbClr val="1B2138"/>
                 </a:solidFill>
@@ -11967,17 +11967,17 @@
               </a:rPr>
               <a:t>1.  Otsuka America Pharmaceutical. Rexulti® (brexpiprazol): Información de prescripción (Prescribing Information). 2023.</a:t>
             </a:r>
-            <a:endParaRPr lang="en-US" sz="1150" dirty="0"/>
+            <a:endParaRPr lang="en-US" sz="1250" dirty="0"/>
           </a:p>
           <a:p>
             <a:pPr indent="0" marL="0">
               <a:spcAft>
-                <a:spcPts val="1100"/>
+                <a:spcPts val="1000"/>
               </a:spcAft>
               <a:buNone/>
             </a:pPr>
             <a:r>
-              <a:rPr lang="en-US" sz="1150" dirty="0">
+              <a:rPr lang="en-US" sz="1250" dirty="0">
                 <a:solidFill>
                   <a:srgbClr val="1B2138"/>
                 </a:solidFill>
@@ -11987,17 +11987,17 @@
               </a:rPr>
               <a:t>2.  Maeda K, et al. Brexpiprazole I: In vitro and in vivo characterization of a novel serotonin-dopamine activity modulator. J Pharmacol Exp Ther. 2014;350(3):589–604.</a:t>
             </a:r>
-            <a:endParaRPr lang="en-US" sz="1150" dirty="0"/>
+            <a:endParaRPr lang="en-US" sz="1250" dirty="0"/>
           </a:p>
           <a:p>
             <a:pPr indent="0" marL="0">
               <a:spcAft>
-                <a:spcPts val="1100"/>
+                <a:spcPts val="1000"/>
               </a:spcAft>
               <a:buNone/>
             </a:pPr>
             <a:r>
-              <a:rPr lang="en-US" sz="1150" dirty="0">
+              <a:rPr lang="en-US" sz="1250" dirty="0">
                 <a:solidFill>
                   <a:srgbClr val="1B2138"/>
                 </a:solidFill>
@@ -12007,17 +12007,17 @@
               </a:rPr>
               <a:t>3.  Citrome L. Brexpiprazole: a new dopamine–serotonin system stabilizer. Int J Clin Pract. 2015;69(9):978–997.</a:t>
             </a:r>
-            <a:endParaRPr lang="en-US" sz="1150" dirty="0"/>
+            <a:endParaRPr lang="en-US" sz="1250" dirty="0"/>
           </a:p>
           <a:p>
             <a:pPr indent="0" marL="0">
               <a:spcAft>
-                <a:spcPts val="1100"/>
+                <a:spcPts val="1000"/>
               </a:spcAft>
               <a:buNone/>
             </a:pPr>
             <a:r>
-              <a:rPr lang="en-US" sz="1150" dirty="0">
+              <a:rPr lang="en-US" sz="1250" dirty="0">
                 <a:solidFill>
                   <a:srgbClr val="1B2138"/>
                 </a:solidFill>
@@ -12027,17 +12027,17 @@
               </a:rPr>
               <a:t>4.  Correll CU, et al. Efficacy and safety of brexpiprazole for the treatment of schizophrenia. Am J Psychiatry. 2015;172(9):870–880.</a:t>
             </a:r>
-            <a:endParaRPr lang="en-US" sz="1150" dirty="0"/>
+            <a:endParaRPr lang="en-US" sz="1250" dirty="0"/>
           </a:p>
           <a:p>
             <a:pPr indent="0" marL="0">
               <a:spcAft>
-                <a:spcPts val="1100"/>
+                <a:spcPts val="1000"/>
               </a:spcAft>
               <a:buNone/>
             </a:pPr>
             <a:r>
-              <a:rPr lang="en-US" sz="1150" dirty="0">
+              <a:rPr lang="en-US" sz="1250" dirty="0">
                 <a:solidFill>
                   <a:srgbClr val="1B2138"/>
                 </a:solidFill>
@@ -12047,7 +12047,7 @@
               </a:rPr>
               <a:t>5.  Kane JM, et al. A multicenter, randomized, double-blind trial of brexpiprazole in schizophrenia. Schizophr Res. 2015;164(1–3):127–135.</a:t>
             </a:r>
-            <a:endParaRPr lang="en-US" sz="1150" dirty="0"/>
+            <a:endParaRPr lang="en-US" sz="1250" dirty="0"/>
           </a:p>
         </p:txBody>
       </p:sp>
@@ -12074,12 +12074,12 @@
           <a:p>
             <a:pPr indent="0" marL="0">
               <a:spcAft>
-                <a:spcPts val="1100"/>
+                <a:spcPts val="1000"/>
               </a:spcAft>
               <a:buNone/>
             </a:pPr>
             <a:r>
-              <a:rPr lang="en-US" sz="1150" dirty="0">
+              <a:rPr lang="en-US" sz="1250" dirty="0">
                 <a:solidFill>
                   <a:srgbClr val="1B2138"/>
                 </a:solidFill>
@@ -12089,17 +12089,17 @@
               </a:rPr>
               <a:t>6.  Thase ME, et al. Adjunctive brexpiprazole in major depressive disorder (PYXIS/POLARIS). J Clin Psychiatry. 2015;76(9):1224–1231.</a:t>
             </a:r>
-            <a:endParaRPr lang="en-US" sz="1150" dirty="0"/>
+            <a:endParaRPr lang="en-US" sz="1250" dirty="0"/>
           </a:p>
           <a:p>
             <a:pPr indent="0" marL="0">
               <a:spcAft>
-                <a:spcPts val="1100"/>
+                <a:spcPts val="1000"/>
               </a:spcAft>
               <a:buNone/>
             </a:pPr>
             <a:r>
-              <a:rPr lang="en-US" sz="1150" dirty="0">
+              <a:rPr lang="en-US" sz="1250" dirty="0">
                 <a:solidFill>
                   <a:srgbClr val="1B2138"/>
                 </a:solidFill>
@@ -12109,17 +12109,17 @@
               </a:rPr>
               <a:t>7.  Grossberg GT, et al. Brexpiprazole for agitation associated with Alzheimer's dementia: phase 3 trial. Am J Geriatr Psychiatry. 2020;28(4):383–400.</a:t>
             </a:r>
-            <a:endParaRPr lang="en-US" sz="1150" dirty="0"/>
+            <a:endParaRPr lang="en-US" sz="1250" dirty="0"/>
           </a:p>
           <a:p>
             <a:pPr indent="0" marL="0">
               <a:spcAft>
-                <a:spcPts val="1100"/>
+                <a:spcPts val="1000"/>
               </a:spcAft>
               <a:buNone/>
             </a:pPr>
             <a:r>
-              <a:rPr lang="en-US" sz="1150" dirty="0">
+              <a:rPr lang="en-US" sz="1250" dirty="0">
                 <a:solidFill>
                   <a:srgbClr val="1B2138"/>
                 </a:solidFill>
@@ -12129,17 +12129,17 @@
               </a:rPr>
               <a:t>8.  Lee D, et al. Brexpiprazole for the treatment of agitation in Alzheimer dementia. JAMA Neurol. 2023;80(12):1307–1316.</a:t>
             </a:r>
-            <a:endParaRPr lang="en-US" sz="1150" dirty="0"/>
+            <a:endParaRPr lang="en-US" sz="1250" dirty="0"/>
           </a:p>
           <a:p>
             <a:pPr indent="0" marL="0">
               <a:spcAft>
-                <a:spcPts val="1100"/>
+                <a:spcPts val="1000"/>
               </a:spcAft>
               <a:buNone/>
             </a:pPr>
             <a:r>
-              <a:rPr lang="en-US" sz="1150" dirty="0">
+              <a:rPr lang="en-US" sz="1250" dirty="0">
                 <a:solidFill>
                   <a:srgbClr val="1B2138"/>
                 </a:solidFill>
@@ -12149,17 +12149,17 @@
               </a:rPr>
               <a:t>9.  Stahl SM. Mechanism of action of brexpiprazole: comparison with aripiprazole. CNS Spectr. 2016;21(1):1–6.</a:t>
             </a:r>
-            <a:endParaRPr lang="en-US" sz="1150" dirty="0"/>
+            <a:endParaRPr lang="en-US" sz="1250" dirty="0"/>
           </a:p>
           <a:p>
             <a:pPr indent="0" marL="0">
               <a:spcAft>
-                <a:spcPts val="1100"/>
+                <a:spcPts val="1000"/>
               </a:spcAft>
               <a:buNone/>
             </a:pPr>
             <a:r>
-              <a:rPr lang="en-US" sz="1150" dirty="0">
+              <a:rPr lang="en-US" sz="1250" dirty="0">
                 <a:solidFill>
                   <a:srgbClr val="1B2138"/>
                 </a:solidFill>
@@ -12169,7 +12169,7 @@
               </a:rPr>
               <a:t>10.  U.S. FDA. Approval of Rexulti for agitation associated with dementia due to Alzheimer's disease. 2023.</a:t>
             </a:r>
-            <a:endParaRPr lang="en-US" sz="1150" dirty="0"/>
+            <a:endParaRPr lang="en-US" sz="1250" dirty="0"/>
           </a:p>
         </p:txBody>
       </p:sp>
@@ -12638,7 +12638,7 @@
               <a:buChar char="•"/>
             </a:pPr>
             <a:r>
-              <a:rPr lang="en-US" sz="1500" dirty="0">
+              <a:rPr lang="en-US" sz="1600" dirty="0">
                 <a:solidFill>
                   <a:srgbClr val="1B2138"/>
                 </a:solidFill>
@@ -12648,7 +12648,7 @@
               </a:rPr>
               <a:t>Comercializado como Rexulti®; genérico: brexpiprazole.</a:t>
             </a:r>
-            <a:endParaRPr lang="en-US" sz="1500" dirty="0"/>
+            <a:endParaRPr lang="en-US" sz="1600" dirty="0"/>
           </a:p>
           <a:p>
             <a:pPr marL="177800" indent="-177800">
@@ -12659,7 +12659,7 @@
               <a:buChar char="•"/>
             </a:pPr>
             <a:r>
-              <a:rPr lang="en-US" sz="1500" dirty="0">
+              <a:rPr lang="en-US" sz="1600" dirty="0">
                 <a:solidFill>
                   <a:srgbClr val="1B2138"/>
                 </a:solidFill>
@@ -12669,7 +12669,7 @@
               </a:rPr>
               <a:t>Modulador de la actividad serotonina-dopamina (SDAM): estabiliza la neurotransmisión en lugar de bloquearla por completo.</a:t>
             </a:r>
-            <a:endParaRPr lang="en-US" sz="1500" dirty="0"/>
+            <a:endParaRPr lang="en-US" sz="1600" dirty="0"/>
           </a:p>
           <a:p>
             <a:pPr marL="177800" indent="-177800">
@@ -12680,7 +12680,7 @@
               <a:buChar char="•"/>
             </a:pPr>
             <a:r>
-              <a:rPr lang="en-US" sz="1500" dirty="0">
+              <a:rPr lang="en-US" sz="1600" dirty="0">
                 <a:solidFill>
                   <a:srgbClr val="1B2138"/>
                 </a:solidFill>
@@ -12690,7 +12690,7 @@
               </a:rPr>
               <a:t>Diseñado como sucesor de segunda generación del aripiprazol, con menor actividad intrínseca dopaminérgica.</a:t>
             </a:r>
-            <a:endParaRPr lang="en-US" sz="1500" dirty="0"/>
+            <a:endParaRPr lang="en-US" sz="1600" dirty="0"/>
           </a:p>
           <a:p>
             <a:pPr marL="177800" indent="-177800">
@@ -12701,7 +12701,7 @@
               <a:buChar char="•"/>
             </a:pPr>
             <a:r>
-              <a:rPr lang="en-US" sz="1500" dirty="0">
+              <a:rPr lang="en-US" sz="1600" dirty="0">
                 <a:solidFill>
                   <a:srgbClr val="1B2138"/>
                 </a:solidFill>
@@ -12711,7 +12711,7 @@
               </a:rPr>
               <a:t>Objetivo de diseño: eficacia antipsicótica con mejor tolerabilidad — menos acatisia, activación e inquietud.</a:t>
             </a:r>
-            <a:endParaRPr lang="en-US" sz="1500" dirty="0"/>
+            <a:endParaRPr lang="en-US" sz="1600" dirty="0"/>
           </a:p>
           <a:p>
             <a:pPr marL="177800" indent="-177800">
@@ -12722,7 +12722,7 @@
               <a:buChar char="•"/>
             </a:pPr>
             <a:r>
-              <a:rPr lang="en-US" sz="1500" dirty="0">
+              <a:rPr lang="en-US" sz="1600" dirty="0">
                 <a:solidFill>
                   <a:srgbClr val="1B2138"/>
                 </a:solidFill>
@@ -12732,7 +12732,7 @@
               </a:rPr>
               <a:t>Administración oral, una vez al día, independiente de los alimentos.</a:t>
             </a:r>
-            <a:endParaRPr lang="en-US" sz="1500" dirty="0"/>
+            <a:endParaRPr lang="en-US" sz="1600" dirty="0"/>
           </a:p>
         </p:txBody>
       </p:sp>
@@ -12987,7 +12987,7 @@
               <a:buNone/>
             </a:pPr>
             <a:r>
-              <a:rPr lang="en-US" sz="1250" dirty="0">
+              <a:rPr lang="en-US" sz="1350" dirty="0">
                 <a:solidFill>
                   <a:srgbClr val="1B2138"/>
                 </a:solidFill>
@@ -12997,7 +12997,7 @@
               </a:rPr>
               <a:t>Otsuka Pharmaceutical en colaboración con H. Lundbeck A/S.</a:t>
             </a:r>
-            <a:endParaRPr lang="en-US" sz="1250" dirty="0"/>
+            <a:endParaRPr lang="en-US" sz="1350" dirty="0"/>
           </a:p>
         </p:txBody>
       </p:sp>
@@ -13092,7 +13092,7 @@
               <a:buNone/>
             </a:pPr>
             <a:r>
-              <a:rPr lang="en-US" sz="1250" dirty="0">
+              <a:rPr lang="en-US" sz="1350" dirty="0">
                 <a:solidFill>
                   <a:srgbClr val="1B2138"/>
                 </a:solidFill>
@@ -13102,7 +13102,7 @@
               </a:rPr>
               <a:t>Aprobado (10 jul 2015) para esquizofrenia y como adyuvante en depresión mayor.</a:t>
             </a:r>
-            <a:endParaRPr lang="en-US" sz="1250" dirty="0"/>
+            <a:endParaRPr lang="en-US" sz="1350" dirty="0"/>
           </a:p>
         </p:txBody>
       </p:sp>
@@ -13197,7 +13197,7 @@
               <a:buNone/>
             </a:pPr>
             <a:r>
-              <a:rPr lang="en-US" sz="1250" dirty="0">
+              <a:rPr lang="en-US" sz="1350" dirty="0">
                 <a:solidFill>
                   <a:srgbClr val="1B2138"/>
                 </a:solidFill>
@@ -13207,7 +13207,7 @@
               </a:rPr>
               <a:t>Aprobaciones posteriores en Europa, Canadá y Latinoamérica.</a:t>
             </a:r>
-            <a:endParaRPr lang="en-US" sz="1250" dirty="0"/>
+            <a:endParaRPr lang="en-US" sz="1350" dirty="0"/>
           </a:p>
         </p:txBody>
       </p:sp>
@@ -13302,7 +13302,7 @@
               <a:buNone/>
             </a:pPr>
             <a:r>
-              <a:rPr lang="en-US" sz="1250" dirty="0">
+              <a:rPr lang="en-US" sz="1350" dirty="0">
                 <a:solidFill>
                   <a:srgbClr val="1B2138"/>
                 </a:solidFill>
@@ -13312,7 +13312,7 @@
               </a:rPr>
               <a:t>Primer fármaco aprobado por la FDA para la agitación asociada a la demencia de Alzheimer.</a:t>
             </a:r>
-            <a:endParaRPr lang="en-US" sz="1250" dirty="0"/>
+            <a:endParaRPr lang="en-US" sz="1350" dirty="0"/>
           </a:p>
         </p:txBody>
       </p:sp>
@@ -13571,7 +13571,7 @@
               <a:buChar char="•"/>
             </a:pPr>
             <a:r>
-              <a:rPr lang="en-US" sz="1500" dirty="0">
+              <a:rPr lang="en-US" sz="1600" dirty="0">
                 <a:solidFill>
                   <a:srgbClr val="1B2138"/>
                 </a:solidFill>
@@ -13581,7 +13581,7 @@
               </a:rPr>
               <a:t>Nombre químico: 7-[4-[4-(1-benzotiofen-4-il)piperazin-1-il]butoxi]quinolin-2(1H)-ona.</a:t>
             </a:r>
-            <a:endParaRPr lang="en-US" sz="1500" dirty="0"/>
+            <a:endParaRPr lang="en-US" sz="1600" dirty="0"/>
           </a:p>
           <a:p>
             <a:pPr marL="177800" indent="-177800">
@@ -13592,7 +13592,7 @@
               <a:buChar char="•"/>
             </a:pPr>
             <a:r>
-              <a:rPr lang="en-US" sz="1500" b="1" dirty="0">
+              <a:rPr lang="en-US" sz="1600" b="1" dirty="0">
                 <a:solidFill>
                   <a:srgbClr val="1B2138"/>
                 </a:solidFill>
@@ -13602,7 +13602,7 @@
               </a:rPr>
               <a:t>Fórmula molecular: C25H27N3O2S.</a:t>
             </a:r>
-            <a:endParaRPr lang="en-US" sz="1500" dirty="0"/>
+            <a:endParaRPr lang="en-US" sz="1600" dirty="0"/>
           </a:p>
           <a:p>
             <a:pPr marL="177800" indent="-177800">
@@ -13613,7 +13613,7 @@
               <a:buChar char="•"/>
             </a:pPr>
             <a:r>
-              <a:rPr lang="en-US" sz="1500" dirty="0">
+              <a:rPr lang="en-US" sz="1600" dirty="0">
                 <a:solidFill>
                   <a:srgbClr val="1B2138"/>
                 </a:solidFill>
@@ -13623,7 +13623,7 @@
               </a:rPr>
               <a:t>Peso molecular: ≈ 433,6 g/mol.</a:t>
             </a:r>
-            <a:endParaRPr lang="en-US" sz="1500" dirty="0"/>
+            <a:endParaRPr lang="en-US" sz="1600" dirty="0"/>
           </a:p>
           <a:p>
             <a:pPr marL="177800" indent="-177800">
@@ -13634,7 +13634,7 @@
               <a:buChar char="•"/>
             </a:pPr>
             <a:r>
-              <a:rPr lang="en-US" sz="1500" dirty="0">
+              <a:rPr lang="en-US" sz="1600" dirty="0">
                 <a:solidFill>
                   <a:srgbClr val="1B2138"/>
                 </a:solidFill>
@@ -13644,7 +13644,7 @@
               </a:rPr>
               <a:t>Núcleo quinolinona unido, por una cadena butoxi, a una piperazina con anillo benzotiofeno.</a:t>
             </a:r>
-            <a:endParaRPr lang="en-US" sz="1500" dirty="0"/>
+            <a:endParaRPr lang="en-US" sz="1600" dirty="0"/>
           </a:p>
           <a:p>
             <a:pPr marL="177800" indent="-177800">
@@ -13655,7 +13655,7 @@
               <a:buChar char="•"/>
             </a:pPr>
             <a:r>
-              <a:rPr lang="en-US" sz="1500" dirty="0">
+              <a:rPr lang="en-US" sz="1600" dirty="0">
                 <a:solidFill>
                   <a:srgbClr val="1B2138"/>
                 </a:solidFill>
@@ -13665,7 +13665,7 @@
               </a:rPr>
               <a:t>El benzotiofeno y la piperazina confieren alta afinidad por receptores D2 y 5-HT.</a:t>
             </a:r>
-            <a:endParaRPr lang="en-US" sz="1500" dirty="0"/>
+            <a:endParaRPr lang="en-US" sz="1600" dirty="0"/>
           </a:p>
           <a:p>
             <a:pPr marL="177800" indent="-177800">
@@ -13676,7 +13676,7 @@
               <a:buChar char="•"/>
             </a:pPr>
             <a:r>
-              <a:rPr lang="en-US" sz="1500" dirty="0">
+              <a:rPr lang="en-US" sz="1600" dirty="0">
                 <a:solidFill>
                   <a:srgbClr val="1B2138"/>
                 </a:solidFill>
@@ -13686,7 +13686,7 @@
               </a:rPr>
               <a:t>Polvo blanco a blanquecino, prácticamente insoluble en agua.</a:t>
             </a:r>
-            <a:endParaRPr lang="en-US" sz="1500" dirty="0"/>
+            <a:endParaRPr lang="en-US" sz="1600" dirty="0"/>
           </a:p>
         </p:txBody>
       </p:sp>
@@ -13905,7 +13905,7 @@
               <a:buNone/>
             </a:pPr>
             <a:r>
-              <a:rPr lang="en-US" sz="1500" b="1" dirty="0">
+              <a:rPr lang="en-US" sz="1600" b="1" dirty="0">
                 <a:solidFill>
                   <a:srgbClr val="1E2761"/>
                 </a:solidFill>
@@ -13915,14 +13915,14 @@
               </a:rPr>
               <a:t>Grupo</a:t>
             </a:r>
-            <a:endParaRPr lang="en-US" sz="1500" dirty="0"/>
+            <a:endParaRPr lang="en-US" sz="1600" dirty="0"/>
           </a:p>
           <a:p>
             <a:pPr algn="l" indent="0" marL="0">
               <a:buNone/>
             </a:pPr>
             <a:r>
-              <a:rPr lang="en-US" sz="1350" dirty="0">
+              <a:rPr lang="en-US" sz="1450" dirty="0">
                 <a:solidFill>
                   <a:srgbClr val="1B2138"/>
                 </a:solidFill>
@@ -13932,7 +13932,7 @@
               </a:rPr>
               <a:t>Antipsicótico atípico (segunda generación).</a:t>
             </a:r>
-            <a:endParaRPr lang="en-US" sz="1500" dirty="0"/>
+            <a:endParaRPr lang="en-US" sz="1600" dirty="0"/>
           </a:p>
         </p:txBody>
       </p:sp>
@@ -13991,7 +13991,7 @@
               <a:buNone/>
             </a:pPr>
             <a:r>
-              <a:rPr lang="en-US" sz="1500" b="1" dirty="0">
+              <a:rPr lang="en-US" sz="1600" b="1" dirty="0">
                 <a:solidFill>
                   <a:srgbClr val="1E2761"/>
                 </a:solidFill>
@@ -14001,14 +14001,14 @@
               </a:rPr>
               <a:t>Subclase funcional</a:t>
             </a:r>
-            <a:endParaRPr lang="en-US" sz="1500" dirty="0"/>
+            <a:endParaRPr lang="en-US" sz="1600" dirty="0"/>
           </a:p>
           <a:p>
             <a:pPr algn="l" indent="0" marL="0">
               <a:buNone/>
             </a:pPr>
             <a:r>
-              <a:rPr lang="en-US" sz="1350" dirty="0">
+              <a:rPr lang="en-US" sz="1450" dirty="0">
                 <a:solidFill>
                   <a:srgbClr val="1B2138"/>
                 </a:solidFill>
@@ -14018,7 +14018,7 @@
               </a:rPr>
               <a:t>Modulador de actividad serotonina-dopamina (SDAM).</a:t>
             </a:r>
-            <a:endParaRPr lang="en-US" sz="1500" dirty="0"/>
+            <a:endParaRPr lang="en-US" sz="1600" dirty="0"/>
           </a:p>
         </p:txBody>
       </p:sp>
@@ -14077,7 +14077,7 @@
               <a:buNone/>
             </a:pPr>
             <a:r>
-              <a:rPr lang="en-US" sz="1500" b="1" dirty="0">
+              <a:rPr lang="en-US" sz="1600" b="1" dirty="0">
                 <a:solidFill>
                   <a:srgbClr val="1E2761"/>
                 </a:solidFill>
@@ -14087,14 +14087,14 @@
               </a:rPr>
               <a:t>Clase ATC</a:t>
             </a:r>
-            <a:endParaRPr lang="en-US" sz="1500" dirty="0"/>
+            <a:endParaRPr lang="en-US" sz="1600" dirty="0"/>
           </a:p>
           <a:p>
             <a:pPr algn="l" indent="0" marL="0">
               <a:buNone/>
             </a:pPr>
             <a:r>
-              <a:rPr lang="en-US" sz="1350" dirty="0">
+              <a:rPr lang="en-US" sz="1450" dirty="0">
                 <a:solidFill>
                   <a:srgbClr val="1B2138"/>
                 </a:solidFill>
@@ -14104,7 +14104,7 @@
               </a:rPr>
               <a:t>N05AX16 — Otros antipsicóticos.</a:t>
             </a:r>
-            <a:endParaRPr lang="en-US" sz="1500" dirty="0"/>
+            <a:endParaRPr lang="en-US" sz="1600" dirty="0"/>
           </a:p>
         </p:txBody>
       </p:sp>
@@ -14163,7 +14163,7 @@
               <a:buNone/>
             </a:pPr>
             <a:r>
-              <a:rPr lang="en-US" sz="1500" b="1" dirty="0">
+              <a:rPr lang="en-US" sz="1600" b="1" dirty="0">
                 <a:solidFill>
                   <a:srgbClr val="1E2761"/>
                 </a:solidFill>
@@ -14173,14 +14173,14 @@
               </a:rPr>
               <a:t>Mecanismo distintivo</a:t>
             </a:r>
-            <a:endParaRPr lang="en-US" sz="1500" dirty="0"/>
+            <a:endParaRPr lang="en-US" sz="1600" dirty="0"/>
           </a:p>
           <a:p>
             <a:pPr algn="l" indent="0" marL="0">
               <a:buNone/>
             </a:pPr>
             <a:r>
-              <a:rPr lang="en-US" sz="1350" dirty="0">
+              <a:rPr lang="en-US" sz="1450" dirty="0">
                 <a:solidFill>
                   <a:srgbClr val="1B2138"/>
                 </a:solidFill>
@@ -14190,7 +14190,7 @@
               </a:rPr>
               <a:t>Agonismo parcial D2/D3/5-HT1A + antagonismo 5-HT2A.</a:t>
             </a:r>
-            <a:endParaRPr lang="en-US" sz="1500" dirty="0"/>
+            <a:endParaRPr lang="en-US" sz="1600" dirty="0"/>
           </a:p>
         </p:txBody>
       </p:sp>
@@ -14410,7 +14410,7 @@
               <a:buChar char="•"/>
             </a:pPr>
             <a:r>
-              <a:rPr lang="en-US" sz="1500" dirty="0">
+              <a:rPr lang="en-US" sz="1600" dirty="0">
                 <a:solidFill>
                   <a:srgbClr val="1B2138"/>
                 </a:solidFill>
@@ -14420,7 +14420,7 @@
               </a:rPr>
               <a:t>Agonista parcial de alta afinidad en receptores D2 y D3: normaliza el tono dopaminérgico — reduce la hiperactividad mesolímbica sin bloqueo excesivo.</a:t>
             </a:r>
-            <a:endParaRPr lang="en-US" sz="1500" dirty="0"/>
+            <a:endParaRPr lang="en-US" sz="1600" dirty="0"/>
           </a:p>
           <a:p>
             <a:pPr marL="177800" indent="-177800">
@@ -14431,7 +14431,7 @@
               <a:buChar char="•"/>
             </a:pPr>
             <a:r>
-              <a:rPr lang="en-US" sz="1500" dirty="0">
+              <a:rPr lang="en-US" sz="1600" dirty="0">
                 <a:solidFill>
                   <a:srgbClr val="1B2138"/>
                 </a:solidFill>
@@ -14441,7 +14441,7 @@
               </a:rPr>
               <a:t>Agonista parcial 5-HT1A: efecto ansiolítico, antidepresivo y procognitivo; favorece la tolerabilidad motora.</a:t>
             </a:r>
-            <a:endParaRPr lang="en-US" sz="1500" dirty="0"/>
+            <a:endParaRPr lang="en-US" sz="1600" dirty="0"/>
           </a:p>
           <a:p>
             <a:pPr marL="177800" indent="-177800">
@@ -14452,7 +14452,7 @@
               <a:buChar char="•"/>
             </a:pPr>
             <a:r>
-              <a:rPr lang="en-US" sz="1500" dirty="0">
+              <a:rPr lang="en-US" sz="1600" dirty="0">
                 <a:solidFill>
                   <a:srgbClr val="1B2138"/>
                 </a:solidFill>
@@ -14462,7 +14462,7 @@
               </a:rPr>
               <a:t>Antagonista potente 5-HT2A: mejora síntomas negativos y reduce el riesgo de síntomas extrapiramidales.</a:t>
             </a:r>
-            <a:endParaRPr lang="en-US" sz="1500" dirty="0"/>
+            <a:endParaRPr lang="en-US" sz="1600" dirty="0"/>
           </a:p>
           <a:p>
             <a:pPr marL="177800" indent="-177800">
@@ -14473,7 +14473,7 @@
               <a:buChar char="•"/>
             </a:pPr>
             <a:r>
-              <a:rPr lang="en-US" sz="1500" dirty="0">
+              <a:rPr lang="en-US" sz="1600" dirty="0">
                 <a:solidFill>
                   <a:srgbClr val="1B2138"/>
                 </a:solidFill>
@@ -14483,7 +14483,7 @@
               </a:rPr>
               <a:t>Antagonismo α1B y α2C adrenérgico: modula ánimo y respuesta de estrés.</a:t>
             </a:r>
-            <a:endParaRPr lang="en-US" sz="1500" dirty="0"/>
+            <a:endParaRPr lang="en-US" sz="1600" dirty="0"/>
           </a:p>
           <a:p>
             <a:pPr marL="177800" indent="-177800">
@@ -14494,7 +14494,7 @@
               <a:buChar char="•"/>
             </a:pPr>
             <a:r>
-              <a:rPr lang="en-US" sz="1500" b="1" dirty="0">
+              <a:rPr lang="en-US" sz="1600" b="1" dirty="0">
                 <a:solidFill>
                   <a:srgbClr val="1E2761"/>
                 </a:solidFill>
@@ -14504,7 +14504,7 @@
               </a:rPr>
               <a:t>Menor actividad intrínseca en D2 que el aripiprazol → menos activación, acatisia e inquietud.</a:t>
             </a:r>
-            <a:endParaRPr lang="en-US" sz="1500" dirty="0"/>
+            <a:endParaRPr lang="en-US" sz="1600" dirty="0"/>
           </a:p>
         </p:txBody>
       </p:sp>
@@ -14772,7 +14772,7 @@
               <a:buNone/>
             </a:pPr>
             <a:r>
-              <a:rPr lang="en-US" sz="1200" dirty="0">
+              <a:rPr lang="en-US" sz="1300" dirty="0">
                 <a:solidFill>
                   <a:srgbClr val="CADCFC"/>
                 </a:solidFill>
@@ -14897,7 +14897,7 @@
               <a:buNone/>
             </a:pPr>
             <a:r>
-              <a:rPr lang="en-US" sz="1200" dirty="0">
+              <a:rPr lang="en-US" sz="1300" dirty="0">
                 <a:solidFill>
                   <a:srgbClr val="CADCFC"/>
                 </a:solidFill>
@@ -15022,7 +15022,7 @@
               <a:buNone/>
             </a:pPr>
             <a:r>
-              <a:rPr lang="en-US" sz="1200" dirty="0">
+              <a:rPr lang="en-US" sz="1300" dirty="0">
                 <a:solidFill>
                   <a:srgbClr val="CADCFC"/>
                 </a:solidFill>

</xml_diff>

<commit_message>
Add conduct-disorder slide and swap two new images into repeats
- New slide 14: brexpiprazole in conduct/behavioral disorders (SDAM
  rationale, approved vs off-label use, clinical caution); renumber
  subsequent badges (25 slides total).
- Replace one repeated molecule image (pharmacokinetics slide) and one
  repeated brain image (schizophrenia slide) with the two new uploads
  to reduce visual repetition.

Co-Authored-By: Claude Opus 4.8 <noreply@anthropic.com>
Claude-Session: https://claude.ai/code/session_01AEe91STi5e9GfyhHPe5sca
</commit_message>
<xml_diff>
--- a/Brexpiprazol_Presentacion_Dra_Heydi_Trujillo.pptx
+++ b/Brexpiprazol_Presentacion_Dra_Heydi_Trujillo.pptx
@@ -29,9 +29,10 @@
     <p:sldId id="277" r:id="rId23"/>
     <p:sldId id="278" r:id="rId24"/>
     <p:sldId id="279" r:id="rId25"/>
+    <p:sldId id="280" r:id="rId26"/>
   </p:sldIdLst>
   <p:notesMasterIdLst>
-    <p:notesMasterId r:id="rId26"/>
+    <p:notesMasterId r:id="rId27"/>
   </p:notesMasterIdLst>
   <p:sldSz cx="12192000" cy="6858000"/>
   <p:notesSz cx="6858000" cy="12192000"/>
@@ -1053,7 +1054,7 @@
           <a:p>
             <a:r>
               <a:rPr lang="en-US" dirty="0"/>
-              <a:t>Titulación siempre gradual. Presentaciones 0,25–4 mg. Dosis única diaria. Ajuste en insuficiencia hepática/renal moderada-grave.</a:t>
+              <a:t>Trastornos de la conducta: agresividad/impulsividad. Racional SDAM. Solo la agitación en Alzheimer está aprobada; el resto es off-label con evidencia limitada. No aprobado en conducta infanto-juvenil. Complemento de intervenciones psicosociales.</a:t>
             </a:r>
             <a:endParaRPr lang="en-US" dirty="0"/>
           </a:p>
@@ -1141,7 +1142,7 @@
           <a:p>
             <a:r>
               <a:rPr lang="en-US" dirty="0"/>
-              <a:t>Individualizar: rango de dosis amplio, titulación lenta, ajuste por CYP2D6/3A4. La t½ larga da margen frente a olvidos.</a:t>
+              <a:t>Titulación siempre gradual. Presentaciones 0,25–4 mg. Dosis única diaria. Ajuste en insuficiencia hepática/renal moderada-grave.</a:t>
             </a:r>
             <a:endParaRPr lang="en-US" dirty="0"/>
           </a:p>
@@ -1229,7 +1230,7 @@
           <a:p>
             <a:r>
               <a:rPr lang="en-US" dirty="0"/>
-              <a:t>Más frecuentes: peso, acatisia (menor que aripiprazol), somnolencia, cefalea. QTc mínimo, prolactina discreta. Menos activación que aripiprazol.</a:t>
+              <a:t>Individualizar: rango de dosis amplio, titulación lenta, ajuste por CYP2D6/3A4. La t½ larga da margen frente a olvidos.</a:t>
             </a:r>
             <a:endParaRPr lang="en-US" dirty="0"/>
           </a:p>
@@ -1317,7 +1318,7 @@
           <a:p>
             <a:r>
               <a:rPr lang="en-US" dirty="0"/>
-              <a:t>Boxed warning: mortalidad en demencia y suicidalidad en jóvenes. Además SNM, discinesia tardía, metabólico, ortostatismo, impulsividad. Contraindicación: hipersensibilidad.</a:t>
+              <a:t>Más frecuentes: peso, acatisia (menor que aripiprazol), somnolencia, cefalea. QTc mínimo, prolactina discreta. Menos activación que aripiprazol.</a:t>
             </a:r>
             <a:endParaRPr lang="en-US" dirty="0"/>
           </a:p>
@@ -1405,7 +1406,7 @@
           <a:p>
             <a:r>
               <a:rPr lang="en-US" dirty="0"/>
-              <a:t>Interacciones dominadas por CYP3A4/2D6: reducir con inhibidores y en metabolizadores lentos; aumentar con inductores. Ajustar en hepatopatía/nefropatía y ancianos.</a:t>
+              <a:t>Boxed warning: mortalidad en demencia y suicidalidad en jóvenes. Además SNM, discinesia tardía, metabólico, ortostatismo, impulsividad. Contraindicación: hipersensibilidad.</a:t>
             </a:r>
             <a:endParaRPr lang="en-US" dirty="0"/>
           </a:p>
@@ -1581,7 +1582,7 @@
           <a:p>
             <a:r>
               <a:rPr lang="en-US" dirty="0"/>
-              <a:t>Frente a aripiprazol: menor actividad intrínseca D2, menos acatisia/activación, mayor antagonismo 5-HT2A; a cambio, algo más de somnolencia/peso. Elegir según el paciente.</a:t>
+              <a:t>Interacciones dominadas por CYP3A4/2D6: reducir con inhibidores y en metabolizadores lentos; aumentar con inductores. Ajustar en hepatopatía/nefropatía y ancianos.</a:t>
             </a:r>
             <a:endParaRPr lang="en-US" dirty="0"/>
           </a:p>
@@ -1669,7 +1670,7 @@
           <a:p>
             <a:r>
               <a:rPr lang="en-US" dirty="0"/>
-              <a:t>Cinco perlas: titulación gradual, monitorización metabólica, interacciones CYP, ventaja de t½ larga, individualización en demencia.</a:t>
+              <a:t>Frente a aripiprazol: menor actividad intrínseca D2, menos acatisia/activación, mayor antagonismo 5-HT2A; a cambio, algo más de somnolencia/peso. Elegir según el paciente.</a:t>
             </a:r>
             <a:endParaRPr lang="en-US" dirty="0"/>
           </a:p>
@@ -1757,7 +1758,7 @@
           <a:p>
             <a:r>
               <a:rPr lang="en-US" dirty="0"/>
-              <a:t>Síntesis: SDAM eficaz y con tolerabilidad motora favorable, tres indicaciones con evidencia, seguridad manejable. Su valor depende de la individualización.</a:t>
+              <a:t>Cinco perlas: titulación gradual, monitorización metabólica, interacciones CYP, ventaja de t½ larga, individualización en demencia.</a:t>
             </a:r>
             <a:endParaRPr lang="en-US" dirty="0"/>
           </a:p>
@@ -1845,7 +1846,7 @@
           <a:p>
             <a:r>
               <a:rPr lang="en-US" dirty="0"/>
-              <a:t>Fuentes primarias: ficha técnica de Rexulti, estudios de Maeda/Citrome/Correll/Thase/Grossberg/Lee y revisiones de Stahl. Referencias formativas.</a:t>
+              <a:t>Síntesis: SDAM eficaz y con tolerabilidad motora favorable, tres indicaciones con evidencia, seguridad manejable. Su valor depende de la individualización.</a:t>
             </a:r>
             <a:endParaRPr lang="en-US" dirty="0"/>
           </a:p>
@@ -1933,7 +1934,7 @@
           <a:p>
             <a:r>
               <a:rPr lang="en-US" dirty="0"/>
-              <a:t>Cierre y agradecimiento. Abrir espacio a preguntas y discusión de casos.</a:t>
+              <a:t>Fuentes primarias: ficha técnica de Rexulti, estudios de Maeda/Citrome/Correll/Thase/Grossberg/Lee y revisiones de Stahl. Referencias formativas.</a:t>
             </a:r>
             <a:endParaRPr lang="en-US" dirty="0"/>
           </a:p>
@@ -1957,6 +1958,94 @@
             <a:fld id="{F7021451-1387-4CA6-816F-3879F97B5CBC}" type="slidenum">
               <a:rPr lang="en-US"/>
               <a:t>24</a:t>
+            </a:fld>
+            <a:endParaRPr lang="en-US"/>
+          </a:p>
+        </p:txBody>
+      </p:sp>
+    </p:spTree>
+    <p:extLst>
+      <p:ext uri="{BB962C8B-B14F-4D97-AF65-F5344CB8AC3E}">
+        <p14:creationId xmlns:p14="http://schemas.microsoft.com/office/powerpoint/2010/main" val="1024086991"/>
+      </p:ext>
+    </p:extLst>
+  </p:cSld>
+  <p:clrMapOvr>
+    <a:masterClrMapping/>
+  </p:clrMapOvr>
+</p:notes>
+</file>
+
+<file path=ppt/notesSlides/notesSlide25.xml><?xml version="1.0" encoding="utf-8"?>
+<p:notes xmlns:a="http://schemas.openxmlformats.org/drawingml/2006/main" xmlns:r="http://schemas.openxmlformats.org/officeDocument/2006/relationships" xmlns:p="http://schemas.openxmlformats.org/presentationml/2006/main">
+  <p:cSld>
+    <p:spTree>
+      <p:nvGrpSpPr>
+        <p:cNvPr id="1" name=""/>
+        <p:cNvGrpSpPr/>
+        <p:nvPr/>
+      </p:nvGrpSpPr>
+      <p:grpSpPr>
+        <a:xfrm>
+          <a:off x="0" y="0"/>
+          <a:ext cx="0" cy="0"/>
+          <a:chOff x="0" y="0"/>
+          <a:chExt cx="0" cy="0"/>
+        </a:xfrm>
+      </p:grpSpPr>
+      <p:sp>
+        <p:nvSpPr>
+          <p:cNvPr id="2" name="Slide Image Placeholder 1"/>
+          <p:cNvSpPr>
+            <a:spLocks noGrp="1" noRot="1" noChangeAspect="1"/>
+          </p:cNvSpPr>
+          <p:nvPr>
+            <p:ph type="sldImg"/>
+          </p:nvPr>
+        </p:nvSpPr>
+        <p:spPr/>
+      </p:sp>
+      <p:sp>
+        <p:nvSpPr>
+          <p:cNvPr id="3" name="Notes Placeholder 2"/>
+          <p:cNvSpPr>
+            <a:spLocks noGrp="1"/>
+          </p:cNvSpPr>
+          <p:nvPr>
+            <p:ph type="body" idx="1"/>
+          </p:nvPr>
+        </p:nvSpPr>
+        <p:spPr/>
+        <p:txBody>
+          <a:bodyPr/>
+          <a:lstStyle/>
+          <a:p>
+            <a:r>
+              <a:rPr lang="en-US" dirty="0"/>
+              <a:t>Cierre y agradecimiento. Abrir espacio a preguntas y discusión de casos.</a:t>
+            </a:r>
+            <a:endParaRPr lang="en-US" dirty="0"/>
+          </a:p>
+        </p:txBody>
+      </p:sp>
+      <p:sp>
+        <p:nvSpPr>
+          <p:cNvPr id="4" name="Slide Number Placeholder 3"/>
+          <p:cNvSpPr>
+            <a:spLocks noGrp="1"/>
+          </p:cNvSpPr>
+          <p:nvPr>
+            <p:ph type="sldNum" sz="quarter" idx="10"/>
+          </p:nvPr>
+        </p:nvSpPr>
+        <p:spPr/>
+        <p:txBody>
+          <a:bodyPr/>
+          <a:lstStyle/>
+          <a:p>
+            <a:fld id="{F7021451-1387-4CA6-816F-3879F97B5CBC}" type="slidenum">
+              <a:rPr lang="en-US"/>
+              <a:t>25</a:t>
             </a:fld>
             <a:endParaRPr lang="en-US"/>
           </a:p>
@@ -3692,7 +3781,7 @@
       </p:sp>
       <p:pic>
         <p:nvPicPr>
-          <p:cNvPr id="17" name="Image 0" descr="/root/.claude/uploads/66fba22f-583e-557b-9ab9-bf088b6d1210/5b8ace72-1000206753.jpg">    </p:cNvPr>
+          <p:cNvPr id="17" name="Image 0" descr="/root/.claude/uploads/66fba22f-583e-557b-9ab9-bf088b6d1210/03076ebf-1000206863.jpg">    </p:cNvPr>
           <p:cNvPicPr>
             <a:picLocks noChangeAspect="1"/>
           </p:cNvPicPr>
@@ -4520,7 +4609,7 @@
       </p:sp>
       <p:pic>
         <p:nvPicPr>
-          <p:cNvPr id="5" name="Image 0" descr="/root/.claude/uploads/66fba22f-583e-557b-9ab9-bf088b6d1210/2084e854-1000206754.jpg">    </p:cNvPr>
+          <p:cNvPr id="5" name="Image 0" descr="/root/.claude/uploads/66fba22f-583e-557b-9ab9-bf088b6d1210/90f42778-1000206864.jpg">    </p:cNvPr>
           <p:cNvPicPr>
             <a:picLocks noChangeAspect="1"/>
           </p:cNvPicPr>
@@ -5940,7 +6029,7 @@
                 <a:ea typeface="Cambria" pitchFamily="34" charset="-122"/>
                 <a:cs typeface="Cambria" pitchFamily="34" charset="-120"/>
               </a:rPr>
-              <a:t>Posología y administración</a:t>
+              <a:t>Brexpiprazol y los trastornos de la conducta</a:t>
             </a:r>
             <a:endParaRPr lang="en-US" sz="3000" dirty="0"/>
           </a:p>
@@ -5948,7 +6037,7 @@
       </p:sp>
       <p:pic>
         <p:nvPicPr>
-          <p:cNvPr id="5" name="Image 0" descr="/root/.claude/uploads/66fba22f-583e-557b-9ab9-bf088b6d1210/ec29a529-1000206767.jpg">    </p:cNvPr>
+          <p:cNvPr id="5" name="Image 0" descr="/root/.claude/uploads/66fba22f-583e-557b-9ab9-bf088b6d1210/90f42778-1000206864.jpg">    </p:cNvPr>
           <p:cNvPicPr>
             <a:picLocks noChangeAspect="1"/>
           </p:cNvPicPr>
@@ -5961,8 +6050,8 @@
         </p:blipFill>
         <p:spPr>
           <a:xfrm>
-            <a:off x="7772400" y="1463040"/>
-            <a:ext cx="3931920" cy="3749040"/>
+            <a:off x="7818120" y="1463040"/>
+            <a:ext cx="3886200" cy="3840480"/>
           </a:xfrm>
           <a:prstGeom prst="rect">
             <a:avLst/>
@@ -5978,20 +6067,149 @@
       </p:pic>
       <p:sp>
         <p:nvSpPr>
-          <p:cNvPr id="6" name="Shape 3"/>
-          <p:cNvSpPr/>
-          <p:nvPr/>
-        </p:nvSpPr>
-        <p:spPr>
-          <a:xfrm>
-            <a:off x="548640" y="1554480"/>
-            <a:ext cx="2331720" cy="621792"/>
-          </a:xfrm>
-          <a:prstGeom prst="rect">
-            <a:avLst/>
+          <p:cNvPr id="6" name="Text 3"/>
+          <p:cNvSpPr/>
+          <p:nvPr/>
+        </p:nvSpPr>
+        <p:spPr>
+          <a:xfrm>
+            <a:off x="548640" y="1508760"/>
+            <a:ext cx="7086600" cy="3794760"/>
+          </a:xfrm>
+          <a:prstGeom prst="rect">
+            <a:avLst/>
+          </a:prstGeom>
+          <a:noFill/>
+          <a:ln/>
+        </p:spPr>
+        <p:txBody>
+          <a:bodyPr wrap="square" rtlCol="0" anchor="t"/>
+          <a:lstStyle/>
+          <a:p>
+            <a:pPr marL="177800" indent="-177800">
+              <a:spcAft>
+                <a:spcPts val="800"/>
+              </a:spcAft>
+              <a:buSzPct val="100000"/>
+              <a:buChar char="•"/>
+            </a:pPr>
+            <a:r>
+              <a:rPr lang="en-US" sz="1600" dirty="0">
+                <a:solidFill>
+                  <a:srgbClr val="1B2138"/>
+                </a:solidFill>
+                <a:latin typeface="Calibri" pitchFamily="34" charset="0"/>
+                <a:ea typeface="Calibri" pitchFamily="34" charset="-122"/>
+                <a:cs typeface="Calibri" pitchFamily="34" charset="-120"/>
+              </a:rPr>
+              <a:t>Los trastornos de la conducta agrupan patrones persistentes de agresividad, impulsividad y transgresión de normas sociales.</a:t>
+            </a:r>
+            <a:endParaRPr lang="en-US" sz="1600" dirty="0"/>
+          </a:p>
+          <a:p>
+            <a:pPr marL="177800" indent="-177800">
+              <a:spcAft>
+                <a:spcPts val="800"/>
+              </a:spcAft>
+              <a:buSzPct val="100000"/>
+              <a:buChar char="•"/>
+            </a:pPr>
+            <a:r>
+              <a:rPr lang="en-US" sz="1600" dirty="0">
+                <a:solidFill>
+                  <a:srgbClr val="1B2138"/>
+                </a:solidFill>
+                <a:latin typeface="Calibri" pitchFamily="34" charset="0"/>
+                <a:ea typeface="Calibri" pitchFamily="34" charset="-122"/>
+                <a:cs typeface="Calibri" pitchFamily="34" charset="-120"/>
+              </a:rPr>
+              <a:t>En el paciente psiquiátrico y en la demencia se expresan como agitación, hostilidad y conducta disruptiva.</a:t>
+            </a:r>
+            <a:endParaRPr lang="en-US" sz="1600" dirty="0"/>
+          </a:p>
+          <a:p>
+            <a:pPr marL="177800" indent="-177800">
+              <a:spcAft>
+                <a:spcPts val="800"/>
+              </a:spcAft>
+              <a:buSzPct val="100000"/>
+              <a:buChar char="•"/>
+            </a:pPr>
+            <a:r>
+              <a:rPr lang="en-US" sz="1600" dirty="0">
+                <a:solidFill>
+                  <a:srgbClr val="1B2138"/>
+                </a:solidFill>
+                <a:latin typeface="Calibri" pitchFamily="34" charset="0"/>
+                <a:ea typeface="Calibri" pitchFamily="34" charset="-122"/>
+                <a:cs typeface="Calibri" pitchFamily="34" charset="-120"/>
+              </a:rPr>
+              <a:t>Racional SDAM: el equilibrio dopamina-serotonina (agonismo parcial D2/5-HT1A + antagonismo 5-HT2A) atenúa la impulsividad y la agresividad.</a:t>
+            </a:r>
+            <a:endParaRPr lang="en-US" sz="1600" dirty="0"/>
+          </a:p>
+          <a:p>
+            <a:pPr marL="177800" indent="-177800">
+              <a:spcAft>
+                <a:spcPts val="800"/>
+              </a:spcAft>
+              <a:buSzPct val="100000"/>
+              <a:buChar char="•"/>
+            </a:pPr>
+            <a:r>
+              <a:rPr lang="en-US" sz="1600" dirty="0">
+                <a:solidFill>
+                  <a:srgbClr val="1B2138"/>
+                </a:solidFill>
+                <a:latin typeface="Calibri" pitchFamily="34" charset="0"/>
+                <a:ea typeface="Calibri" pitchFamily="34" charset="-122"/>
+                <a:cs typeface="Calibri" pitchFamily="34" charset="-120"/>
+              </a:rPr>
+              <a:t>Evidencia aprobada limitada a la agitación en la demencia de Alzheimer; otros usos conductuales son off-label y con evidencia emergente.</a:t>
+            </a:r>
+            <a:endParaRPr lang="en-US" sz="1600" dirty="0"/>
+          </a:p>
+          <a:p>
+            <a:pPr marL="177800" indent="-177800">
+              <a:spcAft>
+                <a:spcPts val="800"/>
+              </a:spcAft>
+              <a:buSzPct val="100000"/>
+              <a:buChar char="•"/>
+            </a:pPr>
+            <a:r>
+              <a:rPr lang="en-US" sz="1600" b="1" dirty="0">
+                <a:solidFill>
+                  <a:srgbClr val="1E2761"/>
+                </a:solidFill>
+                <a:latin typeface="Calibri" pitchFamily="34" charset="0"/>
+                <a:ea typeface="Calibri" pitchFamily="34" charset="-122"/>
+                <a:cs typeface="Calibri" pitchFamily="34" charset="-120"/>
+              </a:rPr>
+              <a:t>No aprobado en el trastorno de conducta de niños y adolescentes; requiere valoración especializada.</a:t>
+            </a:r>
+            <a:endParaRPr lang="en-US" sz="1600" dirty="0"/>
+          </a:p>
+        </p:txBody>
+      </p:sp>
+      <p:sp>
+        <p:nvSpPr>
+          <p:cNvPr id="7" name="Shape 4"/>
+          <p:cNvSpPr/>
+          <p:nvPr/>
+        </p:nvSpPr>
+        <p:spPr>
+          <a:xfrm>
+            <a:off x="548640" y="5440680"/>
+            <a:ext cx="7086600" cy="868680"/>
+          </a:xfrm>
+          <a:prstGeom prst="roundRect">
+            <a:avLst>
+              <a:gd name="adj" fmla="val 8421"/>
+            </a:avLst>
           </a:prstGeom>
           <a:solidFill>
-            <a:srgbClr val="1E2761"/>
+            <a:srgbClr val="F4F7FD"/>
           </a:solidFill>
           <a:ln w="12700">
             <a:solidFill>
@@ -6003,286 +6221,50 @@
       </p:sp>
       <p:sp>
         <p:nvSpPr>
-          <p:cNvPr id="7" name="Text 4"/>
-          <p:cNvSpPr/>
-          <p:nvPr/>
-        </p:nvSpPr>
-        <p:spPr>
-          <a:xfrm>
-            <a:off x="621792" y="1554480"/>
-            <a:ext cx="2185416" cy="621792"/>
-          </a:xfrm>
-          <a:prstGeom prst="rect">
-            <a:avLst/>
-          </a:prstGeom>
-          <a:noFill/>
-          <a:ln/>
-        </p:spPr>
-        <p:txBody>
-          <a:bodyPr wrap="square" lIns="0" tIns="0" rIns="0" bIns="0" rtlCol="0" anchor="ctr"/>
+          <p:cNvPr id="8" name="Text 5"/>
+          <p:cNvSpPr/>
+          <p:nvPr/>
+        </p:nvSpPr>
+        <p:spPr>
+          <a:xfrm>
+            <a:off x="749808" y="5586984"/>
+            <a:ext cx="6684264" cy="576072"/>
+          </a:xfrm>
+          <a:prstGeom prst="rect">
+            <a:avLst/>
+          </a:prstGeom>
+          <a:noFill/>
+          <a:ln/>
+        </p:spPr>
+        <p:txBody>
+          <a:bodyPr wrap="square" rtlCol="0" anchor="t"/>
           <a:lstStyle/>
           <a:p>
             <a:pPr algn="l" indent="0" marL="0">
-              <a:buNone/>
-            </a:pPr>
-            <a:r>
-              <a:rPr lang="en-US" sz="1250" b="1" dirty="0">
-                <a:solidFill>
-                  <a:srgbClr val="FFFFFF"/>
+              <a:spcAft>
+                <a:spcPts val="400"/>
+              </a:spcAft>
+              <a:buNone/>
+            </a:pPr>
+            <a:r>
+              <a:rPr lang="en-US" sz="1400" b="1" dirty="0">
+                <a:solidFill>
+                  <a:srgbClr val="1E2761"/>
                 </a:solidFill>
                 <a:latin typeface="Cambria" pitchFamily="34" charset="0"/>
                 <a:ea typeface="Cambria" pitchFamily="34" charset="-122"/>
                 <a:cs typeface="Cambria" pitchFamily="34" charset="-120"/>
               </a:rPr>
-              <a:t>Indicación</a:t>
-            </a:r>
-            <a:endParaRPr lang="en-US" sz="1250" dirty="0"/>
-          </a:p>
-        </p:txBody>
-      </p:sp>
-      <p:sp>
-        <p:nvSpPr>
-          <p:cNvPr id="8" name="Shape 5"/>
-          <p:cNvSpPr/>
-          <p:nvPr/>
-        </p:nvSpPr>
-        <p:spPr>
-          <a:xfrm>
-            <a:off x="2880360" y="1554480"/>
-            <a:ext cx="1783080" cy="621792"/>
-          </a:xfrm>
-          <a:prstGeom prst="rect">
-            <a:avLst/>
-          </a:prstGeom>
-          <a:solidFill>
-            <a:srgbClr val="1E2761"/>
-          </a:solidFill>
-          <a:ln w="12700">
-            <a:solidFill>
-              <a:srgbClr val="D9E2F5"/>
-            </a:solidFill>
-            <a:prstDash val="solid"/>
-          </a:ln>
-        </p:spPr>
-      </p:sp>
-      <p:sp>
-        <p:nvSpPr>
-          <p:cNvPr id="9" name="Text 6"/>
-          <p:cNvSpPr/>
-          <p:nvPr/>
-        </p:nvSpPr>
-        <p:spPr>
-          <a:xfrm>
-            <a:off x="2953512" y="1554480"/>
-            <a:ext cx="1636776" cy="621792"/>
-          </a:xfrm>
-          <a:prstGeom prst="rect">
-            <a:avLst/>
-          </a:prstGeom>
-          <a:noFill/>
-          <a:ln/>
-        </p:spPr>
-        <p:txBody>
-          <a:bodyPr wrap="square" lIns="0" tIns="0" rIns="0" bIns="0" rtlCol="0" anchor="ctr"/>
-          <a:lstStyle/>
-          <a:p>
-            <a:pPr algn="ctr" indent="0" marL="0">
-              <a:buNone/>
-            </a:pPr>
-            <a:r>
-              <a:rPr lang="en-US" sz="1250" b="1" dirty="0">
-                <a:solidFill>
-                  <a:srgbClr val="FFFFFF"/>
-                </a:solidFill>
-                <a:latin typeface="Cambria" pitchFamily="34" charset="0"/>
-                <a:ea typeface="Cambria" pitchFamily="34" charset="-122"/>
-                <a:cs typeface="Cambria" pitchFamily="34" charset="-120"/>
-              </a:rPr>
-              <a:t>Inicio</a:t>
-            </a:r>
-            <a:endParaRPr lang="en-US" sz="1250" dirty="0"/>
-          </a:p>
-        </p:txBody>
-      </p:sp>
-      <p:sp>
-        <p:nvSpPr>
-          <p:cNvPr id="10" name="Shape 7"/>
-          <p:cNvSpPr/>
-          <p:nvPr/>
-        </p:nvSpPr>
-        <p:spPr>
-          <a:xfrm>
-            <a:off x="4663440" y="1554480"/>
-            <a:ext cx="1417320" cy="621792"/>
-          </a:xfrm>
-          <a:prstGeom prst="rect">
-            <a:avLst/>
-          </a:prstGeom>
-          <a:solidFill>
-            <a:srgbClr val="1E2761"/>
-          </a:solidFill>
-          <a:ln w="12700">
-            <a:solidFill>
-              <a:srgbClr val="D9E2F5"/>
-            </a:solidFill>
-            <a:prstDash val="solid"/>
-          </a:ln>
-        </p:spPr>
-      </p:sp>
-      <p:sp>
-        <p:nvSpPr>
-          <p:cNvPr id="11" name="Text 8"/>
-          <p:cNvSpPr/>
-          <p:nvPr/>
-        </p:nvSpPr>
-        <p:spPr>
-          <a:xfrm>
-            <a:off x="4736592" y="1554480"/>
-            <a:ext cx="1271016" cy="621792"/>
-          </a:xfrm>
-          <a:prstGeom prst="rect">
-            <a:avLst/>
-          </a:prstGeom>
-          <a:noFill/>
-          <a:ln/>
-        </p:spPr>
-        <p:txBody>
-          <a:bodyPr wrap="square" lIns="0" tIns="0" rIns="0" bIns="0" rtlCol="0" anchor="ctr"/>
-          <a:lstStyle/>
-          <a:p>
-            <a:pPr algn="ctr" indent="0" marL="0">
-              <a:buNone/>
-            </a:pPr>
-            <a:r>
-              <a:rPr lang="en-US" sz="1250" b="1" dirty="0">
-                <a:solidFill>
-                  <a:srgbClr val="FFFFFF"/>
-                </a:solidFill>
-                <a:latin typeface="Cambria" pitchFamily="34" charset="0"/>
-                <a:ea typeface="Cambria" pitchFamily="34" charset="-122"/>
-                <a:cs typeface="Cambria" pitchFamily="34" charset="-120"/>
-              </a:rPr>
-              <a:t>Objetivo</a:t>
-            </a:r>
-            <a:endParaRPr lang="en-US" sz="1250" dirty="0"/>
-          </a:p>
-        </p:txBody>
-      </p:sp>
-      <p:sp>
-        <p:nvSpPr>
-          <p:cNvPr id="12" name="Shape 9"/>
-          <p:cNvSpPr/>
-          <p:nvPr/>
-        </p:nvSpPr>
-        <p:spPr>
-          <a:xfrm>
-            <a:off x="6080760" y="1554480"/>
-            <a:ext cx="1188720" cy="621792"/>
-          </a:xfrm>
-          <a:prstGeom prst="rect">
-            <a:avLst/>
-          </a:prstGeom>
-          <a:solidFill>
-            <a:srgbClr val="1E2761"/>
-          </a:solidFill>
-          <a:ln w="12700">
-            <a:solidFill>
-              <a:srgbClr val="D9E2F5"/>
-            </a:solidFill>
-            <a:prstDash val="solid"/>
-          </a:ln>
-        </p:spPr>
-      </p:sp>
-      <p:sp>
-        <p:nvSpPr>
-          <p:cNvPr id="13" name="Text 10"/>
-          <p:cNvSpPr/>
-          <p:nvPr/>
-        </p:nvSpPr>
-        <p:spPr>
-          <a:xfrm>
-            <a:off x="6153912" y="1554480"/>
-            <a:ext cx="1042416" cy="621792"/>
-          </a:xfrm>
-          <a:prstGeom prst="rect">
-            <a:avLst/>
-          </a:prstGeom>
-          <a:noFill/>
-          <a:ln/>
-        </p:spPr>
-        <p:txBody>
-          <a:bodyPr wrap="square" lIns="0" tIns="0" rIns="0" bIns="0" rtlCol="0" anchor="ctr"/>
-          <a:lstStyle/>
-          <a:p>
-            <a:pPr algn="ctr" indent="0" marL="0">
-              <a:buNone/>
-            </a:pPr>
-            <a:r>
-              <a:rPr lang="en-US" sz="1250" b="1" dirty="0">
-                <a:solidFill>
-                  <a:srgbClr val="FFFFFF"/>
-                </a:solidFill>
-                <a:latin typeface="Cambria" pitchFamily="34" charset="0"/>
-                <a:ea typeface="Cambria" pitchFamily="34" charset="-122"/>
-                <a:cs typeface="Cambria" pitchFamily="34" charset="-120"/>
-              </a:rPr>
-              <a:t>Máx.</a:t>
-            </a:r>
-            <a:endParaRPr lang="en-US" sz="1250" dirty="0"/>
-          </a:p>
-        </p:txBody>
-      </p:sp>
-      <p:sp>
-        <p:nvSpPr>
-          <p:cNvPr id="14" name="Shape 11"/>
-          <p:cNvSpPr/>
-          <p:nvPr/>
-        </p:nvSpPr>
-        <p:spPr>
-          <a:xfrm>
-            <a:off x="548640" y="2176272"/>
-            <a:ext cx="2331720" cy="621792"/>
-          </a:xfrm>
-          <a:prstGeom prst="rect">
-            <a:avLst/>
-          </a:prstGeom>
-          <a:solidFill>
-            <a:srgbClr val="EEF3FC"/>
-          </a:solidFill>
-          <a:ln w="12700">
-            <a:solidFill>
-              <a:srgbClr val="D9E2F5"/>
-            </a:solidFill>
-            <a:prstDash val="solid"/>
-          </a:ln>
-        </p:spPr>
-      </p:sp>
-      <p:sp>
-        <p:nvSpPr>
-          <p:cNvPr id="15" name="Text 12"/>
-          <p:cNvSpPr/>
-          <p:nvPr/>
-        </p:nvSpPr>
-        <p:spPr>
-          <a:xfrm>
-            <a:off x="621792" y="2176272"/>
-            <a:ext cx="2185416" cy="621792"/>
-          </a:xfrm>
-          <a:prstGeom prst="rect">
-            <a:avLst/>
-          </a:prstGeom>
-          <a:noFill/>
-          <a:ln/>
-        </p:spPr>
-        <p:txBody>
-          <a:bodyPr wrap="square" lIns="0" tIns="0" rIns="0" bIns="0" rtlCol="0" anchor="ctr"/>
-          <a:lstStyle/>
+              <a:t>Principio de uso</a:t>
+            </a:r>
+            <a:endParaRPr lang="en-US" sz="1400" dirty="0"/>
+          </a:p>
           <a:p>
             <a:pPr algn="l" indent="0" marL="0">
               <a:buNone/>
             </a:pPr>
             <a:r>
-              <a:rPr lang="en-US" sz="1250" b="1" dirty="0">
+              <a:rPr lang="en-US" sz="1300" dirty="0">
                 <a:solidFill>
                   <a:srgbClr val="1B2138"/>
                 </a:solidFill>
@@ -6290,798 +6272,9 @@
                 <a:ea typeface="Calibri" pitchFamily="34" charset="-122"/>
                 <a:cs typeface="Calibri" pitchFamily="34" charset="-120"/>
               </a:rPr>
-              <a:t>Esquizofrenia</a:t>
-            </a:r>
-            <a:endParaRPr lang="en-US" sz="1250" dirty="0"/>
-          </a:p>
-        </p:txBody>
-      </p:sp>
-      <p:sp>
-        <p:nvSpPr>
-          <p:cNvPr id="16" name="Shape 13"/>
-          <p:cNvSpPr/>
-          <p:nvPr/>
-        </p:nvSpPr>
-        <p:spPr>
-          <a:xfrm>
-            <a:off x="2880360" y="2176272"/>
-            <a:ext cx="1783080" cy="621792"/>
-          </a:xfrm>
-          <a:prstGeom prst="rect">
-            <a:avLst/>
-          </a:prstGeom>
-          <a:solidFill>
-            <a:srgbClr val="EEF3FC"/>
-          </a:solidFill>
-          <a:ln w="12700">
-            <a:solidFill>
-              <a:srgbClr val="D9E2F5"/>
-            </a:solidFill>
-            <a:prstDash val="solid"/>
-          </a:ln>
-        </p:spPr>
-      </p:sp>
-      <p:sp>
-        <p:nvSpPr>
-          <p:cNvPr id="17" name="Text 14"/>
-          <p:cNvSpPr/>
-          <p:nvPr/>
-        </p:nvSpPr>
-        <p:spPr>
-          <a:xfrm>
-            <a:off x="2953512" y="2176272"/>
-            <a:ext cx="1636776" cy="621792"/>
-          </a:xfrm>
-          <a:prstGeom prst="rect">
-            <a:avLst/>
-          </a:prstGeom>
-          <a:noFill/>
-          <a:ln/>
-        </p:spPr>
-        <p:txBody>
-          <a:bodyPr wrap="square" lIns="0" tIns="0" rIns="0" bIns="0" rtlCol="0" anchor="ctr"/>
-          <a:lstStyle/>
-          <a:p>
-            <a:pPr algn="ctr" indent="0" marL="0">
-              <a:buNone/>
-            </a:pPr>
-            <a:r>
-              <a:rPr lang="en-US" sz="1250" dirty="0">
-                <a:solidFill>
-                  <a:srgbClr val="1B2138"/>
-                </a:solidFill>
-                <a:latin typeface="Calibri" pitchFamily="34" charset="0"/>
-                <a:ea typeface="Calibri" pitchFamily="34" charset="-122"/>
-                <a:cs typeface="Calibri" pitchFamily="34" charset="-120"/>
-              </a:rPr>
-              <a:t>1 mg (días 1–4)</a:t>
-            </a:r>
-            <a:endParaRPr lang="en-US" sz="1250" dirty="0"/>
-          </a:p>
-        </p:txBody>
-      </p:sp>
-      <p:sp>
-        <p:nvSpPr>
-          <p:cNvPr id="18" name="Shape 15"/>
-          <p:cNvSpPr/>
-          <p:nvPr/>
-        </p:nvSpPr>
-        <p:spPr>
-          <a:xfrm>
-            <a:off x="4663440" y="2176272"/>
-            <a:ext cx="1417320" cy="621792"/>
-          </a:xfrm>
-          <a:prstGeom prst="rect">
-            <a:avLst/>
-          </a:prstGeom>
-          <a:solidFill>
-            <a:srgbClr val="EEF3FC"/>
-          </a:solidFill>
-          <a:ln w="12700">
-            <a:solidFill>
-              <a:srgbClr val="D9E2F5"/>
-            </a:solidFill>
-            <a:prstDash val="solid"/>
-          </a:ln>
-        </p:spPr>
-      </p:sp>
-      <p:sp>
-        <p:nvSpPr>
-          <p:cNvPr id="19" name="Text 16"/>
-          <p:cNvSpPr/>
-          <p:nvPr/>
-        </p:nvSpPr>
-        <p:spPr>
-          <a:xfrm>
-            <a:off x="4736592" y="2176272"/>
-            <a:ext cx="1271016" cy="621792"/>
-          </a:xfrm>
-          <a:prstGeom prst="rect">
-            <a:avLst/>
-          </a:prstGeom>
-          <a:noFill/>
-          <a:ln/>
-        </p:spPr>
-        <p:txBody>
-          <a:bodyPr wrap="square" lIns="0" tIns="0" rIns="0" bIns="0" rtlCol="0" anchor="ctr"/>
-          <a:lstStyle/>
-          <a:p>
-            <a:pPr algn="ctr" indent="0" marL="0">
-              <a:buNone/>
-            </a:pPr>
-            <a:r>
-              <a:rPr lang="en-US" sz="1250" dirty="0">
-                <a:solidFill>
-                  <a:srgbClr val="1B2138"/>
-                </a:solidFill>
-                <a:latin typeface="Calibri" pitchFamily="34" charset="0"/>
-                <a:ea typeface="Calibri" pitchFamily="34" charset="-122"/>
-                <a:cs typeface="Calibri" pitchFamily="34" charset="-120"/>
-              </a:rPr>
-              <a:t>2–4 mg</a:t>
-            </a:r>
-            <a:endParaRPr lang="en-US" sz="1250" dirty="0"/>
-          </a:p>
-        </p:txBody>
-      </p:sp>
-      <p:sp>
-        <p:nvSpPr>
-          <p:cNvPr id="20" name="Shape 17"/>
-          <p:cNvSpPr/>
-          <p:nvPr/>
-        </p:nvSpPr>
-        <p:spPr>
-          <a:xfrm>
-            <a:off x="6080760" y="2176272"/>
-            <a:ext cx="1188720" cy="621792"/>
-          </a:xfrm>
-          <a:prstGeom prst="rect">
-            <a:avLst/>
-          </a:prstGeom>
-          <a:solidFill>
-            <a:srgbClr val="EEF3FC"/>
-          </a:solidFill>
-          <a:ln w="12700">
-            <a:solidFill>
-              <a:srgbClr val="D9E2F5"/>
-            </a:solidFill>
-            <a:prstDash val="solid"/>
-          </a:ln>
-        </p:spPr>
-      </p:sp>
-      <p:sp>
-        <p:nvSpPr>
-          <p:cNvPr id="21" name="Text 18"/>
-          <p:cNvSpPr/>
-          <p:nvPr/>
-        </p:nvSpPr>
-        <p:spPr>
-          <a:xfrm>
-            <a:off x="6153912" y="2176272"/>
-            <a:ext cx="1042416" cy="621792"/>
-          </a:xfrm>
-          <a:prstGeom prst="rect">
-            <a:avLst/>
-          </a:prstGeom>
-          <a:noFill/>
-          <a:ln/>
-        </p:spPr>
-        <p:txBody>
-          <a:bodyPr wrap="square" lIns="0" tIns="0" rIns="0" bIns="0" rtlCol="0" anchor="ctr"/>
-          <a:lstStyle/>
-          <a:p>
-            <a:pPr algn="ctr" indent="0" marL="0">
-              <a:buNone/>
-            </a:pPr>
-            <a:r>
-              <a:rPr lang="en-US" sz="1250" dirty="0">
-                <a:solidFill>
-                  <a:srgbClr val="1B2138"/>
-                </a:solidFill>
-                <a:latin typeface="Calibri" pitchFamily="34" charset="0"/>
-                <a:ea typeface="Calibri" pitchFamily="34" charset="-122"/>
-                <a:cs typeface="Calibri" pitchFamily="34" charset="-120"/>
-              </a:rPr>
-              <a:t>4 mg</a:t>
-            </a:r>
-            <a:endParaRPr lang="en-US" sz="1250" dirty="0"/>
-          </a:p>
-        </p:txBody>
-      </p:sp>
-      <p:sp>
-        <p:nvSpPr>
-          <p:cNvPr id="22" name="Shape 19"/>
-          <p:cNvSpPr/>
-          <p:nvPr/>
-        </p:nvSpPr>
-        <p:spPr>
-          <a:xfrm>
-            <a:off x="548640" y="2798064"/>
-            <a:ext cx="2331720" cy="621792"/>
-          </a:xfrm>
-          <a:prstGeom prst="rect">
-            <a:avLst/>
-          </a:prstGeom>
-          <a:solidFill>
-            <a:srgbClr val="FFFFFF"/>
-          </a:solidFill>
-          <a:ln w="12700">
-            <a:solidFill>
-              <a:srgbClr val="D9E2F5"/>
-            </a:solidFill>
-            <a:prstDash val="solid"/>
-          </a:ln>
-        </p:spPr>
-      </p:sp>
-      <p:sp>
-        <p:nvSpPr>
-          <p:cNvPr id="23" name="Text 20"/>
-          <p:cNvSpPr/>
-          <p:nvPr/>
-        </p:nvSpPr>
-        <p:spPr>
-          <a:xfrm>
-            <a:off x="621792" y="2798064"/>
-            <a:ext cx="2185416" cy="621792"/>
-          </a:xfrm>
-          <a:prstGeom prst="rect">
-            <a:avLst/>
-          </a:prstGeom>
-          <a:noFill/>
-          <a:ln/>
-        </p:spPr>
-        <p:txBody>
-          <a:bodyPr wrap="square" lIns="0" tIns="0" rIns="0" bIns="0" rtlCol="0" anchor="ctr"/>
-          <a:lstStyle/>
-          <a:p>
-            <a:pPr algn="l" indent="0" marL="0">
-              <a:buNone/>
-            </a:pPr>
-            <a:r>
-              <a:rPr lang="en-US" sz="1250" b="1" dirty="0">
-                <a:solidFill>
-                  <a:srgbClr val="1B2138"/>
-                </a:solidFill>
-                <a:latin typeface="Calibri" pitchFamily="34" charset="0"/>
-                <a:ea typeface="Calibri" pitchFamily="34" charset="-122"/>
-                <a:cs typeface="Calibri" pitchFamily="34" charset="-120"/>
-              </a:rPr>
-              <a:t>TDM (adyuvante)</a:t>
-            </a:r>
-            <a:endParaRPr lang="en-US" sz="1250" dirty="0"/>
-          </a:p>
-        </p:txBody>
-      </p:sp>
-      <p:sp>
-        <p:nvSpPr>
-          <p:cNvPr id="24" name="Shape 21"/>
-          <p:cNvSpPr/>
-          <p:nvPr/>
-        </p:nvSpPr>
-        <p:spPr>
-          <a:xfrm>
-            <a:off x="2880360" y="2798064"/>
-            <a:ext cx="1783080" cy="621792"/>
-          </a:xfrm>
-          <a:prstGeom prst="rect">
-            <a:avLst/>
-          </a:prstGeom>
-          <a:solidFill>
-            <a:srgbClr val="FFFFFF"/>
-          </a:solidFill>
-          <a:ln w="12700">
-            <a:solidFill>
-              <a:srgbClr val="D9E2F5"/>
-            </a:solidFill>
-            <a:prstDash val="solid"/>
-          </a:ln>
-        </p:spPr>
-      </p:sp>
-      <p:sp>
-        <p:nvSpPr>
-          <p:cNvPr id="25" name="Text 22"/>
-          <p:cNvSpPr/>
-          <p:nvPr/>
-        </p:nvSpPr>
-        <p:spPr>
-          <a:xfrm>
-            <a:off x="2953512" y="2798064"/>
-            <a:ext cx="1636776" cy="621792"/>
-          </a:xfrm>
-          <a:prstGeom prst="rect">
-            <a:avLst/>
-          </a:prstGeom>
-          <a:noFill/>
-          <a:ln/>
-        </p:spPr>
-        <p:txBody>
-          <a:bodyPr wrap="square" lIns="0" tIns="0" rIns="0" bIns="0" rtlCol="0" anchor="ctr"/>
-          <a:lstStyle/>
-          <a:p>
-            <a:pPr algn="ctr" indent="0" marL="0">
-              <a:buNone/>
-            </a:pPr>
-            <a:r>
-              <a:rPr lang="en-US" sz="1250" dirty="0">
-                <a:solidFill>
-                  <a:srgbClr val="1B2138"/>
-                </a:solidFill>
-                <a:latin typeface="Calibri" pitchFamily="34" charset="0"/>
-                <a:ea typeface="Calibri" pitchFamily="34" charset="-122"/>
-                <a:cs typeface="Calibri" pitchFamily="34" charset="-120"/>
-              </a:rPr>
-              <a:t>0,5–1 mg</a:t>
-            </a:r>
-            <a:endParaRPr lang="en-US" sz="1250" dirty="0"/>
-          </a:p>
-        </p:txBody>
-      </p:sp>
-      <p:sp>
-        <p:nvSpPr>
-          <p:cNvPr id="26" name="Shape 23"/>
-          <p:cNvSpPr/>
-          <p:nvPr/>
-        </p:nvSpPr>
-        <p:spPr>
-          <a:xfrm>
-            <a:off x="4663440" y="2798064"/>
-            <a:ext cx="1417320" cy="621792"/>
-          </a:xfrm>
-          <a:prstGeom prst="rect">
-            <a:avLst/>
-          </a:prstGeom>
-          <a:solidFill>
-            <a:srgbClr val="FFFFFF"/>
-          </a:solidFill>
-          <a:ln w="12700">
-            <a:solidFill>
-              <a:srgbClr val="D9E2F5"/>
-            </a:solidFill>
-            <a:prstDash val="solid"/>
-          </a:ln>
-        </p:spPr>
-      </p:sp>
-      <p:sp>
-        <p:nvSpPr>
-          <p:cNvPr id="27" name="Text 24"/>
-          <p:cNvSpPr/>
-          <p:nvPr/>
-        </p:nvSpPr>
-        <p:spPr>
-          <a:xfrm>
-            <a:off x="4736592" y="2798064"/>
-            <a:ext cx="1271016" cy="621792"/>
-          </a:xfrm>
-          <a:prstGeom prst="rect">
-            <a:avLst/>
-          </a:prstGeom>
-          <a:noFill/>
-          <a:ln/>
-        </p:spPr>
-        <p:txBody>
-          <a:bodyPr wrap="square" lIns="0" tIns="0" rIns="0" bIns="0" rtlCol="0" anchor="ctr"/>
-          <a:lstStyle/>
-          <a:p>
-            <a:pPr algn="ctr" indent="0" marL="0">
-              <a:buNone/>
-            </a:pPr>
-            <a:r>
-              <a:rPr lang="en-US" sz="1250" dirty="0">
-                <a:solidFill>
-                  <a:srgbClr val="1B2138"/>
-                </a:solidFill>
-                <a:latin typeface="Calibri" pitchFamily="34" charset="0"/>
-                <a:ea typeface="Calibri" pitchFamily="34" charset="-122"/>
-                <a:cs typeface="Calibri" pitchFamily="34" charset="-120"/>
-              </a:rPr>
-              <a:t>2 mg</a:t>
-            </a:r>
-            <a:endParaRPr lang="en-US" sz="1250" dirty="0"/>
-          </a:p>
-        </p:txBody>
-      </p:sp>
-      <p:sp>
-        <p:nvSpPr>
-          <p:cNvPr id="28" name="Shape 25"/>
-          <p:cNvSpPr/>
-          <p:nvPr/>
-        </p:nvSpPr>
-        <p:spPr>
-          <a:xfrm>
-            <a:off x="6080760" y="2798064"/>
-            <a:ext cx="1188720" cy="621792"/>
-          </a:xfrm>
-          <a:prstGeom prst="rect">
-            <a:avLst/>
-          </a:prstGeom>
-          <a:solidFill>
-            <a:srgbClr val="FFFFFF"/>
-          </a:solidFill>
-          <a:ln w="12700">
-            <a:solidFill>
-              <a:srgbClr val="D9E2F5"/>
-            </a:solidFill>
-            <a:prstDash val="solid"/>
-          </a:ln>
-        </p:spPr>
-      </p:sp>
-      <p:sp>
-        <p:nvSpPr>
-          <p:cNvPr id="29" name="Text 26"/>
-          <p:cNvSpPr/>
-          <p:nvPr/>
-        </p:nvSpPr>
-        <p:spPr>
-          <a:xfrm>
-            <a:off x="6153912" y="2798064"/>
-            <a:ext cx="1042416" cy="621792"/>
-          </a:xfrm>
-          <a:prstGeom prst="rect">
-            <a:avLst/>
-          </a:prstGeom>
-          <a:noFill/>
-          <a:ln/>
-        </p:spPr>
-        <p:txBody>
-          <a:bodyPr wrap="square" lIns="0" tIns="0" rIns="0" bIns="0" rtlCol="0" anchor="ctr"/>
-          <a:lstStyle/>
-          <a:p>
-            <a:pPr algn="ctr" indent="0" marL="0">
-              <a:buNone/>
-            </a:pPr>
-            <a:r>
-              <a:rPr lang="en-US" sz="1250" dirty="0">
-                <a:solidFill>
-                  <a:srgbClr val="1B2138"/>
-                </a:solidFill>
-                <a:latin typeface="Calibri" pitchFamily="34" charset="0"/>
-                <a:ea typeface="Calibri" pitchFamily="34" charset="-122"/>
-                <a:cs typeface="Calibri" pitchFamily="34" charset="-120"/>
-              </a:rPr>
-              <a:t>3 mg</a:t>
-            </a:r>
-            <a:endParaRPr lang="en-US" sz="1250" dirty="0"/>
-          </a:p>
-        </p:txBody>
-      </p:sp>
-      <p:sp>
-        <p:nvSpPr>
-          <p:cNvPr id="30" name="Shape 27"/>
-          <p:cNvSpPr/>
-          <p:nvPr/>
-        </p:nvSpPr>
-        <p:spPr>
-          <a:xfrm>
-            <a:off x="548640" y="3419856"/>
-            <a:ext cx="2331720" cy="621792"/>
-          </a:xfrm>
-          <a:prstGeom prst="rect">
-            <a:avLst/>
-          </a:prstGeom>
-          <a:solidFill>
-            <a:srgbClr val="EEF3FC"/>
-          </a:solidFill>
-          <a:ln w="12700">
-            <a:solidFill>
-              <a:srgbClr val="D9E2F5"/>
-            </a:solidFill>
-            <a:prstDash val="solid"/>
-          </a:ln>
-        </p:spPr>
-      </p:sp>
-      <p:sp>
-        <p:nvSpPr>
-          <p:cNvPr id="31" name="Text 28"/>
-          <p:cNvSpPr/>
-          <p:nvPr/>
-        </p:nvSpPr>
-        <p:spPr>
-          <a:xfrm>
-            <a:off x="621792" y="3419856"/>
-            <a:ext cx="2185416" cy="621792"/>
-          </a:xfrm>
-          <a:prstGeom prst="rect">
-            <a:avLst/>
-          </a:prstGeom>
-          <a:noFill/>
-          <a:ln/>
-        </p:spPr>
-        <p:txBody>
-          <a:bodyPr wrap="square" lIns="0" tIns="0" rIns="0" bIns="0" rtlCol="0" anchor="ctr"/>
-          <a:lstStyle/>
-          <a:p>
-            <a:pPr algn="l" indent="0" marL="0">
-              <a:buNone/>
-            </a:pPr>
-            <a:r>
-              <a:rPr lang="en-US" sz="1250" b="1" dirty="0">
-                <a:solidFill>
-                  <a:srgbClr val="1B2138"/>
-                </a:solidFill>
-                <a:latin typeface="Calibri" pitchFamily="34" charset="0"/>
-                <a:ea typeface="Calibri" pitchFamily="34" charset="-122"/>
-                <a:cs typeface="Calibri" pitchFamily="34" charset="-120"/>
-              </a:rPr>
-              <a:t>Agitación/Alzheimer</a:t>
-            </a:r>
-            <a:endParaRPr lang="en-US" sz="1250" dirty="0"/>
-          </a:p>
-        </p:txBody>
-      </p:sp>
-      <p:sp>
-        <p:nvSpPr>
-          <p:cNvPr id="32" name="Shape 29"/>
-          <p:cNvSpPr/>
-          <p:nvPr/>
-        </p:nvSpPr>
-        <p:spPr>
-          <a:xfrm>
-            <a:off x="2880360" y="3419856"/>
-            <a:ext cx="1783080" cy="621792"/>
-          </a:xfrm>
-          <a:prstGeom prst="rect">
-            <a:avLst/>
-          </a:prstGeom>
-          <a:solidFill>
-            <a:srgbClr val="EEF3FC"/>
-          </a:solidFill>
-          <a:ln w="12700">
-            <a:solidFill>
-              <a:srgbClr val="D9E2F5"/>
-            </a:solidFill>
-            <a:prstDash val="solid"/>
-          </a:ln>
-        </p:spPr>
-      </p:sp>
-      <p:sp>
-        <p:nvSpPr>
-          <p:cNvPr id="33" name="Text 30"/>
-          <p:cNvSpPr/>
-          <p:nvPr/>
-        </p:nvSpPr>
-        <p:spPr>
-          <a:xfrm>
-            <a:off x="2953512" y="3419856"/>
-            <a:ext cx="1636776" cy="621792"/>
-          </a:xfrm>
-          <a:prstGeom prst="rect">
-            <a:avLst/>
-          </a:prstGeom>
-          <a:noFill/>
-          <a:ln/>
-        </p:spPr>
-        <p:txBody>
-          <a:bodyPr wrap="square" lIns="0" tIns="0" rIns="0" bIns="0" rtlCol="0" anchor="ctr"/>
-          <a:lstStyle/>
-          <a:p>
-            <a:pPr algn="ctr" indent="0" marL="0">
-              <a:buNone/>
-            </a:pPr>
-            <a:r>
-              <a:rPr lang="en-US" sz="1250" dirty="0">
-                <a:solidFill>
-                  <a:srgbClr val="1B2138"/>
-                </a:solidFill>
-                <a:latin typeface="Calibri" pitchFamily="34" charset="0"/>
-                <a:ea typeface="Calibri" pitchFamily="34" charset="-122"/>
-                <a:cs typeface="Calibri" pitchFamily="34" charset="-120"/>
-              </a:rPr>
-              <a:t>0,5 mg (1.ª sem.)</a:t>
-            </a:r>
-            <a:endParaRPr lang="en-US" sz="1250" dirty="0"/>
-          </a:p>
-        </p:txBody>
-      </p:sp>
-      <p:sp>
-        <p:nvSpPr>
-          <p:cNvPr id="34" name="Shape 31"/>
-          <p:cNvSpPr/>
-          <p:nvPr/>
-        </p:nvSpPr>
-        <p:spPr>
-          <a:xfrm>
-            <a:off x="4663440" y="3419856"/>
-            <a:ext cx="1417320" cy="621792"/>
-          </a:xfrm>
-          <a:prstGeom prst="rect">
-            <a:avLst/>
-          </a:prstGeom>
-          <a:solidFill>
-            <a:srgbClr val="EEF3FC"/>
-          </a:solidFill>
-          <a:ln w="12700">
-            <a:solidFill>
-              <a:srgbClr val="D9E2F5"/>
-            </a:solidFill>
-            <a:prstDash val="solid"/>
-          </a:ln>
-        </p:spPr>
-      </p:sp>
-      <p:sp>
-        <p:nvSpPr>
-          <p:cNvPr id="35" name="Text 32"/>
-          <p:cNvSpPr/>
-          <p:nvPr/>
-        </p:nvSpPr>
-        <p:spPr>
-          <a:xfrm>
-            <a:off x="4736592" y="3419856"/>
-            <a:ext cx="1271016" cy="621792"/>
-          </a:xfrm>
-          <a:prstGeom prst="rect">
-            <a:avLst/>
-          </a:prstGeom>
-          <a:noFill/>
-          <a:ln/>
-        </p:spPr>
-        <p:txBody>
-          <a:bodyPr wrap="square" lIns="0" tIns="0" rIns="0" bIns="0" rtlCol="0" anchor="ctr"/>
-          <a:lstStyle/>
-          <a:p>
-            <a:pPr algn="ctr" indent="0" marL="0">
-              <a:buNone/>
-            </a:pPr>
-            <a:r>
-              <a:rPr lang="en-US" sz="1250" dirty="0">
-                <a:solidFill>
-                  <a:srgbClr val="1B2138"/>
-                </a:solidFill>
-                <a:latin typeface="Calibri" pitchFamily="34" charset="0"/>
-                <a:ea typeface="Calibri" pitchFamily="34" charset="-122"/>
-                <a:cs typeface="Calibri" pitchFamily="34" charset="-120"/>
-              </a:rPr>
-              <a:t>2–3 mg</a:t>
-            </a:r>
-            <a:endParaRPr lang="en-US" sz="1250" dirty="0"/>
-          </a:p>
-        </p:txBody>
-      </p:sp>
-      <p:sp>
-        <p:nvSpPr>
-          <p:cNvPr id="36" name="Shape 33"/>
-          <p:cNvSpPr/>
-          <p:nvPr/>
-        </p:nvSpPr>
-        <p:spPr>
-          <a:xfrm>
-            <a:off x="6080760" y="3419856"/>
-            <a:ext cx="1188720" cy="621792"/>
-          </a:xfrm>
-          <a:prstGeom prst="rect">
-            <a:avLst/>
-          </a:prstGeom>
-          <a:solidFill>
-            <a:srgbClr val="EEF3FC"/>
-          </a:solidFill>
-          <a:ln w="12700">
-            <a:solidFill>
-              <a:srgbClr val="D9E2F5"/>
-            </a:solidFill>
-            <a:prstDash val="solid"/>
-          </a:ln>
-        </p:spPr>
-      </p:sp>
-      <p:sp>
-        <p:nvSpPr>
-          <p:cNvPr id="37" name="Text 34"/>
-          <p:cNvSpPr/>
-          <p:nvPr/>
-        </p:nvSpPr>
-        <p:spPr>
-          <a:xfrm>
-            <a:off x="6153912" y="3419856"/>
-            <a:ext cx="1042416" cy="621792"/>
-          </a:xfrm>
-          <a:prstGeom prst="rect">
-            <a:avLst/>
-          </a:prstGeom>
-          <a:noFill/>
-          <a:ln/>
-        </p:spPr>
-        <p:txBody>
-          <a:bodyPr wrap="square" lIns="0" tIns="0" rIns="0" bIns="0" rtlCol="0" anchor="ctr"/>
-          <a:lstStyle/>
-          <a:p>
-            <a:pPr algn="ctr" indent="0" marL="0">
-              <a:buNone/>
-            </a:pPr>
-            <a:r>
-              <a:rPr lang="en-US" sz="1250" dirty="0">
-                <a:solidFill>
-                  <a:srgbClr val="1B2138"/>
-                </a:solidFill>
-                <a:latin typeface="Calibri" pitchFamily="34" charset="0"/>
-                <a:ea typeface="Calibri" pitchFamily="34" charset="-122"/>
-                <a:cs typeface="Calibri" pitchFamily="34" charset="-120"/>
-              </a:rPr>
-              <a:t>3 mg</a:t>
-            </a:r>
-            <a:endParaRPr lang="en-US" sz="1250" dirty="0"/>
-          </a:p>
-        </p:txBody>
-      </p:sp>
-      <p:sp>
-        <p:nvSpPr>
-          <p:cNvPr id="38" name="Text 35"/>
-          <p:cNvSpPr/>
-          <p:nvPr/>
-        </p:nvSpPr>
-        <p:spPr>
-          <a:xfrm>
-            <a:off x="548640" y="4251960"/>
-            <a:ext cx="6949440" cy="1920240"/>
-          </a:xfrm>
-          <a:prstGeom prst="rect">
-            <a:avLst/>
-          </a:prstGeom>
-          <a:noFill/>
-          <a:ln/>
-        </p:spPr>
-        <p:txBody>
-          <a:bodyPr wrap="square" rtlCol="0" anchor="t"/>
-          <a:lstStyle/>
-          <a:p>
-            <a:pPr marL="177800" indent="-177800">
-              <a:spcAft>
-                <a:spcPts val="800"/>
-              </a:spcAft>
-              <a:buSzPct val="100000"/>
-              <a:buChar char="•"/>
-            </a:pPr>
-            <a:r>
-              <a:rPr lang="en-US" sz="1300" dirty="0">
-                <a:solidFill>
-                  <a:srgbClr val="1B2138"/>
-                </a:solidFill>
-                <a:latin typeface="Calibri" pitchFamily="34" charset="0"/>
-                <a:ea typeface="Calibri" pitchFamily="34" charset="-122"/>
-                <a:cs typeface="Calibri" pitchFamily="34" charset="-120"/>
-              </a:rPr>
-              <a:t>Una toma diaria, con o sin alimentos; titulación gradual para minimizar la acatisia.</a:t>
-            </a:r>
-            <a:endParaRPr lang="en-US" sz="1300" dirty="0"/>
-          </a:p>
-          <a:p>
-            <a:pPr marL="177800" indent="-177800">
-              <a:spcAft>
-                <a:spcPts val="800"/>
-              </a:spcAft>
-              <a:buSzPct val="100000"/>
-              <a:buChar char="•"/>
-            </a:pPr>
-            <a:r>
-              <a:rPr lang="en-US" sz="1300" b="1" dirty="0">
-                <a:solidFill>
-                  <a:srgbClr val="1B2138"/>
-                </a:solidFill>
-                <a:latin typeface="Calibri" pitchFamily="34" charset="0"/>
-                <a:ea typeface="Calibri" pitchFamily="34" charset="-122"/>
-                <a:cs typeface="Calibri" pitchFamily="34" charset="-120"/>
-              </a:rPr>
-              <a:t>Comprimidos: 0,25 · 0,5 · 1 · 2 · 3 · 4 mg.</a:t>
-            </a:r>
-            <a:endParaRPr lang="en-US" sz="1300" dirty="0"/>
-          </a:p>
-          <a:p>
-            <a:pPr marL="177800" indent="-177800">
-              <a:spcAft>
-                <a:spcPts val="800"/>
-              </a:spcAft>
-              <a:buSzPct val="100000"/>
-              <a:buChar char="•"/>
-            </a:pPr>
-            <a:r>
-              <a:rPr lang="en-US" sz="1300" dirty="0">
-                <a:solidFill>
-                  <a:srgbClr val="1B2138"/>
-                </a:solidFill>
-                <a:latin typeface="Calibri" pitchFamily="34" charset="0"/>
-                <a:ea typeface="Calibri" pitchFamily="34" charset="-122"/>
-                <a:cs typeface="Calibri" pitchFamily="34" charset="-120"/>
-              </a:rPr>
-              <a:t>Reducir dosis en insuficiencia hepática o renal moderada-grave.</a:t>
-            </a:r>
-            <a:endParaRPr lang="en-US" sz="1300" dirty="0"/>
+              <a:t>Siempre como complemento de las intervenciones psicosociales de primera línea, iniciando a dosis bajas y con monitorización estrecha.</a:t>
+            </a:r>
+            <a:endParaRPr lang="en-US" sz="1400" dirty="0"/>
           </a:p>
         </p:txBody>
       </p:sp>
@@ -7096,6 +6289,1275 @@
 <file path=ppt/slides/slide16.xml><?xml version="1.0" encoding="utf-8"?>
 <p:sld xmlns:a="http://schemas.openxmlformats.org/drawingml/2006/main" xmlns:r="http://schemas.openxmlformats.org/officeDocument/2006/relationships" xmlns:p="http://schemas.openxmlformats.org/presentationml/2006/main">
   <p:cSld name="Slide 16">
+    <p:bg>
+      <p:bgPr>
+        <a:solidFill>
+          <a:srgbClr val="FFFFFF"/>
+        </a:solidFill>
+      </p:bgPr>
+    </p:bg>
+    <p:spTree>
+      <p:nvGrpSpPr>
+        <p:cNvPr id="1" name=""/>
+        <p:cNvGrpSpPr/>
+        <p:nvPr/>
+      </p:nvGrpSpPr>
+      <p:grpSpPr>
+        <a:xfrm>
+          <a:off x="0" y="0"/>
+          <a:ext cx="0" cy="0"/>
+          <a:chOff x="0" y="0"/>
+          <a:chExt cx="0" cy="0"/>
+        </a:xfrm>
+      </p:grpSpPr>
+      <p:sp>
+        <p:nvSpPr>
+          <p:cNvPr id="2" name="Shape 0"/>
+          <p:cNvSpPr/>
+          <p:nvPr/>
+        </p:nvSpPr>
+        <p:spPr>
+          <a:xfrm>
+            <a:off x="502920" y="457200"/>
+            <a:ext cx="566928" cy="566928"/>
+          </a:xfrm>
+          <a:prstGeom prst="ellipse">
+            <a:avLst/>
+          </a:prstGeom>
+          <a:solidFill>
+            <a:srgbClr val="3E5FC0"/>
+          </a:solidFill>
+          <a:ln/>
+        </p:spPr>
+      </p:sp>
+      <p:sp>
+        <p:nvSpPr>
+          <p:cNvPr id="3" name="Text 1"/>
+          <p:cNvSpPr/>
+          <p:nvPr/>
+        </p:nvSpPr>
+        <p:spPr>
+          <a:xfrm>
+            <a:off x="502920" y="457200"/>
+            <a:ext cx="566928" cy="566928"/>
+          </a:xfrm>
+          <a:prstGeom prst="rect">
+            <a:avLst/>
+          </a:prstGeom>
+          <a:noFill/>
+          <a:ln/>
+        </p:spPr>
+        <p:txBody>
+          <a:bodyPr wrap="square" rtlCol="0" anchor="ctr"/>
+          <a:lstStyle/>
+          <a:p>
+            <a:pPr algn="ctr" indent="0" marL="0">
+              <a:buNone/>
+            </a:pPr>
+            <a:r>
+              <a:rPr lang="en-US" sz="2000" b="1" dirty="0">
+                <a:solidFill>
+                  <a:srgbClr val="FFFFFF"/>
+                </a:solidFill>
+                <a:latin typeface="Cambria" pitchFamily="34" charset="0"/>
+                <a:ea typeface="Cambria" pitchFamily="34" charset="-122"/>
+                <a:cs typeface="Cambria" pitchFamily="34" charset="-120"/>
+              </a:rPr>
+              <a:t>15</a:t>
+            </a:r>
+            <a:endParaRPr lang="en-US" sz="2000" dirty="0"/>
+          </a:p>
+        </p:txBody>
+      </p:sp>
+      <p:sp>
+        <p:nvSpPr>
+          <p:cNvPr id="4" name="Text 2"/>
+          <p:cNvSpPr/>
+          <p:nvPr/>
+        </p:nvSpPr>
+        <p:spPr>
+          <a:xfrm>
+            <a:off x="1234440" y="402336"/>
+            <a:ext cx="10424160" cy="713232"/>
+          </a:xfrm>
+          <a:prstGeom prst="rect">
+            <a:avLst/>
+          </a:prstGeom>
+          <a:noFill/>
+          <a:ln/>
+        </p:spPr>
+        <p:txBody>
+          <a:bodyPr wrap="square" rtlCol="0" anchor="ctr"/>
+          <a:lstStyle/>
+          <a:p>
+            <a:pPr algn="l" indent="0" marL="0">
+              <a:buNone/>
+            </a:pPr>
+            <a:r>
+              <a:rPr lang="en-US" sz="3000" b="1" dirty="0">
+                <a:solidFill>
+                  <a:srgbClr val="1E2761"/>
+                </a:solidFill>
+                <a:latin typeface="Cambria" pitchFamily="34" charset="0"/>
+                <a:ea typeface="Cambria" pitchFamily="34" charset="-122"/>
+                <a:cs typeface="Cambria" pitchFamily="34" charset="-120"/>
+              </a:rPr>
+              <a:t>Posología y administración</a:t>
+            </a:r>
+            <a:endParaRPr lang="en-US" sz="3000" dirty="0"/>
+          </a:p>
+        </p:txBody>
+      </p:sp>
+      <p:pic>
+        <p:nvPicPr>
+          <p:cNvPr id="5" name="Image 0" descr="/root/.claude/uploads/66fba22f-583e-557b-9ab9-bf088b6d1210/ec29a529-1000206767.jpg">    </p:cNvPr>
+          <p:cNvPicPr>
+            <a:picLocks noChangeAspect="1"/>
+          </p:cNvPicPr>
+          <p:nvPr/>
+        </p:nvPicPr>
+        <p:blipFill>
+          <a:blip r:embed="rId1"/>
+          <a:srcRect l="0" r="0" t="0" b="0"/>
+          <a:stretch/>
+        </p:blipFill>
+        <p:spPr>
+          <a:xfrm>
+            <a:off x="7772400" y="1463040"/>
+            <a:ext cx="3931920" cy="3749040"/>
+          </a:xfrm>
+          <a:prstGeom prst="rect">
+            <a:avLst/>
+          </a:prstGeom>
+          <a:effectLst>
+            <a:outerShdw sx="100000" sy="100000" kx="0" ky="0" algn="bl" rotWithShape="0" blurRad="114300" dist="38100" dir="5400000">
+              <a:srgbClr val="9AA6C2">
+                <a:alpha val="45000"/>
+              </a:srgbClr>
+            </a:outerShdw>
+          </a:effectLst>
+        </p:spPr>
+      </p:pic>
+      <p:sp>
+        <p:nvSpPr>
+          <p:cNvPr id="6" name="Shape 3"/>
+          <p:cNvSpPr/>
+          <p:nvPr/>
+        </p:nvSpPr>
+        <p:spPr>
+          <a:xfrm>
+            <a:off x="548640" y="1554480"/>
+            <a:ext cx="2331720" cy="621792"/>
+          </a:xfrm>
+          <a:prstGeom prst="rect">
+            <a:avLst/>
+          </a:prstGeom>
+          <a:solidFill>
+            <a:srgbClr val="1E2761"/>
+          </a:solidFill>
+          <a:ln w="12700">
+            <a:solidFill>
+              <a:srgbClr val="D9E2F5"/>
+            </a:solidFill>
+            <a:prstDash val="solid"/>
+          </a:ln>
+        </p:spPr>
+      </p:sp>
+      <p:sp>
+        <p:nvSpPr>
+          <p:cNvPr id="7" name="Text 4"/>
+          <p:cNvSpPr/>
+          <p:nvPr/>
+        </p:nvSpPr>
+        <p:spPr>
+          <a:xfrm>
+            <a:off x="621792" y="1554480"/>
+            <a:ext cx="2185416" cy="621792"/>
+          </a:xfrm>
+          <a:prstGeom prst="rect">
+            <a:avLst/>
+          </a:prstGeom>
+          <a:noFill/>
+          <a:ln/>
+        </p:spPr>
+        <p:txBody>
+          <a:bodyPr wrap="square" lIns="0" tIns="0" rIns="0" bIns="0" rtlCol="0" anchor="ctr"/>
+          <a:lstStyle/>
+          <a:p>
+            <a:pPr algn="l" indent="0" marL="0">
+              <a:buNone/>
+            </a:pPr>
+            <a:r>
+              <a:rPr lang="en-US" sz="1250" b="1" dirty="0">
+                <a:solidFill>
+                  <a:srgbClr val="FFFFFF"/>
+                </a:solidFill>
+                <a:latin typeface="Cambria" pitchFamily="34" charset="0"/>
+                <a:ea typeface="Cambria" pitchFamily="34" charset="-122"/>
+                <a:cs typeface="Cambria" pitchFamily="34" charset="-120"/>
+              </a:rPr>
+              <a:t>Indicación</a:t>
+            </a:r>
+            <a:endParaRPr lang="en-US" sz="1250" dirty="0"/>
+          </a:p>
+        </p:txBody>
+      </p:sp>
+      <p:sp>
+        <p:nvSpPr>
+          <p:cNvPr id="8" name="Shape 5"/>
+          <p:cNvSpPr/>
+          <p:nvPr/>
+        </p:nvSpPr>
+        <p:spPr>
+          <a:xfrm>
+            <a:off x="2880360" y="1554480"/>
+            <a:ext cx="1783080" cy="621792"/>
+          </a:xfrm>
+          <a:prstGeom prst="rect">
+            <a:avLst/>
+          </a:prstGeom>
+          <a:solidFill>
+            <a:srgbClr val="1E2761"/>
+          </a:solidFill>
+          <a:ln w="12700">
+            <a:solidFill>
+              <a:srgbClr val="D9E2F5"/>
+            </a:solidFill>
+            <a:prstDash val="solid"/>
+          </a:ln>
+        </p:spPr>
+      </p:sp>
+      <p:sp>
+        <p:nvSpPr>
+          <p:cNvPr id="9" name="Text 6"/>
+          <p:cNvSpPr/>
+          <p:nvPr/>
+        </p:nvSpPr>
+        <p:spPr>
+          <a:xfrm>
+            <a:off x="2953512" y="1554480"/>
+            <a:ext cx="1636776" cy="621792"/>
+          </a:xfrm>
+          <a:prstGeom prst="rect">
+            <a:avLst/>
+          </a:prstGeom>
+          <a:noFill/>
+          <a:ln/>
+        </p:spPr>
+        <p:txBody>
+          <a:bodyPr wrap="square" lIns="0" tIns="0" rIns="0" bIns="0" rtlCol="0" anchor="ctr"/>
+          <a:lstStyle/>
+          <a:p>
+            <a:pPr algn="ctr" indent="0" marL="0">
+              <a:buNone/>
+            </a:pPr>
+            <a:r>
+              <a:rPr lang="en-US" sz="1250" b="1" dirty="0">
+                <a:solidFill>
+                  <a:srgbClr val="FFFFFF"/>
+                </a:solidFill>
+                <a:latin typeface="Cambria" pitchFamily="34" charset="0"/>
+                <a:ea typeface="Cambria" pitchFamily="34" charset="-122"/>
+                <a:cs typeface="Cambria" pitchFamily="34" charset="-120"/>
+              </a:rPr>
+              <a:t>Inicio</a:t>
+            </a:r>
+            <a:endParaRPr lang="en-US" sz="1250" dirty="0"/>
+          </a:p>
+        </p:txBody>
+      </p:sp>
+      <p:sp>
+        <p:nvSpPr>
+          <p:cNvPr id="10" name="Shape 7"/>
+          <p:cNvSpPr/>
+          <p:nvPr/>
+        </p:nvSpPr>
+        <p:spPr>
+          <a:xfrm>
+            <a:off x="4663440" y="1554480"/>
+            <a:ext cx="1417320" cy="621792"/>
+          </a:xfrm>
+          <a:prstGeom prst="rect">
+            <a:avLst/>
+          </a:prstGeom>
+          <a:solidFill>
+            <a:srgbClr val="1E2761"/>
+          </a:solidFill>
+          <a:ln w="12700">
+            <a:solidFill>
+              <a:srgbClr val="D9E2F5"/>
+            </a:solidFill>
+            <a:prstDash val="solid"/>
+          </a:ln>
+        </p:spPr>
+      </p:sp>
+      <p:sp>
+        <p:nvSpPr>
+          <p:cNvPr id="11" name="Text 8"/>
+          <p:cNvSpPr/>
+          <p:nvPr/>
+        </p:nvSpPr>
+        <p:spPr>
+          <a:xfrm>
+            <a:off x="4736592" y="1554480"/>
+            <a:ext cx="1271016" cy="621792"/>
+          </a:xfrm>
+          <a:prstGeom prst="rect">
+            <a:avLst/>
+          </a:prstGeom>
+          <a:noFill/>
+          <a:ln/>
+        </p:spPr>
+        <p:txBody>
+          <a:bodyPr wrap="square" lIns="0" tIns="0" rIns="0" bIns="0" rtlCol="0" anchor="ctr"/>
+          <a:lstStyle/>
+          <a:p>
+            <a:pPr algn="ctr" indent="0" marL="0">
+              <a:buNone/>
+            </a:pPr>
+            <a:r>
+              <a:rPr lang="en-US" sz="1250" b="1" dirty="0">
+                <a:solidFill>
+                  <a:srgbClr val="FFFFFF"/>
+                </a:solidFill>
+                <a:latin typeface="Cambria" pitchFamily="34" charset="0"/>
+                <a:ea typeface="Cambria" pitchFamily="34" charset="-122"/>
+                <a:cs typeface="Cambria" pitchFamily="34" charset="-120"/>
+              </a:rPr>
+              <a:t>Objetivo</a:t>
+            </a:r>
+            <a:endParaRPr lang="en-US" sz="1250" dirty="0"/>
+          </a:p>
+        </p:txBody>
+      </p:sp>
+      <p:sp>
+        <p:nvSpPr>
+          <p:cNvPr id="12" name="Shape 9"/>
+          <p:cNvSpPr/>
+          <p:nvPr/>
+        </p:nvSpPr>
+        <p:spPr>
+          <a:xfrm>
+            <a:off x="6080760" y="1554480"/>
+            <a:ext cx="1188720" cy="621792"/>
+          </a:xfrm>
+          <a:prstGeom prst="rect">
+            <a:avLst/>
+          </a:prstGeom>
+          <a:solidFill>
+            <a:srgbClr val="1E2761"/>
+          </a:solidFill>
+          <a:ln w="12700">
+            <a:solidFill>
+              <a:srgbClr val="D9E2F5"/>
+            </a:solidFill>
+            <a:prstDash val="solid"/>
+          </a:ln>
+        </p:spPr>
+      </p:sp>
+      <p:sp>
+        <p:nvSpPr>
+          <p:cNvPr id="13" name="Text 10"/>
+          <p:cNvSpPr/>
+          <p:nvPr/>
+        </p:nvSpPr>
+        <p:spPr>
+          <a:xfrm>
+            <a:off x="6153912" y="1554480"/>
+            <a:ext cx="1042416" cy="621792"/>
+          </a:xfrm>
+          <a:prstGeom prst="rect">
+            <a:avLst/>
+          </a:prstGeom>
+          <a:noFill/>
+          <a:ln/>
+        </p:spPr>
+        <p:txBody>
+          <a:bodyPr wrap="square" lIns="0" tIns="0" rIns="0" bIns="0" rtlCol="0" anchor="ctr"/>
+          <a:lstStyle/>
+          <a:p>
+            <a:pPr algn="ctr" indent="0" marL="0">
+              <a:buNone/>
+            </a:pPr>
+            <a:r>
+              <a:rPr lang="en-US" sz="1250" b="1" dirty="0">
+                <a:solidFill>
+                  <a:srgbClr val="FFFFFF"/>
+                </a:solidFill>
+                <a:latin typeface="Cambria" pitchFamily="34" charset="0"/>
+                <a:ea typeface="Cambria" pitchFamily="34" charset="-122"/>
+                <a:cs typeface="Cambria" pitchFamily="34" charset="-120"/>
+              </a:rPr>
+              <a:t>Máx.</a:t>
+            </a:r>
+            <a:endParaRPr lang="en-US" sz="1250" dirty="0"/>
+          </a:p>
+        </p:txBody>
+      </p:sp>
+      <p:sp>
+        <p:nvSpPr>
+          <p:cNvPr id="14" name="Shape 11"/>
+          <p:cNvSpPr/>
+          <p:nvPr/>
+        </p:nvSpPr>
+        <p:spPr>
+          <a:xfrm>
+            <a:off x="548640" y="2176272"/>
+            <a:ext cx="2331720" cy="621792"/>
+          </a:xfrm>
+          <a:prstGeom prst="rect">
+            <a:avLst/>
+          </a:prstGeom>
+          <a:solidFill>
+            <a:srgbClr val="EEF3FC"/>
+          </a:solidFill>
+          <a:ln w="12700">
+            <a:solidFill>
+              <a:srgbClr val="D9E2F5"/>
+            </a:solidFill>
+            <a:prstDash val="solid"/>
+          </a:ln>
+        </p:spPr>
+      </p:sp>
+      <p:sp>
+        <p:nvSpPr>
+          <p:cNvPr id="15" name="Text 12"/>
+          <p:cNvSpPr/>
+          <p:nvPr/>
+        </p:nvSpPr>
+        <p:spPr>
+          <a:xfrm>
+            <a:off x="621792" y="2176272"/>
+            <a:ext cx="2185416" cy="621792"/>
+          </a:xfrm>
+          <a:prstGeom prst="rect">
+            <a:avLst/>
+          </a:prstGeom>
+          <a:noFill/>
+          <a:ln/>
+        </p:spPr>
+        <p:txBody>
+          <a:bodyPr wrap="square" lIns="0" tIns="0" rIns="0" bIns="0" rtlCol="0" anchor="ctr"/>
+          <a:lstStyle/>
+          <a:p>
+            <a:pPr algn="l" indent="0" marL="0">
+              <a:buNone/>
+            </a:pPr>
+            <a:r>
+              <a:rPr lang="en-US" sz="1250" b="1" dirty="0">
+                <a:solidFill>
+                  <a:srgbClr val="1B2138"/>
+                </a:solidFill>
+                <a:latin typeface="Calibri" pitchFamily="34" charset="0"/>
+                <a:ea typeface="Calibri" pitchFamily="34" charset="-122"/>
+                <a:cs typeface="Calibri" pitchFamily="34" charset="-120"/>
+              </a:rPr>
+              <a:t>Esquizofrenia</a:t>
+            </a:r>
+            <a:endParaRPr lang="en-US" sz="1250" dirty="0"/>
+          </a:p>
+        </p:txBody>
+      </p:sp>
+      <p:sp>
+        <p:nvSpPr>
+          <p:cNvPr id="16" name="Shape 13"/>
+          <p:cNvSpPr/>
+          <p:nvPr/>
+        </p:nvSpPr>
+        <p:spPr>
+          <a:xfrm>
+            <a:off x="2880360" y="2176272"/>
+            <a:ext cx="1783080" cy="621792"/>
+          </a:xfrm>
+          <a:prstGeom prst="rect">
+            <a:avLst/>
+          </a:prstGeom>
+          <a:solidFill>
+            <a:srgbClr val="EEF3FC"/>
+          </a:solidFill>
+          <a:ln w="12700">
+            <a:solidFill>
+              <a:srgbClr val="D9E2F5"/>
+            </a:solidFill>
+            <a:prstDash val="solid"/>
+          </a:ln>
+        </p:spPr>
+      </p:sp>
+      <p:sp>
+        <p:nvSpPr>
+          <p:cNvPr id="17" name="Text 14"/>
+          <p:cNvSpPr/>
+          <p:nvPr/>
+        </p:nvSpPr>
+        <p:spPr>
+          <a:xfrm>
+            <a:off x="2953512" y="2176272"/>
+            <a:ext cx="1636776" cy="621792"/>
+          </a:xfrm>
+          <a:prstGeom prst="rect">
+            <a:avLst/>
+          </a:prstGeom>
+          <a:noFill/>
+          <a:ln/>
+        </p:spPr>
+        <p:txBody>
+          <a:bodyPr wrap="square" lIns="0" tIns="0" rIns="0" bIns="0" rtlCol="0" anchor="ctr"/>
+          <a:lstStyle/>
+          <a:p>
+            <a:pPr algn="ctr" indent="0" marL="0">
+              <a:buNone/>
+            </a:pPr>
+            <a:r>
+              <a:rPr lang="en-US" sz="1250" dirty="0">
+                <a:solidFill>
+                  <a:srgbClr val="1B2138"/>
+                </a:solidFill>
+                <a:latin typeface="Calibri" pitchFamily="34" charset="0"/>
+                <a:ea typeface="Calibri" pitchFamily="34" charset="-122"/>
+                <a:cs typeface="Calibri" pitchFamily="34" charset="-120"/>
+              </a:rPr>
+              <a:t>1 mg (días 1–4)</a:t>
+            </a:r>
+            <a:endParaRPr lang="en-US" sz="1250" dirty="0"/>
+          </a:p>
+        </p:txBody>
+      </p:sp>
+      <p:sp>
+        <p:nvSpPr>
+          <p:cNvPr id="18" name="Shape 15"/>
+          <p:cNvSpPr/>
+          <p:nvPr/>
+        </p:nvSpPr>
+        <p:spPr>
+          <a:xfrm>
+            <a:off x="4663440" y="2176272"/>
+            <a:ext cx="1417320" cy="621792"/>
+          </a:xfrm>
+          <a:prstGeom prst="rect">
+            <a:avLst/>
+          </a:prstGeom>
+          <a:solidFill>
+            <a:srgbClr val="EEF3FC"/>
+          </a:solidFill>
+          <a:ln w="12700">
+            <a:solidFill>
+              <a:srgbClr val="D9E2F5"/>
+            </a:solidFill>
+            <a:prstDash val="solid"/>
+          </a:ln>
+        </p:spPr>
+      </p:sp>
+      <p:sp>
+        <p:nvSpPr>
+          <p:cNvPr id="19" name="Text 16"/>
+          <p:cNvSpPr/>
+          <p:nvPr/>
+        </p:nvSpPr>
+        <p:spPr>
+          <a:xfrm>
+            <a:off x="4736592" y="2176272"/>
+            <a:ext cx="1271016" cy="621792"/>
+          </a:xfrm>
+          <a:prstGeom prst="rect">
+            <a:avLst/>
+          </a:prstGeom>
+          <a:noFill/>
+          <a:ln/>
+        </p:spPr>
+        <p:txBody>
+          <a:bodyPr wrap="square" lIns="0" tIns="0" rIns="0" bIns="0" rtlCol="0" anchor="ctr"/>
+          <a:lstStyle/>
+          <a:p>
+            <a:pPr algn="ctr" indent="0" marL="0">
+              <a:buNone/>
+            </a:pPr>
+            <a:r>
+              <a:rPr lang="en-US" sz="1250" dirty="0">
+                <a:solidFill>
+                  <a:srgbClr val="1B2138"/>
+                </a:solidFill>
+                <a:latin typeface="Calibri" pitchFamily="34" charset="0"/>
+                <a:ea typeface="Calibri" pitchFamily="34" charset="-122"/>
+                <a:cs typeface="Calibri" pitchFamily="34" charset="-120"/>
+              </a:rPr>
+              <a:t>2–4 mg</a:t>
+            </a:r>
+            <a:endParaRPr lang="en-US" sz="1250" dirty="0"/>
+          </a:p>
+        </p:txBody>
+      </p:sp>
+      <p:sp>
+        <p:nvSpPr>
+          <p:cNvPr id="20" name="Shape 17"/>
+          <p:cNvSpPr/>
+          <p:nvPr/>
+        </p:nvSpPr>
+        <p:spPr>
+          <a:xfrm>
+            <a:off x="6080760" y="2176272"/>
+            <a:ext cx="1188720" cy="621792"/>
+          </a:xfrm>
+          <a:prstGeom prst="rect">
+            <a:avLst/>
+          </a:prstGeom>
+          <a:solidFill>
+            <a:srgbClr val="EEF3FC"/>
+          </a:solidFill>
+          <a:ln w="12700">
+            <a:solidFill>
+              <a:srgbClr val="D9E2F5"/>
+            </a:solidFill>
+            <a:prstDash val="solid"/>
+          </a:ln>
+        </p:spPr>
+      </p:sp>
+      <p:sp>
+        <p:nvSpPr>
+          <p:cNvPr id="21" name="Text 18"/>
+          <p:cNvSpPr/>
+          <p:nvPr/>
+        </p:nvSpPr>
+        <p:spPr>
+          <a:xfrm>
+            <a:off x="6153912" y="2176272"/>
+            <a:ext cx="1042416" cy="621792"/>
+          </a:xfrm>
+          <a:prstGeom prst="rect">
+            <a:avLst/>
+          </a:prstGeom>
+          <a:noFill/>
+          <a:ln/>
+        </p:spPr>
+        <p:txBody>
+          <a:bodyPr wrap="square" lIns="0" tIns="0" rIns="0" bIns="0" rtlCol="0" anchor="ctr"/>
+          <a:lstStyle/>
+          <a:p>
+            <a:pPr algn="ctr" indent="0" marL="0">
+              <a:buNone/>
+            </a:pPr>
+            <a:r>
+              <a:rPr lang="en-US" sz="1250" dirty="0">
+                <a:solidFill>
+                  <a:srgbClr val="1B2138"/>
+                </a:solidFill>
+                <a:latin typeface="Calibri" pitchFamily="34" charset="0"/>
+                <a:ea typeface="Calibri" pitchFamily="34" charset="-122"/>
+                <a:cs typeface="Calibri" pitchFamily="34" charset="-120"/>
+              </a:rPr>
+              <a:t>4 mg</a:t>
+            </a:r>
+            <a:endParaRPr lang="en-US" sz="1250" dirty="0"/>
+          </a:p>
+        </p:txBody>
+      </p:sp>
+      <p:sp>
+        <p:nvSpPr>
+          <p:cNvPr id="22" name="Shape 19"/>
+          <p:cNvSpPr/>
+          <p:nvPr/>
+        </p:nvSpPr>
+        <p:spPr>
+          <a:xfrm>
+            <a:off x="548640" y="2798064"/>
+            <a:ext cx="2331720" cy="621792"/>
+          </a:xfrm>
+          <a:prstGeom prst="rect">
+            <a:avLst/>
+          </a:prstGeom>
+          <a:solidFill>
+            <a:srgbClr val="FFFFFF"/>
+          </a:solidFill>
+          <a:ln w="12700">
+            <a:solidFill>
+              <a:srgbClr val="D9E2F5"/>
+            </a:solidFill>
+            <a:prstDash val="solid"/>
+          </a:ln>
+        </p:spPr>
+      </p:sp>
+      <p:sp>
+        <p:nvSpPr>
+          <p:cNvPr id="23" name="Text 20"/>
+          <p:cNvSpPr/>
+          <p:nvPr/>
+        </p:nvSpPr>
+        <p:spPr>
+          <a:xfrm>
+            <a:off x="621792" y="2798064"/>
+            <a:ext cx="2185416" cy="621792"/>
+          </a:xfrm>
+          <a:prstGeom prst="rect">
+            <a:avLst/>
+          </a:prstGeom>
+          <a:noFill/>
+          <a:ln/>
+        </p:spPr>
+        <p:txBody>
+          <a:bodyPr wrap="square" lIns="0" tIns="0" rIns="0" bIns="0" rtlCol="0" anchor="ctr"/>
+          <a:lstStyle/>
+          <a:p>
+            <a:pPr algn="l" indent="0" marL="0">
+              <a:buNone/>
+            </a:pPr>
+            <a:r>
+              <a:rPr lang="en-US" sz="1250" b="1" dirty="0">
+                <a:solidFill>
+                  <a:srgbClr val="1B2138"/>
+                </a:solidFill>
+                <a:latin typeface="Calibri" pitchFamily="34" charset="0"/>
+                <a:ea typeface="Calibri" pitchFamily="34" charset="-122"/>
+                <a:cs typeface="Calibri" pitchFamily="34" charset="-120"/>
+              </a:rPr>
+              <a:t>TDM (adyuvante)</a:t>
+            </a:r>
+            <a:endParaRPr lang="en-US" sz="1250" dirty="0"/>
+          </a:p>
+        </p:txBody>
+      </p:sp>
+      <p:sp>
+        <p:nvSpPr>
+          <p:cNvPr id="24" name="Shape 21"/>
+          <p:cNvSpPr/>
+          <p:nvPr/>
+        </p:nvSpPr>
+        <p:spPr>
+          <a:xfrm>
+            <a:off x="2880360" y="2798064"/>
+            <a:ext cx="1783080" cy="621792"/>
+          </a:xfrm>
+          <a:prstGeom prst="rect">
+            <a:avLst/>
+          </a:prstGeom>
+          <a:solidFill>
+            <a:srgbClr val="FFFFFF"/>
+          </a:solidFill>
+          <a:ln w="12700">
+            <a:solidFill>
+              <a:srgbClr val="D9E2F5"/>
+            </a:solidFill>
+            <a:prstDash val="solid"/>
+          </a:ln>
+        </p:spPr>
+      </p:sp>
+      <p:sp>
+        <p:nvSpPr>
+          <p:cNvPr id="25" name="Text 22"/>
+          <p:cNvSpPr/>
+          <p:nvPr/>
+        </p:nvSpPr>
+        <p:spPr>
+          <a:xfrm>
+            <a:off x="2953512" y="2798064"/>
+            <a:ext cx="1636776" cy="621792"/>
+          </a:xfrm>
+          <a:prstGeom prst="rect">
+            <a:avLst/>
+          </a:prstGeom>
+          <a:noFill/>
+          <a:ln/>
+        </p:spPr>
+        <p:txBody>
+          <a:bodyPr wrap="square" lIns="0" tIns="0" rIns="0" bIns="0" rtlCol="0" anchor="ctr"/>
+          <a:lstStyle/>
+          <a:p>
+            <a:pPr algn="ctr" indent="0" marL="0">
+              <a:buNone/>
+            </a:pPr>
+            <a:r>
+              <a:rPr lang="en-US" sz="1250" dirty="0">
+                <a:solidFill>
+                  <a:srgbClr val="1B2138"/>
+                </a:solidFill>
+                <a:latin typeface="Calibri" pitchFamily="34" charset="0"/>
+                <a:ea typeface="Calibri" pitchFamily="34" charset="-122"/>
+                <a:cs typeface="Calibri" pitchFamily="34" charset="-120"/>
+              </a:rPr>
+              <a:t>0,5–1 mg</a:t>
+            </a:r>
+            <a:endParaRPr lang="en-US" sz="1250" dirty="0"/>
+          </a:p>
+        </p:txBody>
+      </p:sp>
+      <p:sp>
+        <p:nvSpPr>
+          <p:cNvPr id="26" name="Shape 23"/>
+          <p:cNvSpPr/>
+          <p:nvPr/>
+        </p:nvSpPr>
+        <p:spPr>
+          <a:xfrm>
+            <a:off x="4663440" y="2798064"/>
+            <a:ext cx="1417320" cy="621792"/>
+          </a:xfrm>
+          <a:prstGeom prst="rect">
+            <a:avLst/>
+          </a:prstGeom>
+          <a:solidFill>
+            <a:srgbClr val="FFFFFF"/>
+          </a:solidFill>
+          <a:ln w="12700">
+            <a:solidFill>
+              <a:srgbClr val="D9E2F5"/>
+            </a:solidFill>
+            <a:prstDash val="solid"/>
+          </a:ln>
+        </p:spPr>
+      </p:sp>
+      <p:sp>
+        <p:nvSpPr>
+          <p:cNvPr id="27" name="Text 24"/>
+          <p:cNvSpPr/>
+          <p:nvPr/>
+        </p:nvSpPr>
+        <p:spPr>
+          <a:xfrm>
+            <a:off x="4736592" y="2798064"/>
+            <a:ext cx="1271016" cy="621792"/>
+          </a:xfrm>
+          <a:prstGeom prst="rect">
+            <a:avLst/>
+          </a:prstGeom>
+          <a:noFill/>
+          <a:ln/>
+        </p:spPr>
+        <p:txBody>
+          <a:bodyPr wrap="square" lIns="0" tIns="0" rIns="0" bIns="0" rtlCol="0" anchor="ctr"/>
+          <a:lstStyle/>
+          <a:p>
+            <a:pPr algn="ctr" indent="0" marL="0">
+              <a:buNone/>
+            </a:pPr>
+            <a:r>
+              <a:rPr lang="en-US" sz="1250" dirty="0">
+                <a:solidFill>
+                  <a:srgbClr val="1B2138"/>
+                </a:solidFill>
+                <a:latin typeface="Calibri" pitchFamily="34" charset="0"/>
+                <a:ea typeface="Calibri" pitchFamily="34" charset="-122"/>
+                <a:cs typeface="Calibri" pitchFamily="34" charset="-120"/>
+              </a:rPr>
+              <a:t>2 mg</a:t>
+            </a:r>
+            <a:endParaRPr lang="en-US" sz="1250" dirty="0"/>
+          </a:p>
+        </p:txBody>
+      </p:sp>
+      <p:sp>
+        <p:nvSpPr>
+          <p:cNvPr id="28" name="Shape 25"/>
+          <p:cNvSpPr/>
+          <p:nvPr/>
+        </p:nvSpPr>
+        <p:spPr>
+          <a:xfrm>
+            <a:off x="6080760" y="2798064"/>
+            <a:ext cx="1188720" cy="621792"/>
+          </a:xfrm>
+          <a:prstGeom prst="rect">
+            <a:avLst/>
+          </a:prstGeom>
+          <a:solidFill>
+            <a:srgbClr val="FFFFFF"/>
+          </a:solidFill>
+          <a:ln w="12700">
+            <a:solidFill>
+              <a:srgbClr val="D9E2F5"/>
+            </a:solidFill>
+            <a:prstDash val="solid"/>
+          </a:ln>
+        </p:spPr>
+      </p:sp>
+      <p:sp>
+        <p:nvSpPr>
+          <p:cNvPr id="29" name="Text 26"/>
+          <p:cNvSpPr/>
+          <p:nvPr/>
+        </p:nvSpPr>
+        <p:spPr>
+          <a:xfrm>
+            <a:off x="6153912" y="2798064"/>
+            <a:ext cx="1042416" cy="621792"/>
+          </a:xfrm>
+          <a:prstGeom prst="rect">
+            <a:avLst/>
+          </a:prstGeom>
+          <a:noFill/>
+          <a:ln/>
+        </p:spPr>
+        <p:txBody>
+          <a:bodyPr wrap="square" lIns="0" tIns="0" rIns="0" bIns="0" rtlCol="0" anchor="ctr"/>
+          <a:lstStyle/>
+          <a:p>
+            <a:pPr algn="ctr" indent="0" marL="0">
+              <a:buNone/>
+            </a:pPr>
+            <a:r>
+              <a:rPr lang="en-US" sz="1250" dirty="0">
+                <a:solidFill>
+                  <a:srgbClr val="1B2138"/>
+                </a:solidFill>
+                <a:latin typeface="Calibri" pitchFamily="34" charset="0"/>
+                <a:ea typeface="Calibri" pitchFamily="34" charset="-122"/>
+                <a:cs typeface="Calibri" pitchFamily="34" charset="-120"/>
+              </a:rPr>
+              <a:t>3 mg</a:t>
+            </a:r>
+            <a:endParaRPr lang="en-US" sz="1250" dirty="0"/>
+          </a:p>
+        </p:txBody>
+      </p:sp>
+      <p:sp>
+        <p:nvSpPr>
+          <p:cNvPr id="30" name="Shape 27"/>
+          <p:cNvSpPr/>
+          <p:nvPr/>
+        </p:nvSpPr>
+        <p:spPr>
+          <a:xfrm>
+            <a:off x="548640" y="3419856"/>
+            <a:ext cx="2331720" cy="621792"/>
+          </a:xfrm>
+          <a:prstGeom prst="rect">
+            <a:avLst/>
+          </a:prstGeom>
+          <a:solidFill>
+            <a:srgbClr val="EEF3FC"/>
+          </a:solidFill>
+          <a:ln w="12700">
+            <a:solidFill>
+              <a:srgbClr val="D9E2F5"/>
+            </a:solidFill>
+            <a:prstDash val="solid"/>
+          </a:ln>
+        </p:spPr>
+      </p:sp>
+      <p:sp>
+        <p:nvSpPr>
+          <p:cNvPr id="31" name="Text 28"/>
+          <p:cNvSpPr/>
+          <p:nvPr/>
+        </p:nvSpPr>
+        <p:spPr>
+          <a:xfrm>
+            <a:off x="621792" y="3419856"/>
+            <a:ext cx="2185416" cy="621792"/>
+          </a:xfrm>
+          <a:prstGeom prst="rect">
+            <a:avLst/>
+          </a:prstGeom>
+          <a:noFill/>
+          <a:ln/>
+        </p:spPr>
+        <p:txBody>
+          <a:bodyPr wrap="square" lIns="0" tIns="0" rIns="0" bIns="0" rtlCol="0" anchor="ctr"/>
+          <a:lstStyle/>
+          <a:p>
+            <a:pPr algn="l" indent="0" marL="0">
+              <a:buNone/>
+            </a:pPr>
+            <a:r>
+              <a:rPr lang="en-US" sz="1250" b="1" dirty="0">
+                <a:solidFill>
+                  <a:srgbClr val="1B2138"/>
+                </a:solidFill>
+                <a:latin typeface="Calibri" pitchFamily="34" charset="0"/>
+                <a:ea typeface="Calibri" pitchFamily="34" charset="-122"/>
+                <a:cs typeface="Calibri" pitchFamily="34" charset="-120"/>
+              </a:rPr>
+              <a:t>Agitación/Alzheimer</a:t>
+            </a:r>
+            <a:endParaRPr lang="en-US" sz="1250" dirty="0"/>
+          </a:p>
+        </p:txBody>
+      </p:sp>
+      <p:sp>
+        <p:nvSpPr>
+          <p:cNvPr id="32" name="Shape 29"/>
+          <p:cNvSpPr/>
+          <p:nvPr/>
+        </p:nvSpPr>
+        <p:spPr>
+          <a:xfrm>
+            <a:off x="2880360" y="3419856"/>
+            <a:ext cx="1783080" cy="621792"/>
+          </a:xfrm>
+          <a:prstGeom prst="rect">
+            <a:avLst/>
+          </a:prstGeom>
+          <a:solidFill>
+            <a:srgbClr val="EEF3FC"/>
+          </a:solidFill>
+          <a:ln w="12700">
+            <a:solidFill>
+              <a:srgbClr val="D9E2F5"/>
+            </a:solidFill>
+            <a:prstDash val="solid"/>
+          </a:ln>
+        </p:spPr>
+      </p:sp>
+      <p:sp>
+        <p:nvSpPr>
+          <p:cNvPr id="33" name="Text 30"/>
+          <p:cNvSpPr/>
+          <p:nvPr/>
+        </p:nvSpPr>
+        <p:spPr>
+          <a:xfrm>
+            <a:off x="2953512" y="3419856"/>
+            <a:ext cx="1636776" cy="621792"/>
+          </a:xfrm>
+          <a:prstGeom prst="rect">
+            <a:avLst/>
+          </a:prstGeom>
+          <a:noFill/>
+          <a:ln/>
+        </p:spPr>
+        <p:txBody>
+          <a:bodyPr wrap="square" lIns="0" tIns="0" rIns="0" bIns="0" rtlCol="0" anchor="ctr"/>
+          <a:lstStyle/>
+          <a:p>
+            <a:pPr algn="ctr" indent="0" marL="0">
+              <a:buNone/>
+            </a:pPr>
+            <a:r>
+              <a:rPr lang="en-US" sz="1250" dirty="0">
+                <a:solidFill>
+                  <a:srgbClr val="1B2138"/>
+                </a:solidFill>
+                <a:latin typeface="Calibri" pitchFamily="34" charset="0"/>
+                <a:ea typeface="Calibri" pitchFamily="34" charset="-122"/>
+                <a:cs typeface="Calibri" pitchFamily="34" charset="-120"/>
+              </a:rPr>
+              <a:t>0,5 mg (1.ª sem.)</a:t>
+            </a:r>
+            <a:endParaRPr lang="en-US" sz="1250" dirty="0"/>
+          </a:p>
+        </p:txBody>
+      </p:sp>
+      <p:sp>
+        <p:nvSpPr>
+          <p:cNvPr id="34" name="Shape 31"/>
+          <p:cNvSpPr/>
+          <p:nvPr/>
+        </p:nvSpPr>
+        <p:spPr>
+          <a:xfrm>
+            <a:off x="4663440" y="3419856"/>
+            <a:ext cx="1417320" cy="621792"/>
+          </a:xfrm>
+          <a:prstGeom prst="rect">
+            <a:avLst/>
+          </a:prstGeom>
+          <a:solidFill>
+            <a:srgbClr val="EEF3FC"/>
+          </a:solidFill>
+          <a:ln w="12700">
+            <a:solidFill>
+              <a:srgbClr val="D9E2F5"/>
+            </a:solidFill>
+            <a:prstDash val="solid"/>
+          </a:ln>
+        </p:spPr>
+      </p:sp>
+      <p:sp>
+        <p:nvSpPr>
+          <p:cNvPr id="35" name="Text 32"/>
+          <p:cNvSpPr/>
+          <p:nvPr/>
+        </p:nvSpPr>
+        <p:spPr>
+          <a:xfrm>
+            <a:off x="4736592" y="3419856"/>
+            <a:ext cx="1271016" cy="621792"/>
+          </a:xfrm>
+          <a:prstGeom prst="rect">
+            <a:avLst/>
+          </a:prstGeom>
+          <a:noFill/>
+          <a:ln/>
+        </p:spPr>
+        <p:txBody>
+          <a:bodyPr wrap="square" lIns="0" tIns="0" rIns="0" bIns="0" rtlCol="0" anchor="ctr"/>
+          <a:lstStyle/>
+          <a:p>
+            <a:pPr algn="ctr" indent="0" marL="0">
+              <a:buNone/>
+            </a:pPr>
+            <a:r>
+              <a:rPr lang="en-US" sz="1250" dirty="0">
+                <a:solidFill>
+                  <a:srgbClr val="1B2138"/>
+                </a:solidFill>
+                <a:latin typeface="Calibri" pitchFamily="34" charset="0"/>
+                <a:ea typeface="Calibri" pitchFamily="34" charset="-122"/>
+                <a:cs typeface="Calibri" pitchFamily="34" charset="-120"/>
+              </a:rPr>
+              <a:t>2–3 mg</a:t>
+            </a:r>
+            <a:endParaRPr lang="en-US" sz="1250" dirty="0"/>
+          </a:p>
+        </p:txBody>
+      </p:sp>
+      <p:sp>
+        <p:nvSpPr>
+          <p:cNvPr id="36" name="Shape 33"/>
+          <p:cNvSpPr/>
+          <p:nvPr/>
+        </p:nvSpPr>
+        <p:spPr>
+          <a:xfrm>
+            <a:off x="6080760" y="3419856"/>
+            <a:ext cx="1188720" cy="621792"/>
+          </a:xfrm>
+          <a:prstGeom prst="rect">
+            <a:avLst/>
+          </a:prstGeom>
+          <a:solidFill>
+            <a:srgbClr val="EEF3FC"/>
+          </a:solidFill>
+          <a:ln w="12700">
+            <a:solidFill>
+              <a:srgbClr val="D9E2F5"/>
+            </a:solidFill>
+            <a:prstDash val="solid"/>
+          </a:ln>
+        </p:spPr>
+      </p:sp>
+      <p:sp>
+        <p:nvSpPr>
+          <p:cNvPr id="37" name="Text 34"/>
+          <p:cNvSpPr/>
+          <p:nvPr/>
+        </p:nvSpPr>
+        <p:spPr>
+          <a:xfrm>
+            <a:off x="6153912" y="3419856"/>
+            <a:ext cx="1042416" cy="621792"/>
+          </a:xfrm>
+          <a:prstGeom prst="rect">
+            <a:avLst/>
+          </a:prstGeom>
+          <a:noFill/>
+          <a:ln/>
+        </p:spPr>
+        <p:txBody>
+          <a:bodyPr wrap="square" lIns="0" tIns="0" rIns="0" bIns="0" rtlCol="0" anchor="ctr"/>
+          <a:lstStyle/>
+          <a:p>
+            <a:pPr algn="ctr" indent="0" marL="0">
+              <a:buNone/>
+            </a:pPr>
+            <a:r>
+              <a:rPr lang="en-US" sz="1250" dirty="0">
+                <a:solidFill>
+                  <a:srgbClr val="1B2138"/>
+                </a:solidFill>
+                <a:latin typeface="Calibri" pitchFamily="34" charset="0"/>
+                <a:ea typeface="Calibri" pitchFamily="34" charset="-122"/>
+                <a:cs typeface="Calibri" pitchFamily="34" charset="-120"/>
+              </a:rPr>
+              <a:t>3 mg</a:t>
+            </a:r>
+            <a:endParaRPr lang="en-US" sz="1250" dirty="0"/>
+          </a:p>
+        </p:txBody>
+      </p:sp>
+      <p:sp>
+        <p:nvSpPr>
+          <p:cNvPr id="38" name="Text 35"/>
+          <p:cNvSpPr/>
+          <p:nvPr/>
+        </p:nvSpPr>
+        <p:spPr>
+          <a:xfrm>
+            <a:off x="548640" y="4251960"/>
+            <a:ext cx="6949440" cy="1920240"/>
+          </a:xfrm>
+          <a:prstGeom prst="rect">
+            <a:avLst/>
+          </a:prstGeom>
+          <a:noFill/>
+          <a:ln/>
+        </p:spPr>
+        <p:txBody>
+          <a:bodyPr wrap="square" rtlCol="0" anchor="t"/>
+          <a:lstStyle/>
+          <a:p>
+            <a:pPr marL="177800" indent="-177800">
+              <a:spcAft>
+                <a:spcPts val="800"/>
+              </a:spcAft>
+              <a:buSzPct val="100000"/>
+              <a:buChar char="•"/>
+            </a:pPr>
+            <a:r>
+              <a:rPr lang="en-US" sz="1300" dirty="0">
+                <a:solidFill>
+                  <a:srgbClr val="1B2138"/>
+                </a:solidFill>
+                <a:latin typeface="Calibri" pitchFamily="34" charset="0"/>
+                <a:ea typeface="Calibri" pitchFamily="34" charset="-122"/>
+                <a:cs typeface="Calibri" pitchFamily="34" charset="-120"/>
+              </a:rPr>
+              <a:t>Una toma diaria, con o sin alimentos; titulación gradual para minimizar la acatisia.</a:t>
+            </a:r>
+            <a:endParaRPr lang="en-US" sz="1300" dirty="0"/>
+          </a:p>
+          <a:p>
+            <a:pPr marL="177800" indent="-177800">
+              <a:spcAft>
+                <a:spcPts val="800"/>
+              </a:spcAft>
+              <a:buSzPct val="100000"/>
+              <a:buChar char="•"/>
+            </a:pPr>
+            <a:r>
+              <a:rPr lang="en-US" sz="1300" b="1" dirty="0">
+                <a:solidFill>
+                  <a:srgbClr val="1B2138"/>
+                </a:solidFill>
+                <a:latin typeface="Calibri" pitchFamily="34" charset="0"/>
+                <a:ea typeface="Calibri" pitchFamily="34" charset="-122"/>
+                <a:cs typeface="Calibri" pitchFamily="34" charset="-120"/>
+              </a:rPr>
+              <a:t>Comprimidos: 0,25 · 0,5 · 1 · 2 · 3 · 4 mg.</a:t>
+            </a:r>
+            <a:endParaRPr lang="en-US" sz="1300" dirty="0"/>
+          </a:p>
+          <a:p>
+            <a:pPr marL="177800" indent="-177800">
+              <a:spcAft>
+                <a:spcPts val="800"/>
+              </a:spcAft>
+              <a:buSzPct val="100000"/>
+              <a:buChar char="•"/>
+            </a:pPr>
+            <a:r>
+              <a:rPr lang="en-US" sz="1300" dirty="0">
+                <a:solidFill>
+                  <a:srgbClr val="1B2138"/>
+                </a:solidFill>
+                <a:latin typeface="Calibri" pitchFamily="34" charset="0"/>
+                <a:ea typeface="Calibri" pitchFamily="34" charset="-122"/>
+                <a:cs typeface="Calibri" pitchFamily="34" charset="-120"/>
+              </a:rPr>
+              <a:t>Reducir dosis en insuficiencia hepática o renal moderada-grave.</a:t>
+            </a:r>
+            <a:endParaRPr lang="en-US" sz="1300" dirty="0"/>
+          </a:p>
+        </p:txBody>
+      </p:sp>
+    </p:spTree>
+  </p:cSld>
+  <p:clrMapOvr>
+    <a:masterClrMapping/>
+  </p:clrMapOvr>
+</p:sld>
+</file>
+
+<file path=ppt/slides/slide17.xml><?xml version="1.0" encoding="utf-8"?>
+<p:sld xmlns:a="http://schemas.openxmlformats.org/drawingml/2006/main" xmlns:r="http://schemas.openxmlformats.org/officeDocument/2006/relationships" xmlns:p="http://schemas.openxmlformats.org/presentationml/2006/main">
+  <p:cSld name="Slide 17">
     <p:bg>
       <p:bgPr>
         <a:solidFill>
@@ -7170,7 +7632,7 @@
                 <a:ea typeface="Cambria" pitchFamily="34" charset="-122"/>
                 <a:cs typeface="Cambria" pitchFamily="34" charset="-120"/>
               </a:rPr>
-              <a:t>15</a:t>
+              <a:t>16</a:t>
             </a:r>
             <a:endParaRPr lang="en-US" sz="2000" dirty="0"/>
           </a:p>
@@ -7380,9 +7842,9 @@
 </p:sld>
 </file>
 
-<file path=ppt/slides/slide17.xml><?xml version="1.0" encoding="utf-8"?>
+<file path=ppt/slides/slide18.xml><?xml version="1.0" encoding="utf-8"?>
 <p:sld xmlns:a="http://schemas.openxmlformats.org/drawingml/2006/main" xmlns:r="http://schemas.openxmlformats.org/officeDocument/2006/relationships" xmlns:p="http://schemas.openxmlformats.org/presentationml/2006/main">
-  <p:cSld name="Slide 17">
+  <p:cSld name="Slide 18">
     <p:bg>
       <p:bgPr>
         <a:solidFill>
@@ -7457,7 +7919,7 @@
                 <a:ea typeface="Cambria" pitchFamily="34" charset="-122"/>
                 <a:cs typeface="Cambria" pitchFamily="34" charset="-120"/>
               </a:rPr>
-              <a:t>16</a:t>
+              <a:t>17</a:t>
             </a:r>
             <a:endParaRPr lang="en-US" sz="2000" dirty="0"/>
           </a:p>
@@ -7943,9 +8405,9 @@
 </p:sld>
 </file>
 
-<file path=ppt/slides/slide18.xml><?xml version="1.0" encoding="utf-8"?>
+<file path=ppt/slides/slide19.xml><?xml version="1.0" encoding="utf-8"?>
 <p:sld xmlns:a="http://schemas.openxmlformats.org/drawingml/2006/main" xmlns:r="http://schemas.openxmlformats.org/officeDocument/2006/relationships" xmlns:p="http://schemas.openxmlformats.org/presentationml/2006/main">
-  <p:cSld name="Slide 18">
+  <p:cSld name="Slide 19">
     <p:bg>
       <p:bgPr>
         <a:solidFill>
@@ -8020,7 +8482,7 @@
                 <a:ea typeface="Cambria" pitchFamily="34" charset="-122"/>
                 <a:cs typeface="Cambria" pitchFamily="34" charset="-120"/>
               </a:rPr>
-              <a:t>17</a:t>
+              <a:t>18</a:t>
             </a:r>
             <a:endParaRPr lang="en-US" sz="2000" dirty="0"/>
           </a:p>
@@ -8298,730 +8760,6 @@
               <a:t>Contraindicado ante hipersensibilidad conocida al brexpiprazol.</a:t>
             </a:r>
             <a:endParaRPr lang="en-US" sz="1600" dirty="0"/>
-          </a:p>
-        </p:txBody>
-      </p:sp>
-    </p:spTree>
-  </p:cSld>
-  <p:clrMapOvr>
-    <a:masterClrMapping/>
-  </p:clrMapOvr>
-</p:sld>
-</file>
-
-<file path=ppt/slides/slide19.xml><?xml version="1.0" encoding="utf-8"?>
-<p:sld xmlns:a="http://schemas.openxmlformats.org/drawingml/2006/main" xmlns:r="http://schemas.openxmlformats.org/officeDocument/2006/relationships" xmlns:p="http://schemas.openxmlformats.org/presentationml/2006/main">
-  <p:cSld name="Slide 19">
-    <p:bg>
-      <p:bgPr>
-        <a:solidFill>
-          <a:srgbClr val="F4F7FD"/>
-        </a:solidFill>
-      </p:bgPr>
-    </p:bg>
-    <p:spTree>
-      <p:nvGrpSpPr>
-        <p:cNvPr id="1" name=""/>
-        <p:cNvGrpSpPr/>
-        <p:nvPr/>
-      </p:nvGrpSpPr>
-      <p:grpSpPr>
-        <a:xfrm>
-          <a:off x="0" y="0"/>
-          <a:ext cx="0" cy="0"/>
-          <a:chOff x="0" y="0"/>
-          <a:chExt cx="0" cy="0"/>
-        </a:xfrm>
-      </p:grpSpPr>
-      <p:sp>
-        <p:nvSpPr>
-          <p:cNvPr id="2" name="Shape 0"/>
-          <p:cNvSpPr/>
-          <p:nvPr/>
-        </p:nvSpPr>
-        <p:spPr>
-          <a:xfrm>
-            <a:off x="502920" y="457200"/>
-            <a:ext cx="566928" cy="566928"/>
-          </a:xfrm>
-          <a:prstGeom prst="ellipse">
-            <a:avLst/>
-          </a:prstGeom>
-          <a:solidFill>
-            <a:srgbClr val="3E5FC0"/>
-          </a:solidFill>
-          <a:ln/>
-        </p:spPr>
-      </p:sp>
-      <p:sp>
-        <p:nvSpPr>
-          <p:cNvPr id="3" name="Text 1"/>
-          <p:cNvSpPr/>
-          <p:nvPr/>
-        </p:nvSpPr>
-        <p:spPr>
-          <a:xfrm>
-            <a:off x="502920" y="457200"/>
-            <a:ext cx="566928" cy="566928"/>
-          </a:xfrm>
-          <a:prstGeom prst="rect">
-            <a:avLst/>
-          </a:prstGeom>
-          <a:noFill/>
-          <a:ln/>
-        </p:spPr>
-        <p:txBody>
-          <a:bodyPr wrap="square" rtlCol="0" anchor="ctr"/>
-          <a:lstStyle/>
-          <a:p>
-            <a:pPr algn="ctr" indent="0" marL="0">
-              <a:buNone/>
-            </a:pPr>
-            <a:r>
-              <a:rPr lang="en-US" sz="2000" b="1" dirty="0">
-                <a:solidFill>
-                  <a:srgbClr val="FFFFFF"/>
-                </a:solidFill>
-                <a:latin typeface="Cambria" pitchFamily="34" charset="0"/>
-                <a:ea typeface="Cambria" pitchFamily="34" charset="-122"/>
-                <a:cs typeface="Cambria" pitchFamily="34" charset="-120"/>
-              </a:rPr>
-              <a:t>18</a:t>
-            </a:r>
-            <a:endParaRPr lang="en-US" sz="2000" dirty="0"/>
-          </a:p>
-        </p:txBody>
-      </p:sp>
-      <p:sp>
-        <p:nvSpPr>
-          <p:cNvPr id="4" name="Text 2"/>
-          <p:cNvSpPr/>
-          <p:nvPr/>
-        </p:nvSpPr>
-        <p:spPr>
-          <a:xfrm>
-            <a:off x="1234440" y="402336"/>
-            <a:ext cx="10424160" cy="713232"/>
-          </a:xfrm>
-          <a:prstGeom prst="rect">
-            <a:avLst/>
-          </a:prstGeom>
-          <a:noFill/>
-          <a:ln/>
-        </p:spPr>
-        <p:txBody>
-          <a:bodyPr wrap="square" rtlCol="0" anchor="ctr"/>
-          <a:lstStyle/>
-          <a:p>
-            <a:pPr algn="l" indent="0" marL="0">
-              <a:buNone/>
-            </a:pPr>
-            <a:r>
-              <a:rPr lang="en-US" sz="3000" b="1" dirty="0">
-                <a:solidFill>
-                  <a:srgbClr val="1E2761"/>
-                </a:solidFill>
-                <a:latin typeface="Cambria" pitchFamily="34" charset="0"/>
-                <a:ea typeface="Cambria" pitchFamily="34" charset="-122"/>
-                <a:cs typeface="Cambria" pitchFamily="34" charset="-120"/>
-              </a:rPr>
-              <a:t>Interacciones y poblaciones especiales</a:t>
-            </a:r>
-            <a:endParaRPr lang="en-US" sz="3000" dirty="0"/>
-          </a:p>
-        </p:txBody>
-      </p:sp>
-      <p:sp>
-        <p:nvSpPr>
-          <p:cNvPr id="5" name="Text 3"/>
-          <p:cNvSpPr/>
-          <p:nvPr/>
-        </p:nvSpPr>
-        <p:spPr>
-          <a:xfrm>
-            <a:off x="548640" y="1417320"/>
-            <a:ext cx="5486400" cy="365760"/>
-          </a:xfrm>
-          <a:prstGeom prst="rect">
-            <a:avLst/>
-          </a:prstGeom>
-          <a:noFill/>
-          <a:ln/>
-        </p:spPr>
-        <p:txBody>
-          <a:bodyPr wrap="square" rtlCol="0" anchor="ctr"/>
-          <a:lstStyle/>
-          <a:p>
-            <a:pPr indent="0" marL="0">
-              <a:buNone/>
-            </a:pPr>
-            <a:r>
-              <a:rPr lang="en-US" sz="1600" b="1" dirty="0">
-                <a:solidFill>
-                  <a:srgbClr val="3E5FC0"/>
-                </a:solidFill>
-                <a:latin typeface="Cambria" pitchFamily="34" charset="0"/>
-                <a:ea typeface="Cambria" pitchFamily="34" charset="-122"/>
-                <a:cs typeface="Cambria" pitchFamily="34" charset="-120"/>
-              </a:rPr>
-              <a:t>Interacciones farmacológicas</a:t>
-            </a:r>
-            <a:endParaRPr lang="en-US" sz="1600" dirty="0"/>
-          </a:p>
-        </p:txBody>
-      </p:sp>
-      <p:sp>
-        <p:nvSpPr>
-          <p:cNvPr id="6" name="Shape 4"/>
-          <p:cNvSpPr/>
-          <p:nvPr/>
-        </p:nvSpPr>
-        <p:spPr>
-          <a:xfrm>
-            <a:off x="548640" y="1874520"/>
-            <a:ext cx="5440680" cy="1234440"/>
-          </a:xfrm>
-          <a:prstGeom prst="roundRect">
-            <a:avLst>
-              <a:gd name="adj" fmla="val 5926"/>
-            </a:avLst>
-          </a:prstGeom>
-          <a:solidFill>
-            <a:srgbClr val="FFFFFF"/>
-          </a:solidFill>
-          <a:ln w="12700">
-            <a:solidFill>
-              <a:srgbClr val="D9E2F5"/>
-            </a:solidFill>
-            <a:prstDash val="solid"/>
-          </a:ln>
-        </p:spPr>
-      </p:sp>
-      <p:sp>
-        <p:nvSpPr>
-          <p:cNvPr id="7" name="Text 5"/>
-          <p:cNvSpPr/>
-          <p:nvPr/>
-        </p:nvSpPr>
-        <p:spPr>
-          <a:xfrm>
-            <a:off x="749808" y="2020824"/>
-            <a:ext cx="5038344" cy="941832"/>
-          </a:xfrm>
-          <a:prstGeom prst="rect">
-            <a:avLst/>
-          </a:prstGeom>
-          <a:noFill/>
-          <a:ln/>
-        </p:spPr>
-        <p:txBody>
-          <a:bodyPr wrap="square" rtlCol="0" anchor="t"/>
-          <a:lstStyle/>
-          <a:p>
-            <a:pPr algn="l" indent="0" marL="0">
-              <a:spcAft>
-                <a:spcPts val="400"/>
-              </a:spcAft>
-              <a:buNone/>
-            </a:pPr>
-            <a:r>
-              <a:rPr lang="en-US" sz="1400" b="1" dirty="0">
-                <a:solidFill>
-                  <a:srgbClr val="1E2761"/>
-                </a:solidFill>
-                <a:latin typeface="Cambria" pitchFamily="34" charset="0"/>
-                <a:ea typeface="Cambria" pitchFamily="34" charset="-122"/>
-                <a:cs typeface="Cambria" pitchFamily="34" charset="-120"/>
-              </a:rPr>
-              <a:t>Inhibidores CYP3A4/CYP2D6</a:t>
-            </a:r>
-            <a:endParaRPr lang="en-US" sz="1400" dirty="0"/>
-          </a:p>
-          <a:p>
-            <a:pPr algn="l" indent="0" marL="0">
-              <a:buNone/>
-            </a:pPr>
-            <a:r>
-              <a:rPr lang="en-US" sz="1250" dirty="0">
-                <a:solidFill>
-                  <a:srgbClr val="1B2138"/>
-                </a:solidFill>
-                <a:latin typeface="Calibri" pitchFamily="34" charset="0"/>
-                <a:ea typeface="Calibri" pitchFamily="34" charset="-122"/>
-                <a:cs typeface="Calibri" pitchFamily="34" charset="-120"/>
-              </a:rPr>
-              <a:t>Reducir la dosis (a la mitad con inhibidores potentes).</a:t>
-            </a:r>
-            <a:endParaRPr lang="en-US" sz="1400" dirty="0"/>
-          </a:p>
-        </p:txBody>
-      </p:sp>
-      <p:sp>
-        <p:nvSpPr>
-          <p:cNvPr id="8" name="Shape 6"/>
-          <p:cNvSpPr/>
-          <p:nvPr/>
-        </p:nvSpPr>
-        <p:spPr>
-          <a:xfrm>
-            <a:off x="548640" y="3291840"/>
-            <a:ext cx="5440680" cy="1234440"/>
-          </a:xfrm>
-          <a:prstGeom prst="roundRect">
-            <a:avLst>
-              <a:gd name="adj" fmla="val 5926"/>
-            </a:avLst>
-          </a:prstGeom>
-          <a:solidFill>
-            <a:srgbClr val="FFFFFF"/>
-          </a:solidFill>
-          <a:ln w="12700">
-            <a:solidFill>
-              <a:srgbClr val="D9E2F5"/>
-            </a:solidFill>
-            <a:prstDash val="solid"/>
-          </a:ln>
-        </p:spPr>
-      </p:sp>
-      <p:sp>
-        <p:nvSpPr>
-          <p:cNvPr id="9" name="Text 7"/>
-          <p:cNvSpPr/>
-          <p:nvPr/>
-        </p:nvSpPr>
-        <p:spPr>
-          <a:xfrm>
-            <a:off x="749808" y="3438144"/>
-            <a:ext cx="5038344" cy="941832"/>
-          </a:xfrm>
-          <a:prstGeom prst="rect">
-            <a:avLst/>
-          </a:prstGeom>
-          <a:noFill/>
-          <a:ln/>
-        </p:spPr>
-        <p:txBody>
-          <a:bodyPr wrap="square" rtlCol="0" anchor="t"/>
-          <a:lstStyle/>
-          <a:p>
-            <a:pPr algn="l" indent="0" marL="0">
-              <a:spcAft>
-                <a:spcPts val="400"/>
-              </a:spcAft>
-              <a:buNone/>
-            </a:pPr>
-            <a:r>
-              <a:rPr lang="en-US" sz="1400" b="1" dirty="0">
-                <a:solidFill>
-                  <a:srgbClr val="1E2761"/>
-                </a:solidFill>
-                <a:latin typeface="Cambria" pitchFamily="34" charset="0"/>
-                <a:ea typeface="Cambria" pitchFamily="34" charset="-122"/>
-                <a:cs typeface="Cambria" pitchFamily="34" charset="-120"/>
-              </a:rPr>
-              <a:t>Inductores de CYP3A4</a:t>
-            </a:r>
-            <a:endParaRPr lang="en-US" sz="1400" dirty="0"/>
-          </a:p>
-          <a:p>
-            <a:pPr algn="l" indent="0" marL="0">
-              <a:buNone/>
-            </a:pPr>
-            <a:r>
-              <a:rPr lang="en-US" sz="1250" dirty="0">
-                <a:solidFill>
-                  <a:srgbClr val="1B2138"/>
-                </a:solidFill>
-                <a:latin typeface="Calibri" pitchFamily="34" charset="0"/>
-                <a:ea typeface="Calibri" pitchFamily="34" charset="-122"/>
-                <a:cs typeface="Calibri" pitchFamily="34" charset="-120"/>
-              </a:rPr>
-              <a:t>Aumentar la dosis (hasta duplicarla).</a:t>
-            </a:r>
-            <a:endParaRPr lang="en-US" sz="1400" dirty="0"/>
-          </a:p>
-        </p:txBody>
-      </p:sp>
-      <p:sp>
-        <p:nvSpPr>
-          <p:cNvPr id="10" name="Shape 8"/>
-          <p:cNvSpPr/>
-          <p:nvPr/>
-        </p:nvSpPr>
-        <p:spPr>
-          <a:xfrm>
-            <a:off x="548640" y="4709160"/>
-            <a:ext cx="5440680" cy="1234440"/>
-          </a:xfrm>
-          <a:prstGeom prst="roundRect">
-            <a:avLst>
-              <a:gd name="adj" fmla="val 5926"/>
-            </a:avLst>
-          </a:prstGeom>
-          <a:solidFill>
-            <a:srgbClr val="FFFFFF"/>
-          </a:solidFill>
-          <a:ln w="12700">
-            <a:solidFill>
-              <a:srgbClr val="D9E2F5"/>
-            </a:solidFill>
-            <a:prstDash val="solid"/>
-          </a:ln>
-        </p:spPr>
-      </p:sp>
-      <p:sp>
-        <p:nvSpPr>
-          <p:cNvPr id="11" name="Text 9"/>
-          <p:cNvSpPr/>
-          <p:nvPr/>
-        </p:nvSpPr>
-        <p:spPr>
-          <a:xfrm>
-            <a:off x="749808" y="4855464"/>
-            <a:ext cx="5038344" cy="941832"/>
-          </a:xfrm>
-          <a:prstGeom prst="rect">
-            <a:avLst/>
-          </a:prstGeom>
-          <a:noFill/>
-          <a:ln/>
-        </p:spPr>
-        <p:txBody>
-          <a:bodyPr wrap="square" rtlCol="0" anchor="t"/>
-          <a:lstStyle/>
-          <a:p>
-            <a:pPr algn="l" indent="0" marL="0">
-              <a:spcAft>
-                <a:spcPts val="400"/>
-              </a:spcAft>
-              <a:buNone/>
-            </a:pPr>
-            <a:r>
-              <a:rPr lang="en-US" sz="1400" b="1" dirty="0">
-                <a:solidFill>
-                  <a:srgbClr val="1E2761"/>
-                </a:solidFill>
-                <a:latin typeface="Cambria" pitchFamily="34" charset="0"/>
-                <a:ea typeface="Cambria" pitchFamily="34" charset="-122"/>
-                <a:cs typeface="Cambria" pitchFamily="34" charset="-120"/>
-              </a:rPr>
-              <a:t>Metabolizadores lentos CYP2D6</a:t>
-            </a:r>
-            <a:endParaRPr lang="en-US" sz="1400" dirty="0"/>
-          </a:p>
-          <a:p>
-            <a:pPr algn="l" indent="0" marL="0">
-              <a:buNone/>
-            </a:pPr>
-            <a:r>
-              <a:rPr lang="en-US" sz="1250" dirty="0">
-                <a:solidFill>
-                  <a:srgbClr val="1B2138"/>
-                </a:solidFill>
-                <a:latin typeface="Calibri" pitchFamily="34" charset="0"/>
-                <a:ea typeface="Calibri" pitchFamily="34" charset="-122"/>
-                <a:cs typeface="Calibri" pitchFamily="34" charset="-120"/>
-              </a:rPr>
-              <a:t>Reducir la dosis por mayor exposición.</a:t>
-            </a:r>
-            <a:endParaRPr lang="en-US" sz="1400" dirty="0"/>
-          </a:p>
-        </p:txBody>
-      </p:sp>
-      <p:sp>
-        <p:nvSpPr>
-          <p:cNvPr id="12" name="Text 10"/>
-          <p:cNvSpPr/>
-          <p:nvPr/>
-        </p:nvSpPr>
-        <p:spPr>
-          <a:xfrm>
-            <a:off x="6217920" y="1417320"/>
-            <a:ext cx="5486400" cy="365760"/>
-          </a:xfrm>
-          <a:prstGeom prst="rect">
-            <a:avLst/>
-          </a:prstGeom>
-          <a:noFill/>
-          <a:ln/>
-        </p:spPr>
-        <p:txBody>
-          <a:bodyPr wrap="square" rtlCol="0" anchor="ctr"/>
-          <a:lstStyle/>
-          <a:p>
-            <a:pPr indent="0" marL="0">
-              <a:buNone/>
-            </a:pPr>
-            <a:r>
-              <a:rPr lang="en-US" sz="1600" b="1" dirty="0">
-                <a:solidFill>
-                  <a:srgbClr val="3E5FC0"/>
-                </a:solidFill>
-                <a:latin typeface="Cambria" pitchFamily="34" charset="0"/>
-                <a:ea typeface="Cambria" pitchFamily="34" charset="-122"/>
-                <a:cs typeface="Cambria" pitchFamily="34" charset="-120"/>
-              </a:rPr>
-              <a:t>Poblaciones especiales</a:t>
-            </a:r>
-            <a:endParaRPr lang="en-US" sz="1600" dirty="0"/>
-          </a:p>
-        </p:txBody>
-      </p:sp>
-      <p:sp>
-        <p:nvSpPr>
-          <p:cNvPr id="13" name="Shape 11"/>
-          <p:cNvSpPr/>
-          <p:nvPr/>
-        </p:nvSpPr>
-        <p:spPr>
-          <a:xfrm>
-            <a:off x="6217920" y="1874520"/>
-            <a:ext cx="5440680" cy="1234440"/>
-          </a:xfrm>
-          <a:prstGeom prst="roundRect">
-            <a:avLst>
-              <a:gd name="adj" fmla="val 5926"/>
-            </a:avLst>
-          </a:prstGeom>
-          <a:solidFill>
-            <a:srgbClr val="FFFFFF"/>
-          </a:solidFill>
-          <a:ln w="12700">
-            <a:solidFill>
-              <a:srgbClr val="D9E2F5"/>
-            </a:solidFill>
-            <a:prstDash val="solid"/>
-          </a:ln>
-        </p:spPr>
-      </p:sp>
-      <p:sp>
-        <p:nvSpPr>
-          <p:cNvPr id="14" name="Text 12"/>
-          <p:cNvSpPr/>
-          <p:nvPr/>
-        </p:nvSpPr>
-        <p:spPr>
-          <a:xfrm>
-            <a:off x="6419088" y="2020824"/>
-            <a:ext cx="5038344" cy="941832"/>
-          </a:xfrm>
-          <a:prstGeom prst="rect">
-            <a:avLst/>
-          </a:prstGeom>
-          <a:noFill/>
-          <a:ln/>
-        </p:spPr>
-        <p:txBody>
-          <a:bodyPr wrap="square" rtlCol="0" anchor="t"/>
-          <a:lstStyle/>
-          <a:p>
-            <a:pPr algn="l" indent="0" marL="0">
-              <a:spcAft>
-                <a:spcPts val="400"/>
-              </a:spcAft>
-              <a:buNone/>
-            </a:pPr>
-            <a:r>
-              <a:rPr lang="en-US" sz="1400" b="1" dirty="0">
-                <a:solidFill>
-                  <a:srgbClr val="1E2761"/>
-                </a:solidFill>
-                <a:latin typeface="Cambria" pitchFamily="34" charset="0"/>
-                <a:ea typeface="Cambria" pitchFamily="34" charset="-122"/>
-                <a:cs typeface="Cambria" pitchFamily="34" charset="-120"/>
-              </a:rPr>
-              <a:t>Hepática/renal moderada-grave</a:t>
-            </a:r>
-            <a:endParaRPr lang="en-US" sz="1400" dirty="0"/>
-          </a:p>
-          <a:p>
-            <a:pPr algn="l" indent="0" marL="0">
-              <a:buNone/>
-            </a:pPr>
-            <a:r>
-              <a:rPr lang="en-US" sz="1250" dirty="0">
-                <a:solidFill>
-                  <a:srgbClr val="1B2138"/>
-                </a:solidFill>
-                <a:latin typeface="Calibri" pitchFamily="34" charset="0"/>
-                <a:ea typeface="Calibri" pitchFamily="34" charset="-122"/>
-                <a:cs typeface="Calibri" pitchFamily="34" charset="-120"/>
-              </a:rPr>
-              <a:t>Ajustar y reducir la dosis máxima.</a:t>
-            </a:r>
-            <a:endParaRPr lang="en-US" sz="1400" dirty="0"/>
-          </a:p>
-        </p:txBody>
-      </p:sp>
-      <p:sp>
-        <p:nvSpPr>
-          <p:cNvPr id="15" name="Shape 13"/>
-          <p:cNvSpPr/>
-          <p:nvPr/>
-        </p:nvSpPr>
-        <p:spPr>
-          <a:xfrm>
-            <a:off x="6217920" y="3291840"/>
-            <a:ext cx="5440680" cy="1234440"/>
-          </a:xfrm>
-          <a:prstGeom prst="roundRect">
-            <a:avLst>
-              <a:gd name="adj" fmla="val 5926"/>
-            </a:avLst>
-          </a:prstGeom>
-          <a:solidFill>
-            <a:srgbClr val="FFFFFF"/>
-          </a:solidFill>
-          <a:ln w="12700">
-            <a:solidFill>
-              <a:srgbClr val="D9E2F5"/>
-            </a:solidFill>
-            <a:prstDash val="solid"/>
-          </a:ln>
-        </p:spPr>
-      </p:sp>
-      <p:sp>
-        <p:nvSpPr>
-          <p:cNvPr id="16" name="Text 14"/>
-          <p:cNvSpPr/>
-          <p:nvPr/>
-        </p:nvSpPr>
-        <p:spPr>
-          <a:xfrm>
-            <a:off x="6419088" y="3438144"/>
-            <a:ext cx="5038344" cy="941832"/>
-          </a:xfrm>
-          <a:prstGeom prst="rect">
-            <a:avLst/>
-          </a:prstGeom>
-          <a:noFill/>
-          <a:ln/>
-        </p:spPr>
-        <p:txBody>
-          <a:bodyPr wrap="square" rtlCol="0" anchor="t"/>
-          <a:lstStyle/>
-          <a:p>
-            <a:pPr algn="l" indent="0" marL="0">
-              <a:spcAft>
-                <a:spcPts val="400"/>
-              </a:spcAft>
-              <a:buNone/>
-            </a:pPr>
-            <a:r>
-              <a:rPr lang="en-US" sz="1400" b="1" dirty="0">
-                <a:solidFill>
-                  <a:srgbClr val="1E2761"/>
-                </a:solidFill>
-                <a:latin typeface="Cambria" pitchFamily="34" charset="0"/>
-                <a:ea typeface="Cambria" pitchFamily="34" charset="-122"/>
-                <a:cs typeface="Cambria" pitchFamily="34" charset="-120"/>
-              </a:rPr>
-              <a:t>Embarazo y lactancia</a:t>
-            </a:r>
-            <a:endParaRPr lang="en-US" sz="1400" dirty="0"/>
-          </a:p>
-          <a:p>
-            <a:pPr algn="l" indent="0" marL="0">
-              <a:buNone/>
-            </a:pPr>
-            <a:r>
-              <a:rPr lang="en-US" sz="1250" dirty="0">
-                <a:solidFill>
-                  <a:srgbClr val="1B2138"/>
-                </a:solidFill>
-                <a:latin typeface="Calibri" pitchFamily="34" charset="0"/>
-                <a:ea typeface="Calibri" pitchFamily="34" charset="-122"/>
-                <a:cs typeface="Calibri" pitchFamily="34" charset="-120"/>
-              </a:rPr>
-              <a:t>Valorar riesgo-beneficio; datos limitados.</a:t>
-            </a:r>
-            <a:endParaRPr lang="en-US" sz="1400" dirty="0"/>
-          </a:p>
-        </p:txBody>
-      </p:sp>
-      <p:sp>
-        <p:nvSpPr>
-          <p:cNvPr id="17" name="Shape 15"/>
-          <p:cNvSpPr/>
-          <p:nvPr/>
-        </p:nvSpPr>
-        <p:spPr>
-          <a:xfrm>
-            <a:off x="6217920" y="4709160"/>
-            <a:ext cx="5440680" cy="1234440"/>
-          </a:xfrm>
-          <a:prstGeom prst="roundRect">
-            <a:avLst>
-              <a:gd name="adj" fmla="val 5926"/>
-            </a:avLst>
-          </a:prstGeom>
-          <a:solidFill>
-            <a:srgbClr val="FFFFFF"/>
-          </a:solidFill>
-          <a:ln w="12700">
-            <a:solidFill>
-              <a:srgbClr val="D9E2F5"/>
-            </a:solidFill>
-            <a:prstDash val="solid"/>
-          </a:ln>
-        </p:spPr>
-      </p:sp>
-      <p:sp>
-        <p:nvSpPr>
-          <p:cNvPr id="18" name="Text 16"/>
-          <p:cNvSpPr/>
-          <p:nvPr/>
-        </p:nvSpPr>
-        <p:spPr>
-          <a:xfrm>
-            <a:off x="6419088" y="4855464"/>
-            <a:ext cx="5038344" cy="941832"/>
-          </a:xfrm>
-          <a:prstGeom prst="rect">
-            <a:avLst/>
-          </a:prstGeom>
-          <a:noFill/>
-          <a:ln/>
-        </p:spPr>
-        <p:txBody>
-          <a:bodyPr wrap="square" rtlCol="0" anchor="t"/>
-          <a:lstStyle/>
-          <a:p>
-            <a:pPr algn="l" indent="0" marL="0">
-              <a:spcAft>
-                <a:spcPts val="400"/>
-              </a:spcAft>
-              <a:buNone/>
-            </a:pPr>
-            <a:r>
-              <a:rPr lang="en-US" sz="1400" b="1" dirty="0">
-                <a:solidFill>
-                  <a:srgbClr val="1E2761"/>
-                </a:solidFill>
-                <a:latin typeface="Cambria" pitchFamily="34" charset="0"/>
-                <a:ea typeface="Cambria" pitchFamily="34" charset="-122"/>
-                <a:cs typeface="Cambria" pitchFamily="34" charset="-120"/>
-              </a:rPr>
-              <a:t>Ancianos</a:t>
-            </a:r>
-            <a:endParaRPr lang="en-US" sz="1400" dirty="0"/>
-          </a:p>
-          <a:p>
-            <a:pPr algn="l" indent="0" marL="0">
-              <a:buNone/>
-            </a:pPr>
-            <a:r>
-              <a:rPr lang="en-US" sz="1250" dirty="0">
-                <a:solidFill>
-                  <a:srgbClr val="1B2138"/>
-                </a:solidFill>
-                <a:latin typeface="Calibri" pitchFamily="34" charset="0"/>
-                <a:ea typeface="Calibri" pitchFamily="34" charset="-122"/>
-                <a:cs typeface="Calibri" pitchFamily="34" charset="-120"/>
-              </a:rPr>
-              <a:t>Iniciar bajo y titular con precaución.</a:t>
-            </a:r>
-            <a:endParaRPr lang="en-US" sz="1400" dirty="0"/>
           </a:p>
         </p:txBody>
       </p:sp>
@@ -9747,6 +9485,730 @@
     <p:bg>
       <p:bgPr>
         <a:solidFill>
+          <a:srgbClr val="F4F7FD"/>
+        </a:solidFill>
+      </p:bgPr>
+    </p:bg>
+    <p:spTree>
+      <p:nvGrpSpPr>
+        <p:cNvPr id="1" name=""/>
+        <p:cNvGrpSpPr/>
+        <p:nvPr/>
+      </p:nvGrpSpPr>
+      <p:grpSpPr>
+        <a:xfrm>
+          <a:off x="0" y="0"/>
+          <a:ext cx="0" cy="0"/>
+          <a:chOff x="0" y="0"/>
+          <a:chExt cx="0" cy="0"/>
+        </a:xfrm>
+      </p:grpSpPr>
+      <p:sp>
+        <p:nvSpPr>
+          <p:cNvPr id="2" name="Shape 0"/>
+          <p:cNvSpPr/>
+          <p:nvPr/>
+        </p:nvSpPr>
+        <p:spPr>
+          <a:xfrm>
+            <a:off x="502920" y="457200"/>
+            <a:ext cx="566928" cy="566928"/>
+          </a:xfrm>
+          <a:prstGeom prst="ellipse">
+            <a:avLst/>
+          </a:prstGeom>
+          <a:solidFill>
+            <a:srgbClr val="3E5FC0"/>
+          </a:solidFill>
+          <a:ln/>
+        </p:spPr>
+      </p:sp>
+      <p:sp>
+        <p:nvSpPr>
+          <p:cNvPr id="3" name="Text 1"/>
+          <p:cNvSpPr/>
+          <p:nvPr/>
+        </p:nvSpPr>
+        <p:spPr>
+          <a:xfrm>
+            <a:off x="502920" y="457200"/>
+            <a:ext cx="566928" cy="566928"/>
+          </a:xfrm>
+          <a:prstGeom prst="rect">
+            <a:avLst/>
+          </a:prstGeom>
+          <a:noFill/>
+          <a:ln/>
+        </p:spPr>
+        <p:txBody>
+          <a:bodyPr wrap="square" rtlCol="0" anchor="ctr"/>
+          <a:lstStyle/>
+          <a:p>
+            <a:pPr algn="ctr" indent="0" marL="0">
+              <a:buNone/>
+            </a:pPr>
+            <a:r>
+              <a:rPr lang="en-US" sz="2000" b="1" dirty="0">
+                <a:solidFill>
+                  <a:srgbClr val="FFFFFF"/>
+                </a:solidFill>
+                <a:latin typeface="Cambria" pitchFamily="34" charset="0"/>
+                <a:ea typeface="Cambria" pitchFamily="34" charset="-122"/>
+                <a:cs typeface="Cambria" pitchFamily="34" charset="-120"/>
+              </a:rPr>
+              <a:t>19</a:t>
+            </a:r>
+            <a:endParaRPr lang="en-US" sz="2000" dirty="0"/>
+          </a:p>
+        </p:txBody>
+      </p:sp>
+      <p:sp>
+        <p:nvSpPr>
+          <p:cNvPr id="4" name="Text 2"/>
+          <p:cNvSpPr/>
+          <p:nvPr/>
+        </p:nvSpPr>
+        <p:spPr>
+          <a:xfrm>
+            <a:off x="1234440" y="402336"/>
+            <a:ext cx="10424160" cy="713232"/>
+          </a:xfrm>
+          <a:prstGeom prst="rect">
+            <a:avLst/>
+          </a:prstGeom>
+          <a:noFill/>
+          <a:ln/>
+        </p:spPr>
+        <p:txBody>
+          <a:bodyPr wrap="square" rtlCol="0" anchor="ctr"/>
+          <a:lstStyle/>
+          <a:p>
+            <a:pPr algn="l" indent="0" marL="0">
+              <a:buNone/>
+            </a:pPr>
+            <a:r>
+              <a:rPr lang="en-US" sz="3000" b="1" dirty="0">
+                <a:solidFill>
+                  <a:srgbClr val="1E2761"/>
+                </a:solidFill>
+                <a:latin typeface="Cambria" pitchFamily="34" charset="0"/>
+                <a:ea typeface="Cambria" pitchFamily="34" charset="-122"/>
+                <a:cs typeface="Cambria" pitchFamily="34" charset="-120"/>
+              </a:rPr>
+              <a:t>Interacciones y poblaciones especiales</a:t>
+            </a:r>
+            <a:endParaRPr lang="en-US" sz="3000" dirty="0"/>
+          </a:p>
+        </p:txBody>
+      </p:sp>
+      <p:sp>
+        <p:nvSpPr>
+          <p:cNvPr id="5" name="Text 3"/>
+          <p:cNvSpPr/>
+          <p:nvPr/>
+        </p:nvSpPr>
+        <p:spPr>
+          <a:xfrm>
+            <a:off x="548640" y="1417320"/>
+            <a:ext cx="5486400" cy="365760"/>
+          </a:xfrm>
+          <a:prstGeom prst="rect">
+            <a:avLst/>
+          </a:prstGeom>
+          <a:noFill/>
+          <a:ln/>
+        </p:spPr>
+        <p:txBody>
+          <a:bodyPr wrap="square" rtlCol="0" anchor="ctr"/>
+          <a:lstStyle/>
+          <a:p>
+            <a:pPr indent="0" marL="0">
+              <a:buNone/>
+            </a:pPr>
+            <a:r>
+              <a:rPr lang="en-US" sz="1600" b="1" dirty="0">
+                <a:solidFill>
+                  <a:srgbClr val="3E5FC0"/>
+                </a:solidFill>
+                <a:latin typeface="Cambria" pitchFamily="34" charset="0"/>
+                <a:ea typeface="Cambria" pitchFamily="34" charset="-122"/>
+                <a:cs typeface="Cambria" pitchFamily="34" charset="-120"/>
+              </a:rPr>
+              <a:t>Interacciones farmacológicas</a:t>
+            </a:r>
+            <a:endParaRPr lang="en-US" sz="1600" dirty="0"/>
+          </a:p>
+        </p:txBody>
+      </p:sp>
+      <p:sp>
+        <p:nvSpPr>
+          <p:cNvPr id="6" name="Shape 4"/>
+          <p:cNvSpPr/>
+          <p:nvPr/>
+        </p:nvSpPr>
+        <p:spPr>
+          <a:xfrm>
+            <a:off x="548640" y="1874520"/>
+            <a:ext cx="5440680" cy="1234440"/>
+          </a:xfrm>
+          <a:prstGeom prst="roundRect">
+            <a:avLst>
+              <a:gd name="adj" fmla="val 5926"/>
+            </a:avLst>
+          </a:prstGeom>
+          <a:solidFill>
+            <a:srgbClr val="FFFFFF"/>
+          </a:solidFill>
+          <a:ln w="12700">
+            <a:solidFill>
+              <a:srgbClr val="D9E2F5"/>
+            </a:solidFill>
+            <a:prstDash val="solid"/>
+          </a:ln>
+        </p:spPr>
+      </p:sp>
+      <p:sp>
+        <p:nvSpPr>
+          <p:cNvPr id="7" name="Text 5"/>
+          <p:cNvSpPr/>
+          <p:nvPr/>
+        </p:nvSpPr>
+        <p:spPr>
+          <a:xfrm>
+            <a:off x="749808" y="2020824"/>
+            <a:ext cx="5038344" cy="941832"/>
+          </a:xfrm>
+          <a:prstGeom prst="rect">
+            <a:avLst/>
+          </a:prstGeom>
+          <a:noFill/>
+          <a:ln/>
+        </p:spPr>
+        <p:txBody>
+          <a:bodyPr wrap="square" rtlCol="0" anchor="t"/>
+          <a:lstStyle/>
+          <a:p>
+            <a:pPr algn="l" indent="0" marL="0">
+              <a:spcAft>
+                <a:spcPts val="400"/>
+              </a:spcAft>
+              <a:buNone/>
+            </a:pPr>
+            <a:r>
+              <a:rPr lang="en-US" sz="1400" b="1" dirty="0">
+                <a:solidFill>
+                  <a:srgbClr val="1E2761"/>
+                </a:solidFill>
+                <a:latin typeface="Cambria" pitchFamily="34" charset="0"/>
+                <a:ea typeface="Cambria" pitchFamily="34" charset="-122"/>
+                <a:cs typeface="Cambria" pitchFamily="34" charset="-120"/>
+              </a:rPr>
+              <a:t>Inhibidores CYP3A4/CYP2D6</a:t>
+            </a:r>
+            <a:endParaRPr lang="en-US" sz="1400" dirty="0"/>
+          </a:p>
+          <a:p>
+            <a:pPr algn="l" indent="0" marL="0">
+              <a:buNone/>
+            </a:pPr>
+            <a:r>
+              <a:rPr lang="en-US" sz="1250" dirty="0">
+                <a:solidFill>
+                  <a:srgbClr val="1B2138"/>
+                </a:solidFill>
+                <a:latin typeface="Calibri" pitchFamily="34" charset="0"/>
+                <a:ea typeface="Calibri" pitchFamily="34" charset="-122"/>
+                <a:cs typeface="Calibri" pitchFamily="34" charset="-120"/>
+              </a:rPr>
+              <a:t>Reducir la dosis (a la mitad con inhibidores potentes).</a:t>
+            </a:r>
+            <a:endParaRPr lang="en-US" sz="1400" dirty="0"/>
+          </a:p>
+        </p:txBody>
+      </p:sp>
+      <p:sp>
+        <p:nvSpPr>
+          <p:cNvPr id="8" name="Shape 6"/>
+          <p:cNvSpPr/>
+          <p:nvPr/>
+        </p:nvSpPr>
+        <p:spPr>
+          <a:xfrm>
+            <a:off x="548640" y="3291840"/>
+            <a:ext cx="5440680" cy="1234440"/>
+          </a:xfrm>
+          <a:prstGeom prst="roundRect">
+            <a:avLst>
+              <a:gd name="adj" fmla="val 5926"/>
+            </a:avLst>
+          </a:prstGeom>
+          <a:solidFill>
+            <a:srgbClr val="FFFFFF"/>
+          </a:solidFill>
+          <a:ln w="12700">
+            <a:solidFill>
+              <a:srgbClr val="D9E2F5"/>
+            </a:solidFill>
+            <a:prstDash val="solid"/>
+          </a:ln>
+        </p:spPr>
+      </p:sp>
+      <p:sp>
+        <p:nvSpPr>
+          <p:cNvPr id="9" name="Text 7"/>
+          <p:cNvSpPr/>
+          <p:nvPr/>
+        </p:nvSpPr>
+        <p:spPr>
+          <a:xfrm>
+            <a:off x="749808" y="3438144"/>
+            <a:ext cx="5038344" cy="941832"/>
+          </a:xfrm>
+          <a:prstGeom prst="rect">
+            <a:avLst/>
+          </a:prstGeom>
+          <a:noFill/>
+          <a:ln/>
+        </p:spPr>
+        <p:txBody>
+          <a:bodyPr wrap="square" rtlCol="0" anchor="t"/>
+          <a:lstStyle/>
+          <a:p>
+            <a:pPr algn="l" indent="0" marL="0">
+              <a:spcAft>
+                <a:spcPts val="400"/>
+              </a:spcAft>
+              <a:buNone/>
+            </a:pPr>
+            <a:r>
+              <a:rPr lang="en-US" sz="1400" b="1" dirty="0">
+                <a:solidFill>
+                  <a:srgbClr val="1E2761"/>
+                </a:solidFill>
+                <a:latin typeface="Cambria" pitchFamily="34" charset="0"/>
+                <a:ea typeface="Cambria" pitchFamily="34" charset="-122"/>
+                <a:cs typeface="Cambria" pitchFamily="34" charset="-120"/>
+              </a:rPr>
+              <a:t>Inductores de CYP3A4</a:t>
+            </a:r>
+            <a:endParaRPr lang="en-US" sz="1400" dirty="0"/>
+          </a:p>
+          <a:p>
+            <a:pPr algn="l" indent="0" marL="0">
+              <a:buNone/>
+            </a:pPr>
+            <a:r>
+              <a:rPr lang="en-US" sz="1250" dirty="0">
+                <a:solidFill>
+                  <a:srgbClr val="1B2138"/>
+                </a:solidFill>
+                <a:latin typeface="Calibri" pitchFamily="34" charset="0"/>
+                <a:ea typeface="Calibri" pitchFamily="34" charset="-122"/>
+                <a:cs typeface="Calibri" pitchFamily="34" charset="-120"/>
+              </a:rPr>
+              <a:t>Aumentar la dosis (hasta duplicarla).</a:t>
+            </a:r>
+            <a:endParaRPr lang="en-US" sz="1400" dirty="0"/>
+          </a:p>
+        </p:txBody>
+      </p:sp>
+      <p:sp>
+        <p:nvSpPr>
+          <p:cNvPr id="10" name="Shape 8"/>
+          <p:cNvSpPr/>
+          <p:nvPr/>
+        </p:nvSpPr>
+        <p:spPr>
+          <a:xfrm>
+            <a:off x="548640" y="4709160"/>
+            <a:ext cx="5440680" cy="1234440"/>
+          </a:xfrm>
+          <a:prstGeom prst="roundRect">
+            <a:avLst>
+              <a:gd name="adj" fmla="val 5926"/>
+            </a:avLst>
+          </a:prstGeom>
+          <a:solidFill>
+            <a:srgbClr val="FFFFFF"/>
+          </a:solidFill>
+          <a:ln w="12700">
+            <a:solidFill>
+              <a:srgbClr val="D9E2F5"/>
+            </a:solidFill>
+            <a:prstDash val="solid"/>
+          </a:ln>
+        </p:spPr>
+      </p:sp>
+      <p:sp>
+        <p:nvSpPr>
+          <p:cNvPr id="11" name="Text 9"/>
+          <p:cNvSpPr/>
+          <p:nvPr/>
+        </p:nvSpPr>
+        <p:spPr>
+          <a:xfrm>
+            <a:off x="749808" y="4855464"/>
+            <a:ext cx="5038344" cy="941832"/>
+          </a:xfrm>
+          <a:prstGeom prst="rect">
+            <a:avLst/>
+          </a:prstGeom>
+          <a:noFill/>
+          <a:ln/>
+        </p:spPr>
+        <p:txBody>
+          <a:bodyPr wrap="square" rtlCol="0" anchor="t"/>
+          <a:lstStyle/>
+          <a:p>
+            <a:pPr algn="l" indent="0" marL="0">
+              <a:spcAft>
+                <a:spcPts val="400"/>
+              </a:spcAft>
+              <a:buNone/>
+            </a:pPr>
+            <a:r>
+              <a:rPr lang="en-US" sz="1400" b="1" dirty="0">
+                <a:solidFill>
+                  <a:srgbClr val="1E2761"/>
+                </a:solidFill>
+                <a:latin typeface="Cambria" pitchFamily="34" charset="0"/>
+                <a:ea typeface="Cambria" pitchFamily="34" charset="-122"/>
+                <a:cs typeface="Cambria" pitchFamily="34" charset="-120"/>
+              </a:rPr>
+              <a:t>Metabolizadores lentos CYP2D6</a:t>
+            </a:r>
+            <a:endParaRPr lang="en-US" sz="1400" dirty="0"/>
+          </a:p>
+          <a:p>
+            <a:pPr algn="l" indent="0" marL="0">
+              <a:buNone/>
+            </a:pPr>
+            <a:r>
+              <a:rPr lang="en-US" sz="1250" dirty="0">
+                <a:solidFill>
+                  <a:srgbClr val="1B2138"/>
+                </a:solidFill>
+                <a:latin typeface="Calibri" pitchFamily="34" charset="0"/>
+                <a:ea typeface="Calibri" pitchFamily="34" charset="-122"/>
+                <a:cs typeface="Calibri" pitchFamily="34" charset="-120"/>
+              </a:rPr>
+              <a:t>Reducir la dosis por mayor exposición.</a:t>
+            </a:r>
+            <a:endParaRPr lang="en-US" sz="1400" dirty="0"/>
+          </a:p>
+        </p:txBody>
+      </p:sp>
+      <p:sp>
+        <p:nvSpPr>
+          <p:cNvPr id="12" name="Text 10"/>
+          <p:cNvSpPr/>
+          <p:nvPr/>
+        </p:nvSpPr>
+        <p:spPr>
+          <a:xfrm>
+            <a:off x="6217920" y="1417320"/>
+            <a:ext cx="5486400" cy="365760"/>
+          </a:xfrm>
+          <a:prstGeom prst="rect">
+            <a:avLst/>
+          </a:prstGeom>
+          <a:noFill/>
+          <a:ln/>
+        </p:spPr>
+        <p:txBody>
+          <a:bodyPr wrap="square" rtlCol="0" anchor="ctr"/>
+          <a:lstStyle/>
+          <a:p>
+            <a:pPr indent="0" marL="0">
+              <a:buNone/>
+            </a:pPr>
+            <a:r>
+              <a:rPr lang="en-US" sz="1600" b="1" dirty="0">
+                <a:solidFill>
+                  <a:srgbClr val="3E5FC0"/>
+                </a:solidFill>
+                <a:latin typeface="Cambria" pitchFamily="34" charset="0"/>
+                <a:ea typeface="Cambria" pitchFamily="34" charset="-122"/>
+                <a:cs typeface="Cambria" pitchFamily="34" charset="-120"/>
+              </a:rPr>
+              <a:t>Poblaciones especiales</a:t>
+            </a:r>
+            <a:endParaRPr lang="en-US" sz="1600" dirty="0"/>
+          </a:p>
+        </p:txBody>
+      </p:sp>
+      <p:sp>
+        <p:nvSpPr>
+          <p:cNvPr id="13" name="Shape 11"/>
+          <p:cNvSpPr/>
+          <p:nvPr/>
+        </p:nvSpPr>
+        <p:spPr>
+          <a:xfrm>
+            <a:off x="6217920" y="1874520"/>
+            <a:ext cx="5440680" cy="1234440"/>
+          </a:xfrm>
+          <a:prstGeom prst="roundRect">
+            <a:avLst>
+              <a:gd name="adj" fmla="val 5926"/>
+            </a:avLst>
+          </a:prstGeom>
+          <a:solidFill>
+            <a:srgbClr val="FFFFFF"/>
+          </a:solidFill>
+          <a:ln w="12700">
+            <a:solidFill>
+              <a:srgbClr val="D9E2F5"/>
+            </a:solidFill>
+            <a:prstDash val="solid"/>
+          </a:ln>
+        </p:spPr>
+      </p:sp>
+      <p:sp>
+        <p:nvSpPr>
+          <p:cNvPr id="14" name="Text 12"/>
+          <p:cNvSpPr/>
+          <p:nvPr/>
+        </p:nvSpPr>
+        <p:spPr>
+          <a:xfrm>
+            <a:off x="6419088" y="2020824"/>
+            <a:ext cx="5038344" cy="941832"/>
+          </a:xfrm>
+          <a:prstGeom prst="rect">
+            <a:avLst/>
+          </a:prstGeom>
+          <a:noFill/>
+          <a:ln/>
+        </p:spPr>
+        <p:txBody>
+          <a:bodyPr wrap="square" rtlCol="0" anchor="t"/>
+          <a:lstStyle/>
+          <a:p>
+            <a:pPr algn="l" indent="0" marL="0">
+              <a:spcAft>
+                <a:spcPts val="400"/>
+              </a:spcAft>
+              <a:buNone/>
+            </a:pPr>
+            <a:r>
+              <a:rPr lang="en-US" sz="1400" b="1" dirty="0">
+                <a:solidFill>
+                  <a:srgbClr val="1E2761"/>
+                </a:solidFill>
+                <a:latin typeface="Cambria" pitchFamily="34" charset="0"/>
+                <a:ea typeface="Cambria" pitchFamily="34" charset="-122"/>
+                <a:cs typeface="Cambria" pitchFamily="34" charset="-120"/>
+              </a:rPr>
+              <a:t>Hepática/renal moderada-grave</a:t>
+            </a:r>
+            <a:endParaRPr lang="en-US" sz="1400" dirty="0"/>
+          </a:p>
+          <a:p>
+            <a:pPr algn="l" indent="0" marL="0">
+              <a:buNone/>
+            </a:pPr>
+            <a:r>
+              <a:rPr lang="en-US" sz="1250" dirty="0">
+                <a:solidFill>
+                  <a:srgbClr val="1B2138"/>
+                </a:solidFill>
+                <a:latin typeface="Calibri" pitchFamily="34" charset="0"/>
+                <a:ea typeface="Calibri" pitchFamily="34" charset="-122"/>
+                <a:cs typeface="Calibri" pitchFamily="34" charset="-120"/>
+              </a:rPr>
+              <a:t>Ajustar y reducir la dosis máxima.</a:t>
+            </a:r>
+            <a:endParaRPr lang="en-US" sz="1400" dirty="0"/>
+          </a:p>
+        </p:txBody>
+      </p:sp>
+      <p:sp>
+        <p:nvSpPr>
+          <p:cNvPr id="15" name="Shape 13"/>
+          <p:cNvSpPr/>
+          <p:nvPr/>
+        </p:nvSpPr>
+        <p:spPr>
+          <a:xfrm>
+            <a:off x="6217920" y="3291840"/>
+            <a:ext cx="5440680" cy="1234440"/>
+          </a:xfrm>
+          <a:prstGeom prst="roundRect">
+            <a:avLst>
+              <a:gd name="adj" fmla="val 5926"/>
+            </a:avLst>
+          </a:prstGeom>
+          <a:solidFill>
+            <a:srgbClr val="FFFFFF"/>
+          </a:solidFill>
+          <a:ln w="12700">
+            <a:solidFill>
+              <a:srgbClr val="D9E2F5"/>
+            </a:solidFill>
+            <a:prstDash val="solid"/>
+          </a:ln>
+        </p:spPr>
+      </p:sp>
+      <p:sp>
+        <p:nvSpPr>
+          <p:cNvPr id="16" name="Text 14"/>
+          <p:cNvSpPr/>
+          <p:nvPr/>
+        </p:nvSpPr>
+        <p:spPr>
+          <a:xfrm>
+            <a:off x="6419088" y="3438144"/>
+            <a:ext cx="5038344" cy="941832"/>
+          </a:xfrm>
+          <a:prstGeom prst="rect">
+            <a:avLst/>
+          </a:prstGeom>
+          <a:noFill/>
+          <a:ln/>
+        </p:spPr>
+        <p:txBody>
+          <a:bodyPr wrap="square" rtlCol="0" anchor="t"/>
+          <a:lstStyle/>
+          <a:p>
+            <a:pPr algn="l" indent="0" marL="0">
+              <a:spcAft>
+                <a:spcPts val="400"/>
+              </a:spcAft>
+              <a:buNone/>
+            </a:pPr>
+            <a:r>
+              <a:rPr lang="en-US" sz="1400" b="1" dirty="0">
+                <a:solidFill>
+                  <a:srgbClr val="1E2761"/>
+                </a:solidFill>
+                <a:latin typeface="Cambria" pitchFamily="34" charset="0"/>
+                <a:ea typeface="Cambria" pitchFamily="34" charset="-122"/>
+                <a:cs typeface="Cambria" pitchFamily="34" charset="-120"/>
+              </a:rPr>
+              <a:t>Embarazo y lactancia</a:t>
+            </a:r>
+            <a:endParaRPr lang="en-US" sz="1400" dirty="0"/>
+          </a:p>
+          <a:p>
+            <a:pPr algn="l" indent="0" marL="0">
+              <a:buNone/>
+            </a:pPr>
+            <a:r>
+              <a:rPr lang="en-US" sz="1250" dirty="0">
+                <a:solidFill>
+                  <a:srgbClr val="1B2138"/>
+                </a:solidFill>
+                <a:latin typeface="Calibri" pitchFamily="34" charset="0"/>
+                <a:ea typeface="Calibri" pitchFamily="34" charset="-122"/>
+                <a:cs typeface="Calibri" pitchFamily="34" charset="-120"/>
+              </a:rPr>
+              <a:t>Valorar riesgo-beneficio; datos limitados.</a:t>
+            </a:r>
+            <a:endParaRPr lang="en-US" sz="1400" dirty="0"/>
+          </a:p>
+        </p:txBody>
+      </p:sp>
+      <p:sp>
+        <p:nvSpPr>
+          <p:cNvPr id="17" name="Shape 15"/>
+          <p:cNvSpPr/>
+          <p:nvPr/>
+        </p:nvSpPr>
+        <p:spPr>
+          <a:xfrm>
+            <a:off x="6217920" y="4709160"/>
+            <a:ext cx="5440680" cy="1234440"/>
+          </a:xfrm>
+          <a:prstGeom prst="roundRect">
+            <a:avLst>
+              <a:gd name="adj" fmla="val 5926"/>
+            </a:avLst>
+          </a:prstGeom>
+          <a:solidFill>
+            <a:srgbClr val="FFFFFF"/>
+          </a:solidFill>
+          <a:ln w="12700">
+            <a:solidFill>
+              <a:srgbClr val="D9E2F5"/>
+            </a:solidFill>
+            <a:prstDash val="solid"/>
+          </a:ln>
+        </p:spPr>
+      </p:sp>
+      <p:sp>
+        <p:nvSpPr>
+          <p:cNvPr id="18" name="Text 16"/>
+          <p:cNvSpPr/>
+          <p:nvPr/>
+        </p:nvSpPr>
+        <p:spPr>
+          <a:xfrm>
+            <a:off x="6419088" y="4855464"/>
+            <a:ext cx="5038344" cy="941832"/>
+          </a:xfrm>
+          <a:prstGeom prst="rect">
+            <a:avLst/>
+          </a:prstGeom>
+          <a:noFill/>
+          <a:ln/>
+        </p:spPr>
+        <p:txBody>
+          <a:bodyPr wrap="square" rtlCol="0" anchor="t"/>
+          <a:lstStyle/>
+          <a:p>
+            <a:pPr algn="l" indent="0" marL="0">
+              <a:spcAft>
+                <a:spcPts val="400"/>
+              </a:spcAft>
+              <a:buNone/>
+            </a:pPr>
+            <a:r>
+              <a:rPr lang="en-US" sz="1400" b="1" dirty="0">
+                <a:solidFill>
+                  <a:srgbClr val="1E2761"/>
+                </a:solidFill>
+                <a:latin typeface="Cambria" pitchFamily="34" charset="0"/>
+                <a:ea typeface="Cambria" pitchFamily="34" charset="-122"/>
+                <a:cs typeface="Cambria" pitchFamily="34" charset="-120"/>
+              </a:rPr>
+              <a:t>Ancianos</a:t>
+            </a:r>
+            <a:endParaRPr lang="en-US" sz="1400" dirty="0"/>
+          </a:p>
+          <a:p>
+            <a:pPr algn="l" indent="0" marL="0">
+              <a:buNone/>
+            </a:pPr>
+            <a:r>
+              <a:rPr lang="en-US" sz="1250" dirty="0">
+                <a:solidFill>
+                  <a:srgbClr val="1B2138"/>
+                </a:solidFill>
+                <a:latin typeface="Calibri" pitchFamily="34" charset="0"/>
+                <a:ea typeface="Calibri" pitchFamily="34" charset="-122"/>
+                <a:cs typeface="Calibri" pitchFamily="34" charset="-120"/>
+              </a:rPr>
+              <a:t>Iniciar bajo y titular con precaución.</a:t>
+            </a:r>
+            <a:endParaRPr lang="en-US" sz="1400" dirty="0"/>
+          </a:p>
+        </p:txBody>
+      </p:sp>
+    </p:spTree>
+  </p:cSld>
+  <p:clrMapOvr>
+    <a:masterClrMapping/>
+  </p:clrMapOvr>
+</p:sld>
+</file>
+
+<file path=ppt/slides/slide21.xml><?xml version="1.0" encoding="utf-8"?>
+<p:sld xmlns:a="http://schemas.openxmlformats.org/drawingml/2006/main" xmlns:r="http://schemas.openxmlformats.org/officeDocument/2006/relationships" xmlns:p="http://schemas.openxmlformats.org/presentationml/2006/main">
+  <p:cSld name="Slide 21">
+    <p:bg>
+      <p:bgPr>
+        <a:solidFill>
           <a:srgbClr val="FFFFFF"/>
         </a:solidFill>
       </p:bgPr>
@@ -9818,7 +10280,7 @@
                 <a:ea typeface="Cambria" pitchFamily="34" charset="-122"/>
                 <a:cs typeface="Cambria" pitchFamily="34" charset="-120"/>
               </a:rPr>
-              <a:t>19</a:t>
+              <a:t>20</a:t>
             </a:r>
             <a:endParaRPr lang="en-US" sz="2000" dirty="0"/>
           </a:p>
@@ -10914,9 +11376,9 @@
 </p:sld>
 </file>
 
-<file path=ppt/slides/slide21.xml><?xml version="1.0" encoding="utf-8"?>
+<file path=ppt/slides/slide22.xml><?xml version="1.0" encoding="utf-8"?>
 <p:sld xmlns:a="http://schemas.openxmlformats.org/drawingml/2006/main" xmlns:r="http://schemas.openxmlformats.org/officeDocument/2006/relationships" xmlns:p="http://schemas.openxmlformats.org/presentationml/2006/main">
-  <p:cSld name="Slide 21">
+  <p:cSld name="Slide 22">
     <p:bg>
       <p:bgPr>
         <a:solidFill>
@@ -10991,7 +11453,7 @@
                 <a:ea typeface="Cambria" pitchFamily="34" charset="-122"/>
                 <a:cs typeface="Cambria" pitchFamily="34" charset="-120"/>
               </a:rPr>
-              <a:t>20</a:t>
+              <a:t>21</a:t>
             </a:r>
             <a:endParaRPr lang="en-US" sz="2000" dirty="0"/>
           </a:p>
@@ -11564,9 +12026,9 @@
 </p:sld>
 </file>
 
-<file path=ppt/slides/slide22.xml><?xml version="1.0" encoding="utf-8"?>
+<file path=ppt/slides/slide23.xml><?xml version="1.0" encoding="utf-8"?>
 <p:sld xmlns:a="http://schemas.openxmlformats.org/drawingml/2006/main" xmlns:r="http://schemas.openxmlformats.org/officeDocument/2006/relationships" xmlns:p="http://schemas.openxmlformats.org/presentationml/2006/main">
-  <p:cSld name="Slide 22">
+  <p:cSld name="Slide 23">
     <p:bg>
       <p:bgPr>
         <a:solidFill>
@@ -11807,9 +12269,9 @@
 </p:sld>
 </file>
 
-<file path=ppt/slides/slide23.xml><?xml version="1.0" encoding="utf-8"?>
+<file path=ppt/slides/slide24.xml><?xml version="1.0" encoding="utf-8"?>
 <p:sld xmlns:a="http://schemas.openxmlformats.org/drawingml/2006/main" xmlns:r="http://schemas.openxmlformats.org/officeDocument/2006/relationships" xmlns:p="http://schemas.openxmlformats.org/presentationml/2006/main">
-  <p:cSld name="Slide 23">
+  <p:cSld name="Slide 24">
     <p:bg>
       <p:bgPr>
         <a:solidFill>
@@ -11884,7 +12346,7 @@
                 <a:ea typeface="Cambria" pitchFamily="34" charset="-122"/>
                 <a:cs typeface="Cambria" pitchFamily="34" charset="-120"/>
               </a:rPr>
-              <a:t>21</a:t>
+              <a:t>22</a:t>
             </a:r>
             <a:endParaRPr lang="en-US" sz="2000" dirty="0"/>
           </a:p>
@@ -12181,9 +12643,9 @@
 </p:sld>
 </file>
 
-<file path=ppt/slides/slide24.xml><?xml version="1.0" encoding="utf-8"?>
+<file path=ppt/slides/slide25.xml><?xml version="1.0" encoding="utf-8"?>
 <p:sld xmlns:a="http://schemas.openxmlformats.org/drawingml/2006/main" xmlns:r="http://schemas.openxmlformats.org/officeDocument/2006/relationships" xmlns:p="http://schemas.openxmlformats.org/presentationml/2006/main">
-  <p:cSld name="Slide 24">
+  <p:cSld name="Slide 25">
     <p:bg>
       <p:bgPr>
         <a:solidFill>

</xml_diff>

<commit_message>
Swap two more new images into repeated slots
- Neural-network image on the conduct-disorder slide (frees cerebroNeu
  to appear only on the schizophrenia slide).
- Doctor-patient consultation image on the clinical-pearls slide (frees
  the lab image to appear only on the history slide).
Reduces duplicated images from six to four.

Co-Authored-By: Claude Opus 4.8 <noreply@anthropic.com>
Claude-Session: https://claude.ai/code/session_01AEe91STi5e9GfyhHPe5sca
</commit_message>
<xml_diff>
--- a/Brexpiprazol_Presentacion_Dra_Heydi_Trujillo.pptx
+++ b/Brexpiprazol_Presentacion_Dra_Heydi_Trujillo.pptx
@@ -6037,7 +6037,7 @@
       </p:sp>
       <p:pic>
         <p:nvPicPr>
-          <p:cNvPr id="5" name="Image 0" descr="/root/.claude/uploads/66fba22f-583e-557b-9ab9-bf088b6d1210/90f42778-1000206864.jpg">    </p:cNvPr>
+          <p:cNvPr id="5" name="Image 0" descr="/root/.claude/uploads/66fba22f-583e-557b-9ab9-bf088b6d1210/d425260d-1000207007.jpg">    </p:cNvPr>
           <p:cNvPicPr>
             <a:picLocks noChangeAspect="1"/>
           </p:cNvPicPr>
@@ -11500,7 +11500,7 @@
       </p:sp>
       <p:pic>
         <p:nvPicPr>
-          <p:cNvPr id="5" name="Image 0" descr="/root/.claude/uploads/66fba22f-583e-557b-9ab9-bf088b6d1210/3e754cf6-1000206756.jpg">    </p:cNvPr>
+          <p:cNvPr id="5" name="Image 0" descr="/root/.claude/uploads/66fba22f-583e-557b-9ab9-bf088b6d1210/ac2a47e1-1000207008.jpg">    </p:cNvPr>
           <p:cNvPicPr>
             <a:picLocks noChangeAspect="1"/>
           </p:cNvPicPr>

</xml_diff>